<commit_message>
Add experiment-coverage accounting (paper 45 tasks vs reproduction), updated report (540 lines) and PPT (20 slides); full-budget GPU results included
</commit_message>
<xml_diff>
--- a/ppt/FINO复现工作与结果分析.pptx
+++ b/ppt/FINO复现工作与结果分析.pptx
@@ -24,6 +24,7 @@
     <p:sldId id="272" r:id="rId24"/>
     <p:sldId id="273" r:id="rId25"/>
     <p:sldId id="274" r:id="rId26"/>
+    <p:sldId id="275" r:id="rId27"/>
   </p:sldIdLst>
   <p:sldSz cx="12191695" cy="6858000" type="screen4x3"/>
   <p:notesSz cx="6858000" cy="9144000"/>
@@ -1150,7 +1151,7 @@
           <a:lstStyle/>
           <a:p>
             <a:r>
-              <a:t>结论升级为"三层全部完成"：代码级、机制级、数值级（antmaze-large 全预算 100% vs 92%）。交付物包含全部数据与脚本；扩展任务正在运行。</a:t>
+              <a:t>覆盖度盘点：论文 45 个任务中，本复现完整完成 1 个任务的主对比（FINO+FQL），另有 2 个 OGBench 任务接近完成，D4RL 与消融未覆盖。这是诚实的完成度口径。</a:t>
             </a:r>
           </a:p>
         </p:txBody>
@@ -1220,7 +1221,7 @@
           <a:lstStyle/>
           <a:p>
             <a:r>
-              <a:t>结束：谢谢，欢迎提问。所有材料都在 GitHub 仓库和 docs 目录。</a:t>
+              <a:t>结论升级为"三层全部完成"：代码级、机制级、数值级（antmaze-large 全预算 100% vs 92%）。交付物包含全部数据与脚本；扩展任务正在运行。</a:t>
             </a:r>
           </a:p>
         </p:txBody>
@@ -1291,6 +1292,76 @@
           <a:p>
             <a:r>
               <a:t>目录：先讲总览，再讲背景与范围，然后准备、实验、结果分析，最后审计发现与交付。</a:t>
+            </a:r>
+          </a:p>
+        </p:txBody>
+      </p:sp>
+      <p:sp>
+        <p:nvSpPr>
+          <p:cNvPr id="4" name="Slide Number Placeholder 3"/>
+          <p:cNvSpPr>
+            <a:spLocks noGrp="1"/>
+          </p:cNvSpPr>
+          <p:nvPr>
+            <p:ph type="sldNum" idx="5" sz="quarter"/>
+          </p:nvPr>
+        </p:nvSpPr>
+        <p:spPr/>
+      </p:sp>
+    </p:spTree>
+  </p:cSld>
+  <p:clrMapOvr>
+    <a:masterClrMapping/>
+  </p:clrMapOvr>
+</p:notes>
+</file>
+
+<file path=ppt/notesSlides/notesSlide20.xml><?xml version="1.0" encoding="utf-8"?>
+<p:notes xmlns:a="http://schemas.openxmlformats.org/drawingml/2006/main" xmlns:p="http://schemas.openxmlformats.org/presentationml/2006/main" xmlns:r="http://schemas.openxmlformats.org/officeDocument/2006/relationships">
+  <p:cSld>
+    <p:spTree>
+      <p:nvGrpSpPr>
+        <p:cNvPr id="1" name=""/>
+        <p:cNvGrpSpPr/>
+        <p:nvPr/>
+      </p:nvGrpSpPr>
+      <p:grpSpPr>
+        <a:xfrm>
+          <a:off x="0" y="0"/>
+          <a:ext cx="0" cy="0"/>
+          <a:chOff x="0" y="0"/>
+          <a:chExt cx="0" cy="0"/>
+        </a:xfrm>
+      </p:grpSpPr>
+      <p:sp>
+        <p:nvSpPr>
+          <p:cNvPr id="2" name="Slide Image Placeholder 1"/>
+          <p:cNvSpPr>
+            <a:spLocks noGrp="1"/>
+          </p:cNvSpPr>
+          <p:nvPr>
+            <p:ph type="sldImg" idx="2"/>
+          </p:nvPr>
+        </p:nvSpPr>
+        <p:spPr/>
+      </p:sp>
+      <p:sp>
+        <p:nvSpPr>
+          <p:cNvPr id="3" name="Notes Placeholder 2"/>
+          <p:cNvSpPr>
+            <a:spLocks noGrp="1"/>
+          </p:cNvSpPr>
+          <p:nvPr>
+            <p:ph type="body" idx="3" sz="quarter"/>
+          </p:nvPr>
+        </p:nvSpPr>
+        <p:spPr/>
+        <p:txBody>
+          <a:bodyPr/>
+          <a:lstStyle/>
+          <a:p>
+            <a:r>
+              <a:t>结束：谢谢，欢迎提问。所有材料都在 GitHub 仓库和 docs 目录。</a:t>
             </a:r>
           </a:p>
         </p:txBody>
@@ -17300,7 +17371,7 @@
                 <a:ea typeface="Microsoft YaHei"/>
                 <a:cs typeface="Microsoft YaHei"/>
               </a:rPr>
-              <a:t>05 · 结论</a:t>
+              <a:t>05 · 覆盖度</a:t>
             </a:r>
           </a:p>
         </p:txBody>
@@ -17341,7 +17412,7 @@
                 <a:ea typeface="Microsoft YaHei"/>
                 <a:cs typeface="Microsoft YaHei"/>
               </a:rPr>
-              <a:t>结论：代码级、机制级、数值级复现全部完成</a:t>
+              <a:t>论文 45 个任务：本次复现完成了多少？</a:t>
             </a:r>
           </a:p>
         </p:txBody>
@@ -17484,397 +17555,7 @@
         <p:spPr>
           <a:xfrm>
             <a:off x="640080" y="1389888"/>
-            <a:ext cx="3484778" cy="1691640"/>
-          </a:xfrm>
-          <a:prstGeom prst="roundRect">
-            <a:avLst>
-              <a:gd name="adj" fmla="val 5000"/>
-            </a:avLst>
-          </a:prstGeom>
-          <a:solidFill>
-            <a:srgbClr val="E9F5EE"/>
-          </a:solidFill>
-          <a:ln w="9525">
-            <a:solidFill>
-              <a:srgbClr val="2E8B57"/>
-            </a:solidFill>
-          </a:ln>
-          <a:effectLst/>
-        </p:spPr>
-        <p:style>
-          <a:lnRef idx="1">
-            <a:schemeClr val="accent1"/>
-          </a:lnRef>
-          <a:fillRef idx="3">
-            <a:schemeClr val="accent1"/>
-          </a:fillRef>
-          <a:effectRef idx="2">
-            <a:schemeClr val="accent1"/>
-          </a:effectRef>
-          <a:fontRef idx="minor">
-            <a:schemeClr val="lt1"/>
-          </a:fontRef>
-        </p:style>
-        <p:txBody>
-          <a:bodyPr rtlCol="0" anchor="ctr"/>
-          <a:lstStyle/>
-          <a:p>
-            <a:pPr algn="ctr"/>
-          </a:p>
-        </p:txBody>
-      </p:sp>
-      <p:sp>
-        <p:nvSpPr>
-          <p:cNvPr id="9" name="TextBox 8"/>
-          <p:cNvSpPr txBox="1"/>
-          <p:nvPr/>
-        </p:nvSpPr>
-        <p:spPr>
-          <a:xfrm>
-            <a:off x="841247" y="1517904"/>
-            <a:ext cx="3119018" cy="292608"/>
-          </a:xfrm>
-          <a:prstGeom prst="rect">
-            <a:avLst/>
-          </a:prstGeom>
-          <a:noFill/>
-        </p:spPr>
-        <p:txBody>
-          <a:bodyPr wrap="square" lIns="0" rIns="0" tIns="0" bIns="0" anchor="t">
-            <a:spAutoFit/>
-          </a:bodyPr>
-          <a:lstStyle/>
-          <a:p>
-            <a:pPr algn="l">
-              <a:lnSpc>
-                <a:spcPct val="108000"/>
-              </a:lnSpc>
-            </a:pPr>
-            <a:r>
-              <a:rPr sz="1200" b="1" i="0">
-                <a:solidFill>
-                  <a:srgbClr val="2E8B57"/>
-                </a:solidFill>
-                <a:latin typeface="Microsoft YaHei"/>
-                <a:ea typeface="Microsoft YaHei"/>
-                <a:cs typeface="Microsoft YaHei"/>
-              </a:rPr>
-              <a:t>✅ 代码级复现</a:t>
-            </a:r>
-          </a:p>
-        </p:txBody>
-      </p:sp>
-      <p:sp>
-        <p:nvSpPr>
-          <p:cNvPr id="10" name="TextBox 9"/>
-          <p:cNvSpPr txBox="1"/>
-          <p:nvPr/>
-        </p:nvSpPr>
-        <p:spPr>
-          <a:xfrm>
-            <a:off x="841247" y="1883664"/>
-            <a:ext cx="3100730" cy="1097280"/>
-          </a:xfrm>
-          <a:prstGeom prst="rect">
-            <a:avLst/>
-          </a:prstGeom>
-          <a:noFill/>
-        </p:spPr>
-        <p:txBody>
-          <a:bodyPr wrap="square" lIns="0" rIns="0" tIns="0" bIns="0" anchor="t">
-            <a:spAutoFit/>
-          </a:bodyPr>
-          <a:lstStyle/>
-          <a:p>
-            <a:pPr algn="l">
-              <a:lnSpc>
-                <a:spcPct val="128000"/>
-              </a:lnSpc>
-            </a:pPr>
-            <a:r>
-              <a:rPr sz="919" b="0" i="0">
-                <a:solidFill>
-                  <a:srgbClr val="1B263B"/>
-                </a:solidFill>
-                <a:latin typeface="Microsoft YaHei"/>
-                <a:ea typeface="Microsoft YaHei"/>
-                <a:cs typeface="Microsoft YaHei"/>
-              </a:rPr>
-              <a:t>官方实现全链路可运行：训练、在线微调、评估、熵自适应 β、checkpoint；5 处平台补丁，算法零改动。</a:t>
-            </a:r>
-          </a:p>
-        </p:txBody>
-      </p:sp>
-      <p:sp>
-        <p:nvSpPr>
-          <p:cNvPr id="11" name="Rounded Rectangle 10"/>
-          <p:cNvSpPr/>
-          <p:nvPr/>
-        </p:nvSpPr>
-        <p:spPr>
-          <a:xfrm>
-            <a:off x="4353458" y="1389888"/>
-            <a:ext cx="3484778" cy="1691640"/>
-          </a:xfrm>
-          <a:prstGeom prst="roundRect">
-            <a:avLst>
-              <a:gd name="adj" fmla="val 5000"/>
-            </a:avLst>
-          </a:prstGeom>
-          <a:solidFill>
-            <a:srgbClr val="E9F5EE"/>
-          </a:solidFill>
-          <a:ln w="9525">
-            <a:solidFill>
-              <a:srgbClr val="2E8B57"/>
-            </a:solidFill>
-          </a:ln>
-          <a:effectLst/>
-        </p:spPr>
-        <p:style>
-          <a:lnRef idx="1">
-            <a:schemeClr val="accent1"/>
-          </a:lnRef>
-          <a:fillRef idx="3">
-            <a:schemeClr val="accent1"/>
-          </a:fillRef>
-          <a:effectRef idx="2">
-            <a:schemeClr val="accent1"/>
-          </a:effectRef>
-          <a:fontRef idx="minor">
-            <a:schemeClr val="lt1"/>
-          </a:fontRef>
-        </p:style>
-        <p:txBody>
-          <a:bodyPr rtlCol="0" anchor="ctr"/>
-          <a:lstStyle/>
-          <a:p>
-            <a:pPr algn="ctr"/>
-          </a:p>
-        </p:txBody>
-      </p:sp>
-      <p:sp>
-        <p:nvSpPr>
-          <p:cNvPr id="12" name="TextBox 11"/>
-          <p:cNvSpPr txBox="1"/>
-          <p:nvPr/>
-        </p:nvSpPr>
-        <p:spPr>
-          <a:xfrm>
-            <a:off x="4554626" y="1517904"/>
-            <a:ext cx="3119018" cy="292608"/>
-          </a:xfrm>
-          <a:prstGeom prst="rect">
-            <a:avLst/>
-          </a:prstGeom>
-          <a:noFill/>
-        </p:spPr>
-        <p:txBody>
-          <a:bodyPr wrap="square" lIns="0" rIns="0" tIns="0" bIns="0" anchor="t">
-            <a:spAutoFit/>
-          </a:bodyPr>
-          <a:lstStyle/>
-          <a:p>
-            <a:pPr algn="l">
-              <a:lnSpc>
-                <a:spcPct val="108000"/>
-              </a:lnSpc>
-            </a:pPr>
-            <a:r>
-              <a:rPr sz="1200" b="1" i="0">
-                <a:solidFill>
-                  <a:srgbClr val="2E8B57"/>
-                </a:solidFill>
-                <a:latin typeface="Microsoft YaHei"/>
-                <a:ea typeface="Microsoft YaHei"/>
-                <a:cs typeface="Microsoft YaHei"/>
-              </a:rPr>
-              <a:t>✅ 机制级复现</a:t>
-            </a:r>
-          </a:p>
-        </p:txBody>
-      </p:sp>
-      <p:sp>
-        <p:nvSpPr>
-          <p:cNvPr id="13" name="TextBox 12"/>
-          <p:cNvSpPr txBox="1"/>
-          <p:nvPr/>
-        </p:nvSpPr>
-        <p:spPr>
-          <a:xfrm>
-            <a:off x="4554626" y="1883664"/>
-            <a:ext cx="3100730" cy="1097280"/>
-          </a:xfrm>
-          <a:prstGeom prst="rect">
-            <a:avLst/>
-          </a:prstGeom>
-          <a:noFill/>
-        </p:spPr>
-        <p:txBody>
-          <a:bodyPr wrap="square" lIns="0" rIns="0" tIns="0" bIns="0" anchor="t">
-            <a:spAutoFit/>
-          </a:bodyPr>
-          <a:lstStyle/>
-          <a:p>
-            <a:pPr algn="l">
-              <a:lnSpc>
-                <a:spcPct val="128000"/>
-              </a:lnSpc>
-            </a:pPr>
-            <a:r>
-              <a:rPr sz="919" b="0" i="0">
-                <a:solidFill>
-                  <a:srgbClr val="1B263B"/>
-                </a:solidFill>
-                <a:latin typeface="Microsoft YaHei"/>
-                <a:ea typeface="Microsoft YaHei"/>
-                <a:cs typeface="Microsoft YaHei"/>
-              </a:rPr>
-              <a:t>2D 玩具定量验证三大机制：蒸馏 5.38× 且保真、Q-guided 在 d≥4 有效、噪声注入方向正确。</a:t>
-            </a:r>
-          </a:p>
-        </p:txBody>
-      </p:sp>
-      <p:sp>
-        <p:nvSpPr>
-          <p:cNvPr id="14" name="Rounded Rectangle 13"/>
-          <p:cNvSpPr/>
-          <p:nvPr/>
-        </p:nvSpPr>
-        <p:spPr>
-          <a:xfrm>
-            <a:off x="8066836" y="1389888"/>
-            <a:ext cx="3484778" cy="1691640"/>
-          </a:xfrm>
-          <a:prstGeom prst="roundRect">
-            <a:avLst>
-              <a:gd name="adj" fmla="val 5000"/>
-            </a:avLst>
-          </a:prstGeom>
-          <a:solidFill>
-            <a:srgbClr val="E9F5EE"/>
-          </a:solidFill>
-          <a:ln w="9525">
-            <a:solidFill>
-              <a:srgbClr val="2E8B57"/>
-            </a:solidFill>
-          </a:ln>
-          <a:effectLst/>
-        </p:spPr>
-        <p:style>
-          <a:lnRef idx="1">
-            <a:schemeClr val="accent1"/>
-          </a:lnRef>
-          <a:fillRef idx="3">
-            <a:schemeClr val="accent1"/>
-          </a:fillRef>
-          <a:effectRef idx="2">
-            <a:schemeClr val="accent1"/>
-          </a:effectRef>
-          <a:fontRef idx="minor">
-            <a:schemeClr val="lt1"/>
-          </a:fontRef>
-        </p:style>
-        <p:txBody>
-          <a:bodyPr rtlCol="0" anchor="ctr"/>
-          <a:lstStyle/>
-          <a:p>
-            <a:pPr algn="ctr"/>
-          </a:p>
-        </p:txBody>
-      </p:sp>
-      <p:sp>
-        <p:nvSpPr>
-          <p:cNvPr id="15" name="TextBox 14"/>
-          <p:cNvSpPr txBox="1"/>
-          <p:nvPr/>
-        </p:nvSpPr>
-        <p:spPr>
-          <a:xfrm>
-            <a:off x="8268004" y="1517904"/>
-            <a:ext cx="3119018" cy="292608"/>
-          </a:xfrm>
-          <a:prstGeom prst="rect">
-            <a:avLst/>
-          </a:prstGeom>
-          <a:noFill/>
-        </p:spPr>
-        <p:txBody>
-          <a:bodyPr wrap="square" lIns="0" rIns="0" tIns="0" bIns="0" anchor="t">
-            <a:spAutoFit/>
-          </a:bodyPr>
-          <a:lstStyle/>
-          <a:p>
-            <a:pPr algn="l">
-              <a:lnSpc>
-                <a:spcPct val="108000"/>
-              </a:lnSpc>
-            </a:pPr>
-            <a:r>
-              <a:rPr sz="1200" b="1" i="0">
-                <a:solidFill>
-                  <a:srgbClr val="2E8B57"/>
-                </a:solidFill>
-                <a:latin typeface="Microsoft YaHei"/>
-                <a:ea typeface="Microsoft YaHei"/>
-                <a:cs typeface="Microsoft YaHei"/>
-              </a:rPr>
-              <a:t>✅ 数值级复现</a:t>
-            </a:r>
-          </a:p>
-        </p:txBody>
-      </p:sp>
-      <p:sp>
-        <p:nvSpPr>
-          <p:cNvPr id="16" name="TextBox 15"/>
-          <p:cNvSpPr txBox="1"/>
-          <p:nvPr/>
-        </p:nvSpPr>
-        <p:spPr>
-          <a:xfrm>
-            <a:off x="8268004" y="1883664"/>
-            <a:ext cx="3100730" cy="1097280"/>
-          </a:xfrm>
-          <a:prstGeom prst="rect">
-            <a:avLst/>
-          </a:prstGeom>
-          <a:noFill/>
-        </p:spPr>
-        <p:txBody>
-          <a:bodyPr wrap="square" lIns="0" rIns="0" tIns="0" bIns="0" anchor="t">
-            <a:spAutoFit/>
-          </a:bodyPr>
-          <a:lstStyle/>
-          <a:p>
-            <a:pPr algn="l">
-              <a:lnSpc>
-                <a:spcPct val="128000"/>
-              </a:lnSpc>
-            </a:pPr>
-            <a:r>
-              <a:rPr sz="919" b="0" i="0">
-                <a:solidFill>
-                  <a:srgbClr val="1B263B"/>
-                </a:solidFill>
-                <a:latin typeface="Microsoft YaHei"/>
-                <a:ea typeface="Microsoft YaHei"/>
-                <a:cs typeface="Microsoft YaHei"/>
-              </a:rPr>
-              <a:t>antmaze-large 全预算：FINO 100% vs FQL 92%；单任务 2.3–2.5 h（GPU），方向与论文一致。</a:t>
-            </a:r>
-          </a:p>
-        </p:txBody>
-      </p:sp>
-      <p:sp>
-        <p:nvSpPr>
-          <p:cNvPr id="17" name="Rounded Rectangle 16"/>
-          <p:cNvSpPr/>
-          <p:nvPr/>
-        </p:nvSpPr>
-        <p:spPr>
-          <a:xfrm>
-            <a:off x="640080" y="3246120"/>
-            <a:ext cx="5349240" cy="2697480"/>
+            <a:ext cx="5029200" cy="3017520"/>
           </a:xfrm>
           <a:prstGeom prst="roundRect">
             <a:avLst>
@@ -17915,14 +17596,14 @@
       </p:sp>
       <p:sp>
         <p:nvSpPr>
-          <p:cNvPr id="18" name="TextBox 17"/>
+          <p:cNvPr id="9" name="TextBox 8"/>
           <p:cNvSpPr txBox="1"/>
           <p:nvPr/>
         </p:nvSpPr>
         <p:spPr>
           <a:xfrm>
-            <a:off x="868680" y="3364992"/>
-            <a:ext cx="4937760" cy="274320"/>
+            <a:off x="868680" y="1517904"/>
+            <a:ext cx="4572000" cy="274320"/>
           </a:xfrm>
           <a:prstGeom prst="rect">
             <a:avLst/>
@@ -17949,236 +17630,568 @@
                 <a:ea typeface="Microsoft YaHei"/>
                 <a:cs typeface="Microsoft YaHei"/>
               </a:rPr>
-              <a:t>交付物</a:t>
-            </a:r>
-          </a:p>
-        </p:txBody>
-      </p:sp>
-      <p:sp>
-        <p:nvSpPr>
-          <p:cNvPr id="19" name="TextBox 18"/>
-          <p:cNvSpPr txBox="1"/>
-          <p:nvPr/>
-        </p:nvSpPr>
-        <p:spPr>
-          <a:xfrm>
-            <a:off x="868680" y="3675887"/>
-            <a:ext cx="4937760" cy="2103120"/>
-          </a:xfrm>
-          <a:prstGeom prst="rect">
-            <a:avLst/>
-          </a:prstGeom>
-          <a:noFill/>
-        </p:spPr>
-        <p:txBody>
-          <a:bodyPr wrap="square" lIns="0" rIns="0" tIns="0" bIns="0">
-            <a:spAutoFit/>
-          </a:bodyPr>
-          <a:lstStyle/>
-          <a:p>
-            <a:pPr marL="182880" indent="-182880">
-              <a:lnSpc>
-                <a:spcPct val="112000"/>
-              </a:lnSpc>
-              <a:spcAft>
-                <a:spcPts val="300"/>
-              </a:spcAft>
-            </a:pPr>
-            <a:r>
-              <a:rPr sz="919" b="0" i="0">
-                <a:solidFill>
-                  <a:srgbClr val="C97F1C"/>
-                </a:solidFill>
-                <a:latin typeface="Microsoft YaHei"/>
-                <a:ea typeface="Microsoft YaHei"/>
-                <a:cs typeface="Microsoft YaHei"/>
-              </a:rPr>
-              <a:t>• </a:t>
-            </a:r>
-            <a:r>
-              <a:rPr sz="919" b="1" i="0">
-                <a:solidFill>
-                  <a:srgbClr val="1B263B"/>
-                </a:solidFill>
-                <a:latin typeface="Microsoft YaHei"/>
-                <a:ea typeface="Microsoft YaHei"/>
-                <a:cs typeface="Microsoft YaHei"/>
-              </a:rPr>
-              <a:t>GitHub：github.com/engulf408/FINO（99 文件 / 6.88 MB）</a:t>
-            </a:r>
-          </a:p>
-          <a:p>
-            <a:pPr marL="182880" indent="-182880">
-              <a:lnSpc>
-                <a:spcPct val="112000"/>
-              </a:lnSpc>
-              <a:spcAft>
-                <a:spcPts val="300"/>
-              </a:spcAft>
-            </a:pPr>
-            <a:r>
-              <a:rPr sz="919" b="0" i="0">
-                <a:solidFill>
-                  <a:srgbClr val="C97F1C"/>
-                </a:solidFill>
-                <a:latin typeface="Microsoft YaHei"/>
-                <a:ea typeface="Microsoft YaHei"/>
-                <a:cs typeface="Microsoft YaHei"/>
-              </a:rPr>
-              <a:t>• </a:t>
-            </a:r>
-            <a:r>
-              <a:rPr sz="919" b="0" i="0">
-                <a:solidFill>
-                  <a:srgbClr val="1B263B"/>
-                </a:solidFill>
-                <a:latin typeface="Microsoft YaHei"/>
-                <a:ea typeface="Microsoft YaHei"/>
-                <a:cs typeface="Microsoft YaHei"/>
-              </a:rPr>
-              <a:t>docs/02 复现报告（506 行）：CPU + GPU 全预算结果、偏差、复现路径</a:t>
-            </a:r>
-          </a:p>
-          <a:p>
-            <a:pPr marL="182880" indent="-182880">
-              <a:lnSpc>
-                <a:spcPct val="112000"/>
-              </a:lnSpc>
-              <a:spcAft>
-                <a:spcPts val="300"/>
-              </a:spcAft>
-            </a:pPr>
-            <a:r>
-              <a:rPr sz="919" b="0" i="0">
-                <a:solidFill>
-                  <a:srgbClr val="C97F1C"/>
-                </a:solidFill>
-                <a:latin typeface="Microsoft YaHei"/>
-                <a:ea typeface="Microsoft YaHei"/>
-                <a:cs typeface="Microsoft YaHei"/>
-              </a:rPr>
-              <a:t>• </a:t>
-            </a:r>
-            <a:r>
-              <a:rPr sz="919" b="0" i="0">
-                <a:solidFill>
-                  <a:srgbClr val="1B263B"/>
-                </a:solidFill>
-                <a:latin typeface="Microsoft YaHei"/>
-                <a:ea typeface="Microsoft YaHei"/>
-                <a:cs typeface="Microsoft YaHei"/>
-              </a:rPr>
-              <a:t>docs/01 源码分析（724 行）与 docs/patches.diff（5 处）</a:t>
-            </a:r>
-          </a:p>
-          <a:p>
-            <a:pPr marL="182880" indent="-182880">
-              <a:lnSpc>
-                <a:spcPct val="112000"/>
-              </a:lnSpc>
-              <a:spcAft>
-                <a:spcPts val="300"/>
-              </a:spcAft>
-            </a:pPr>
-            <a:r>
-              <a:rPr sz="919" b="0" i="0">
-                <a:solidFill>
-                  <a:srgbClr val="C97F1C"/>
-                </a:solidFill>
-                <a:latin typeface="Microsoft YaHei"/>
-                <a:ea typeface="Microsoft YaHei"/>
-                <a:cs typeface="Microsoft YaHei"/>
-              </a:rPr>
-              <a:t>• </a:t>
-            </a:r>
-            <a:r>
-              <a:rPr sz="919" b="0" i="0">
-                <a:solidFill>
-                  <a:srgbClr val="1B263B"/>
-                </a:solidFill>
-                <a:latin typeface="Microsoft YaHei"/>
-                <a:ea typeface="Microsoft YaHei"/>
-                <a:cs typeface="Microsoft YaHei"/>
-              </a:rPr>
-              <a:t>experiments/toy：4 组机制实验 + 8 张图 + RESULTS.md</a:t>
-            </a:r>
-          </a:p>
-          <a:p>
-            <a:pPr marL="182880" indent="-182880">
-              <a:lnSpc>
-                <a:spcPct val="112000"/>
-              </a:lnSpc>
-              <a:spcAft>
-                <a:spcPts val="300"/>
-              </a:spcAft>
-            </a:pPr>
-            <a:r>
-              <a:rPr sz="919" b="0" i="0">
-                <a:solidFill>
-                  <a:srgbClr val="C97F1C"/>
-                </a:solidFill>
-                <a:latin typeface="Microsoft YaHei"/>
-                <a:ea typeface="Microsoft YaHei"/>
-                <a:cs typeface="Microsoft YaHei"/>
-              </a:rPr>
-              <a:t>• </a:t>
-            </a:r>
-            <a:r>
-              <a:rPr sz="919" b="0" i="0">
-                <a:solidFill>
-                  <a:srgbClr val="1B263B"/>
-                </a:solidFill>
-                <a:latin typeface="Microsoft YaHei"/>
-                <a:ea typeface="Microsoft YaHei"/>
-                <a:cs typeface="Microsoft YaHei"/>
-              </a:rPr>
-              <a:t>gpu_exp/：全预算 FINO/FQL 的 CSV、flags、1M 步 checkpoint</a:t>
-            </a:r>
-          </a:p>
-          <a:p>
-            <a:pPr marL="182880" indent="-182880">
-              <a:lnSpc>
-                <a:spcPct val="112000"/>
-              </a:lnSpc>
-              <a:spcAft>
-                <a:spcPts val="300"/>
-              </a:spcAft>
-            </a:pPr>
-            <a:r>
-              <a:rPr sz="919" b="0" i="0">
-                <a:solidFill>
-                  <a:srgbClr val="C97F1C"/>
-                </a:solidFill>
-                <a:latin typeface="Microsoft YaHei"/>
-                <a:ea typeface="Microsoft YaHei"/>
-                <a:cs typeface="Microsoft YaHei"/>
-              </a:rPr>
-              <a:t>• </a:t>
-            </a:r>
-            <a:r>
-              <a:rPr sz="919" b="0" i="0">
-                <a:solidFill>
-                  <a:srgbClr val="1B263B"/>
-                </a:solidFill>
-                <a:latin typeface="Microsoft YaHei"/>
-                <a:ea typeface="Microsoft YaHei"/>
-                <a:cs typeface="Microsoft YaHei"/>
-              </a:rPr>
-              <a:t>results/：CPU/GPU 曲线、gpu_summary、checkpoint 分析</a:t>
-            </a:r>
-          </a:p>
-        </p:txBody>
-      </p:sp>
-      <p:sp>
-        <p:nvSpPr>
-          <p:cNvPr id="20" name="Rounded Rectangle 19"/>
+              <a:t>论文实验构成（README 45 条命令）</a:t>
+            </a:r>
+          </a:p>
+        </p:txBody>
+      </p:sp>
+      <p:graphicFrame>
+        <p:nvGraphicFramePr>
+          <p:cNvPr id="10" name="Table 9"/>
+          <p:cNvGraphicFramePr>
+            <a:graphicFrameLocks noGrp="1"/>
+          </p:cNvGraphicFramePr>
+          <p:nvPr/>
+        </p:nvGraphicFramePr>
+        <p:xfrm>
+          <a:off x="868680" y="1847088"/>
+          <a:ext cx="4572000" cy="1982418"/>
+        </p:xfrm>
+        <a:graphic>
+          <a:graphicData uri="http://schemas.openxmlformats.org/drawingml/2006/table">
+            <a:tbl>
+              <a:tblPr firstRow="1" bandRow="1">
+                <a:tableStyleId>{2D5ABB26-0587-4C30-8999-92F81FD0307C}</a:tableStyleId>
+              </a:tblPr>
+              <a:tblGrid>
+                <a:gridCol w="2103120"/>
+                <a:gridCol w="914400"/>
+                <a:gridCol w="1554480"/>
+              </a:tblGrid>
+              <a:tr h="329184">
+                <a:tc>
+                  <a:txBody>
+                    <a:bodyPr wrap="square"/>
+                    <a:lstStyle/>
+                    <a:p>
+                      <a:pPr algn="l">
+                        <a:lnSpc>
+                          <a:spcPct val="100000"/>
+                        </a:lnSpc>
+                      </a:pPr>
+                      <a:r>
+                        <a:rPr sz="880" b="1" i="0">
+                          <a:solidFill>
+                            <a:srgbClr val="FFFFFF"/>
+                          </a:solidFill>
+                          <a:latin typeface="Microsoft YaHei"/>
+                          <a:ea typeface="Microsoft YaHei"/>
+                          <a:cs typeface="Microsoft YaHei"/>
+                        </a:rPr>
+                        <a:t>类别</a:t>
+                      </a:r>
+                    </a:p>
+                  </a:txBody>
+                  <a:tcPr marL="73152" marR="54864" marT="27432" marB="27432" anchor="ctr">
+                    <a:lnB w="9525" cap="flat" cmpd="sng" algn="ctr">
+                      <a:solidFill>
+                        <a:srgbClr val="E2E7EE"/>
+                      </a:solidFill>
+                    </a:lnB>
+                    <a:solidFill>
+                      <a:srgbClr val="0F1B2D"/>
+                    </a:solidFill>
+                  </a:tcPr>
+                </a:tc>
+                <a:tc>
+                  <a:txBody>
+                    <a:bodyPr wrap="square"/>
+                    <a:lstStyle/>
+                    <a:p>
+                      <a:pPr algn="ctr">
+                        <a:lnSpc>
+                          <a:spcPct val="100000"/>
+                        </a:lnSpc>
+                      </a:pPr>
+                      <a:r>
+                        <a:rPr sz="880" b="1" i="0">
+                          <a:solidFill>
+                            <a:srgbClr val="FFFFFF"/>
+                          </a:solidFill>
+                          <a:latin typeface="Microsoft YaHei"/>
+                          <a:ea typeface="Microsoft YaHei"/>
+                          <a:cs typeface="Microsoft YaHei"/>
+                        </a:rPr>
+                        <a:t>数量</a:t>
+                      </a:r>
+                    </a:p>
+                  </a:txBody>
+                  <a:tcPr marL="73152" marR="54864" marT="27432" marB="27432" anchor="ctr">
+                    <a:lnB w="9525" cap="flat" cmpd="sng" algn="ctr">
+                      <a:solidFill>
+                        <a:srgbClr val="E2E7EE"/>
+                      </a:solidFill>
+                    </a:lnB>
+                    <a:solidFill>
+                      <a:srgbClr val="0F1B2D"/>
+                    </a:solidFill>
+                  </a:tcPr>
+                </a:tc>
+                <a:tc>
+                  <a:txBody>
+                    <a:bodyPr wrap="square"/>
+                    <a:lstStyle/>
+                    <a:p>
+                      <a:pPr algn="ctr">
+                        <a:lnSpc>
+                          <a:spcPct val="100000"/>
+                        </a:lnSpc>
+                      </a:pPr>
+                      <a:r>
+                        <a:rPr sz="880" b="1" i="0">
+                          <a:solidFill>
+                            <a:srgbClr val="FFFFFF"/>
+                          </a:solidFill>
+                          <a:latin typeface="Microsoft YaHei"/>
+                          <a:ea typeface="Microsoft YaHei"/>
+                          <a:cs typeface="Microsoft YaHei"/>
+                        </a:rPr>
+                        <a:t>说明</a:t>
+                      </a:r>
+                    </a:p>
+                  </a:txBody>
+                  <a:tcPr marL="73152" marR="54864" marT="27432" marB="27432" anchor="ctr">
+                    <a:lnB w="9525" cap="flat" cmpd="sng" algn="ctr">
+                      <a:solidFill>
+                        <a:srgbClr val="E2E7EE"/>
+                      </a:solidFill>
+                    </a:lnB>
+                    <a:solidFill>
+                      <a:srgbClr val="0F1B2D"/>
+                    </a:solidFill>
+                  </a:tcPr>
+                </a:tc>
+              </a:tr>
+              <a:tr h="384048">
+                <a:tc>
+                  <a:txBody>
+                    <a:bodyPr wrap="square"/>
+                    <a:lstStyle/>
+                    <a:p>
+                      <a:pPr algn="l">
+                        <a:lnSpc>
+                          <a:spcPct val="100000"/>
+                        </a:lnSpc>
+                      </a:pPr>
+                      <a:r>
+                        <a:rPr sz="880" b="1" i="0">
+                          <a:solidFill>
+                            <a:srgbClr val="0F1B2D"/>
+                          </a:solidFill>
+                          <a:latin typeface="Microsoft YaHei"/>
+                          <a:ea typeface="Microsoft YaHei"/>
+                          <a:cs typeface="Microsoft YaHei"/>
+                        </a:rPr>
+                        <a:t>OGBench 主任务</a:t>
+                      </a:r>
+                    </a:p>
+                  </a:txBody>
+                  <a:tcPr marL="73152" marR="54864" marT="27432" marB="27432" anchor="ctr">
+                    <a:lnB w="9525" cap="flat" cmpd="sng" algn="ctr">
+                      <a:solidFill>
+                        <a:srgbClr val="E2E7EE"/>
+                      </a:solidFill>
+                    </a:lnB>
+                    <a:solidFill>
+                      <a:srgbClr val="FFFFFF"/>
+                    </a:solidFill>
+                  </a:tcPr>
+                </a:tc>
+                <a:tc>
+                  <a:txBody>
+                    <a:bodyPr wrap="square"/>
+                    <a:lstStyle/>
+                    <a:p>
+                      <a:pPr algn="l">
+                        <a:lnSpc>
+                          <a:spcPct val="100000"/>
+                        </a:lnSpc>
+                      </a:pPr>
+                      <a:r>
+                        <a:rPr sz="880" b="0" i="0">
+                          <a:solidFill>
+                            <a:srgbClr val="1B263B"/>
+                          </a:solidFill>
+                          <a:latin typeface="Microsoft YaHei"/>
+                          <a:ea typeface="Microsoft YaHei"/>
+                          <a:cs typeface="Microsoft YaHei"/>
+                        </a:rPr>
+                        <a:t>35</a:t>
+                      </a:r>
+                    </a:p>
+                  </a:txBody>
+                  <a:tcPr marL="73152" marR="54864" marT="27432" marB="27432" anchor="ctr">
+                    <a:lnB w="9525" cap="flat" cmpd="sng" algn="ctr">
+                      <a:solidFill>
+                        <a:srgbClr val="E2E7EE"/>
+                      </a:solidFill>
+                    </a:lnB>
+                    <a:solidFill>
+                      <a:srgbClr val="FFFFFF"/>
+                    </a:solidFill>
+                  </a:tcPr>
+                </a:tc>
+                <a:tc>
+                  <a:txBody>
+                    <a:bodyPr wrap="square"/>
+                    <a:lstStyle/>
+                    <a:p>
+                      <a:pPr algn="l">
+                        <a:lnSpc>
+                          <a:spcPct val="100000"/>
+                        </a:lnSpc>
+                      </a:pPr>
+                      <a:r>
+                        <a:rPr sz="880" b="0" i="0">
+                          <a:solidFill>
+                            <a:srgbClr val="1B263B"/>
+                          </a:solidFill>
+                          <a:latin typeface="Microsoft YaHei"/>
+                          <a:ea typeface="Microsoft YaHei"/>
+                          <a:cs typeface="Microsoft YaHei"/>
+                        </a:rPr>
+                        <a:t>7 环境 × 5 task</a:t>
+                      </a:r>
+                    </a:p>
+                  </a:txBody>
+                  <a:tcPr marL="73152" marR="54864" marT="27432" marB="27432" anchor="ctr">
+                    <a:lnB w="9525" cap="flat" cmpd="sng" algn="ctr">
+                      <a:solidFill>
+                        <a:srgbClr val="E2E7EE"/>
+                      </a:solidFill>
+                    </a:lnB>
+                    <a:solidFill>
+                      <a:srgbClr val="FFFFFF"/>
+                    </a:solidFill>
+                  </a:tcPr>
+                </a:tc>
+              </a:tr>
+              <a:tr h="423062">
+                <a:tc>
+                  <a:txBody>
+                    <a:bodyPr wrap="square"/>
+                    <a:lstStyle/>
+                    <a:p>
+                      <a:pPr algn="l">
+                        <a:lnSpc>
+                          <a:spcPct val="100000"/>
+                        </a:lnSpc>
+                      </a:pPr>
+                      <a:r>
+                        <a:rPr sz="880" b="1" i="0">
+                          <a:solidFill>
+                            <a:srgbClr val="0F1B2D"/>
+                          </a:solidFill>
+                          <a:latin typeface="Microsoft YaHei"/>
+                          <a:ea typeface="Microsoft YaHei"/>
+                          <a:cs typeface="Microsoft YaHei"/>
+                        </a:rPr>
+                        <a:t>D4RL 任务</a:t>
+                      </a:r>
+                    </a:p>
+                  </a:txBody>
+                  <a:tcPr marL="73152" marR="54864" marT="27432" marB="27432" anchor="ctr">
+                    <a:lnB w="9525" cap="flat" cmpd="sng" algn="ctr">
+                      <a:solidFill>
+                        <a:srgbClr val="E2E7EE"/>
+                      </a:solidFill>
+                    </a:lnB>
+                    <a:solidFill>
+                      <a:srgbClr val="F5F7FB"/>
+                    </a:solidFill>
+                  </a:tcPr>
+                </a:tc>
+                <a:tc>
+                  <a:txBody>
+                    <a:bodyPr wrap="square"/>
+                    <a:lstStyle/>
+                    <a:p>
+                      <a:pPr algn="l">
+                        <a:lnSpc>
+                          <a:spcPct val="100000"/>
+                        </a:lnSpc>
+                      </a:pPr>
+                      <a:r>
+                        <a:rPr sz="880" b="0" i="0">
+                          <a:solidFill>
+                            <a:srgbClr val="1B263B"/>
+                          </a:solidFill>
+                          <a:latin typeface="Microsoft YaHei"/>
+                          <a:ea typeface="Microsoft YaHei"/>
+                          <a:cs typeface="Microsoft YaHei"/>
+                        </a:rPr>
+                        <a:t>10</a:t>
+                      </a:r>
+                    </a:p>
+                  </a:txBody>
+                  <a:tcPr marL="73152" marR="54864" marT="27432" marB="27432" anchor="ctr">
+                    <a:lnB w="9525" cap="flat" cmpd="sng" algn="ctr">
+                      <a:solidFill>
+                        <a:srgbClr val="E2E7EE"/>
+                      </a:solidFill>
+                    </a:lnB>
+                    <a:solidFill>
+                      <a:srgbClr val="F5F7FB"/>
+                    </a:solidFill>
+                  </a:tcPr>
+                </a:tc>
+                <a:tc>
+                  <a:txBody>
+                    <a:bodyPr wrap="square"/>
+                    <a:lstStyle/>
+                    <a:p>
+                      <a:pPr algn="l">
+                        <a:lnSpc>
+                          <a:spcPct val="100000"/>
+                        </a:lnSpc>
+                      </a:pPr>
+                      <a:r>
+                        <a:rPr sz="880" b="0" i="0">
+                          <a:solidFill>
+                            <a:srgbClr val="1B263B"/>
+                          </a:solidFill>
+                          <a:latin typeface="Microsoft YaHei"/>
+                          <a:ea typeface="Microsoft YaHei"/>
+                          <a:cs typeface="Microsoft YaHei"/>
+                        </a:rPr>
+                        <a:t>antmaze/adroit/locomotion</a:t>
+                      </a:r>
+                    </a:p>
+                  </a:txBody>
+                  <a:tcPr marL="73152" marR="54864" marT="27432" marB="27432" anchor="ctr">
+                    <a:lnB w="9525" cap="flat" cmpd="sng" algn="ctr">
+                      <a:solidFill>
+                        <a:srgbClr val="E2E7EE"/>
+                      </a:solidFill>
+                    </a:lnB>
+                    <a:solidFill>
+                      <a:srgbClr val="F5F7FB"/>
+                    </a:solidFill>
+                  </a:tcPr>
+                </a:tc>
+              </a:tr>
+              <a:tr h="423062">
+                <a:tc>
+                  <a:txBody>
+                    <a:bodyPr wrap="square"/>
+                    <a:lstStyle/>
+                    <a:p>
+                      <a:pPr algn="l">
+                        <a:lnSpc>
+                          <a:spcPct val="100000"/>
+                        </a:lnSpc>
+                      </a:pPr>
+                      <a:r>
+                        <a:rPr sz="880" b="1" i="0">
+                          <a:solidFill>
+                            <a:srgbClr val="0F1B2D"/>
+                          </a:solidFill>
+                          <a:latin typeface="Microsoft YaHei"/>
+                          <a:ea typeface="Microsoft YaHei"/>
+                          <a:cs typeface="Microsoft YaHei"/>
+                        </a:rPr>
+                        <a:t>baseline 对比</a:t>
+                      </a:r>
+                    </a:p>
+                  </a:txBody>
+                  <a:tcPr marL="73152" marR="54864" marT="27432" marB="27432" anchor="ctr">
+                    <a:lnB w="9525" cap="flat" cmpd="sng" algn="ctr">
+                      <a:solidFill>
+                        <a:srgbClr val="E2E7EE"/>
+                      </a:solidFill>
+                    </a:lnB>
+                    <a:solidFill>
+                      <a:srgbClr val="FFFFFF"/>
+                    </a:solidFill>
+                  </a:tcPr>
+                </a:tc>
+                <a:tc>
+                  <a:txBody>
+                    <a:bodyPr wrap="square"/>
+                    <a:lstStyle/>
+                    <a:p>
+                      <a:pPr algn="l">
+                        <a:lnSpc>
+                          <a:spcPct val="100000"/>
+                        </a:lnSpc>
+                      </a:pPr>
+                      <a:r>
+                        <a:rPr sz="880" b="0" i="0">
+                          <a:solidFill>
+                            <a:srgbClr val="1B263B"/>
+                          </a:solidFill>
+                          <a:latin typeface="Microsoft YaHei"/>
+                          <a:ea typeface="Microsoft YaHei"/>
+                          <a:cs typeface="Microsoft YaHei"/>
+                        </a:rPr>
+                        <a:t>多个</a:t>
+                      </a:r>
+                    </a:p>
+                  </a:txBody>
+                  <a:tcPr marL="73152" marR="54864" marT="27432" marB="27432" anchor="ctr">
+                    <a:lnB w="9525" cap="flat" cmpd="sng" algn="ctr">
+                      <a:solidFill>
+                        <a:srgbClr val="E2E7EE"/>
+                      </a:solidFill>
+                    </a:lnB>
+                    <a:solidFill>
+                      <a:srgbClr val="FFFFFF"/>
+                    </a:solidFill>
+                  </a:tcPr>
+                </a:tc>
+                <a:tc>
+                  <a:txBody>
+                    <a:bodyPr wrap="square"/>
+                    <a:lstStyle/>
+                    <a:p>
+                      <a:pPr algn="l">
+                        <a:lnSpc>
+                          <a:spcPct val="100000"/>
+                        </a:lnSpc>
+                      </a:pPr>
+                      <a:r>
+                        <a:rPr sz="880" b="0" i="0">
+                          <a:solidFill>
+                            <a:srgbClr val="1B263B"/>
+                          </a:solidFill>
+                          <a:latin typeface="Microsoft YaHei"/>
+                          <a:ea typeface="Microsoft YaHei"/>
+                          <a:cs typeface="Microsoft YaHei"/>
+                        </a:rPr>
+                        <a:t>FQL/IQL/IFQL/SAC/ReBRAC</a:t>
+                      </a:r>
+                    </a:p>
+                  </a:txBody>
+                  <a:tcPr marL="73152" marR="54864" marT="27432" marB="27432" anchor="ctr">
+                    <a:lnB w="9525" cap="flat" cmpd="sng" algn="ctr">
+                      <a:solidFill>
+                        <a:srgbClr val="E2E7EE"/>
+                      </a:solidFill>
+                    </a:lnB>
+                    <a:solidFill>
+                      <a:srgbClr val="FFFFFF"/>
+                    </a:solidFill>
+                  </a:tcPr>
+                </a:tc>
+              </a:tr>
+              <a:tr h="423062">
+                <a:tc>
+                  <a:txBody>
+                    <a:bodyPr wrap="square"/>
+                    <a:lstStyle/>
+                    <a:p>
+                      <a:pPr algn="l">
+                        <a:lnSpc>
+                          <a:spcPct val="100000"/>
+                        </a:lnSpc>
+                      </a:pPr>
+                      <a:r>
+                        <a:rPr sz="880" b="1" i="0">
+                          <a:solidFill>
+                            <a:srgbClr val="0F1B2D"/>
+                          </a:solidFill>
+                          <a:latin typeface="Microsoft YaHei"/>
+                          <a:ea typeface="Microsoft YaHei"/>
+                          <a:cs typeface="Microsoft YaHei"/>
+                        </a:rPr>
+                        <a:t>消融实验</a:t>
+                      </a:r>
+                    </a:p>
+                  </a:txBody>
+                  <a:tcPr marL="73152" marR="54864" marT="27432" marB="27432" anchor="ctr">
+                    <a:lnB w="9525" cap="flat" cmpd="sng" algn="ctr">
+                      <a:solidFill>
+                        <a:srgbClr val="E2E7EE"/>
+                      </a:solidFill>
+                    </a:lnB>
+                    <a:solidFill>
+                      <a:srgbClr val="F5F7FB"/>
+                    </a:solidFill>
+                  </a:tcPr>
+                </a:tc>
+                <a:tc>
+                  <a:txBody>
+                    <a:bodyPr wrap="square"/>
+                    <a:lstStyle/>
+                    <a:p>
+                      <a:pPr algn="l">
+                        <a:lnSpc>
+                          <a:spcPct val="100000"/>
+                        </a:lnSpc>
+                      </a:pPr>
+                      <a:r>
+                        <a:rPr sz="880" b="0" i="0">
+                          <a:solidFill>
+                            <a:srgbClr val="1B263B"/>
+                          </a:solidFill>
+                          <a:latin typeface="Microsoft YaHei"/>
+                          <a:ea typeface="Microsoft YaHei"/>
+                          <a:cs typeface="Microsoft YaHei"/>
+                        </a:rPr>
+                        <a:t>约 5 组</a:t>
+                      </a:r>
+                    </a:p>
+                  </a:txBody>
+                  <a:tcPr marL="73152" marR="54864" marT="27432" marB="27432" anchor="ctr">
+                    <a:lnB w="9525" cap="flat" cmpd="sng" algn="ctr">
+                      <a:solidFill>
+                        <a:srgbClr val="E2E7EE"/>
+                      </a:solidFill>
+                    </a:lnB>
+                    <a:solidFill>
+                      <a:srgbClr val="F5F7FB"/>
+                    </a:solidFill>
+                  </a:tcPr>
+                </a:tc>
+                <a:tc>
+                  <a:txBody>
+                    <a:bodyPr wrap="square"/>
+                    <a:lstStyle/>
+                    <a:p>
+                      <a:pPr algn="l">
+                        <a:lnSpc>
+                          <a:spcPct val="100000"/>
+                        </a:lnSpc>
+                      </a:pPr>
+                      <a:r>
+                        <a:rPr sz="880" b="0" i="0">
+                          <a:solidFill>
+                            <a:srgbClr val="1B263B"/>
+                          </a:solidFill>
+                          <a:latin typeface="Microsoft YaHei"/>
+                          <a:ea typeface="Microsoft YaHei"/>
+                          <a:cs typeface="Microsoft YaHei"/>
+                        </a:rPr>
+                        <a:t>噪声/Q-guided/β/flow steps/α</a:t>
+                      </a:r>
+                    </a:p>
+                  </a:txBody>
+                  <a:tcPr marL="73152" marR="54864" marT="27432" marB="27432" anchor="ctr">
+                    <a:lnB w="9525" cap="flat" cmpd="sng" algn="ctr">
+                      <a:solidFill>
+                        <a:srgbClr val="E2E7EE"/>
+                      </a:solidFill>
+                    </a:lnB>
+                    <a:solidFill>
+                      <a:srgbClr val="F5F7FB"/>
+                    </a:solidFill>
+                  </a:tcPr>
+                </a:tc>
+              </a:tr>
+            </a:tbl>
+          </a:graphicData>
+        </a:graphic>
+      </p:graphicFrame>
+      <p:sp>
+        <p:nvSpPr>
+          <p:cNvPr id="11" name="Rounded Rectangle 10"/>
           <p:cNvSpPr/>
           <p:nvPr/>
         </p:nvSpPr>
         <p:spPr>
           <a:xfrm>
-            <a:off x="6199632" y="3246120"/>
-            <a:ext cx="5349240" cy="2697480"/>
+            <a:off x="5897880" y="1389888"/>
+            <a:ext cx="5650992" cy="3017520"/>
           </a:xfrm>
           <a:prstGeom prst="roundRect">
             <a:avLst>
@@ -18186,7 +18199,7 @@
             </a:avLst>
           </a:prstGeom>
           <a:solidFill>
-            <a:srgbClr val="ECF1F8"/>
+            <a:srgbClr val="F5F7FB"/>
           </a:solidFill>
           <a:ln w="9525">
             <a:solidFill>
@@ -18219,14 +18232,14 @@
       </p:sp>
       <p:sp>
         <p:nvSpPr>
-          <p:cNvPr id="21" name="TextBox 20"/>
+          <p:cNvPr id="12" name="TextBox 11"/>
           <p:cNvSpPr txBox="1"/>
           <p:nvPr/>
         </p:nvSpPr>
         <p:spPr>
           <a:xfrm>
-            <a:off x="6428232" y="3364992"/>
-            <a:ext cx="4937760" cy="274320"/>
+            <a:off x="6126480" y="1517904"/>
+            <a:ext cx="5212080" cy="274320"/>
           </a:xfrm>
           <a:prstGeom prst="rect">
             <a:avLst/>
@@ -18253,21 +18266,761 @@
                 <a:ea typeface="Microsoft YaHei"/>
                 <a:cs typeface="Microsoft YaHei"/>
               </a:rPr>
-              <a:t>如何复刻（本机已走通）</a:t>
-            </a:r>
-          </a:p>
-        </p:txBody>
-      </p:sp>
-      <p:sp>
-        <p:nvSpPr>
-          <p:cNvPr id="22" name="TextBox 21"/>
+              <a:t>本复现实际覆盖（截至 10-21 18:20）</a:t>
+            </a:r>
+          </a:p>
+        </p:txBody>
+      </p:sp>
+      <p:graphicFrame>
+        <p:nvGraphicFramePr>
+          <p:cNvPr id="13" name="Table 12"/>
+          <p:cNvGraphicFramePr>
+            <a:graphicFrameLocks noGrp="1"/>
+          </p:cNvGraphicFramePr>
+          <p:nvPr/>
+        </p:nvGraphicFramePr>
+        <p:xfrm>
+          <a:off x="6126480" y="1847088"/>
+          <a:ext cx="5212079" cy="2314040"/>
+        </p:xfrm>
+        <a:graphic>
+          <a:graphicData uri="http://schemas.openxmlformats.org/drawingml/2006/table">
+            <a:tbl>
+              <a:tblPr firstRow="1" bandRow="1">
+                <a:tableStyleId>{2D5ABB26-0587-4C30-8999-92F81FD0307C}</a:tableStyleId>
+              </a:tblPr>
+              <a:tblGrid>
+                <a:gridCol w="2293315"/>
+                <a:gridCol w="938174"/>
+                <a:gridCol w="1980590"/>
+              </a:tblGrid>
+              <a:tr h="329184">
+                <a:tc>
+                  <a:txBody>
+                    <a:bodyPr wrap="square"/>
+                    <a:lstStyle/>
+                    <a:p>
+                      <a:pPr algn="l">
+                        <a:lnSpc>
+                          <a:spcPct val="100000"/>
+                        </a:lnSpc>
+                      </a:pPr>
+                      <a:r>
+                        <a:rPr sz="860" b="1" i="0">
+                          <a:solidFill>
+                            <a:srgbClr val="FFFFFF"/>
+                          </a:solidFill>
+                          <a:latin typeface="Microsoft YaHei"/>
+                          <a:ea typeface="Microsoft YaHei"/>
+                          <a:cs typeface="Microsoft YaHei"/>
+                        </a:rPr>
+                        <a:t>类别</a:t>
+                      </a:r>
+                    </a:p>
+                  </a:txBody>
+                  <a:tcPr marL="73152" marR="54864" marT="27432" marB="27432" anchor="ctr">
+                    <a:lnB w="9525" cap="flat" cmpd="sng" algn="ctr">
+                      <a:solidFill>
+                        <a:srgbClr val="E2E7EE"/>
+                      </a:solidFill>
+                    </a:lnB>
+                    <a:solidFill>
+                      <a:srgbClr val="0F1B2D"/>
+                    </a:solidFill>
+                  </a:tcPr>
+                </a:tc>
+                <a:tc>
+                  <a:txBody>
+                    <a:bodyPr wrap="square"/>
+                    <a:lstStyle/>
+                    <a:p>
+                      <a:pPr algn="ctr">
+                        <a:lnSpc>
+                          <a:spcPct val="100000"/>
+                        </a:lnSpc>
+                      </a:pPr>
+                      <a:r>
+                        <a:rPr sz="860" b="1" i="0">
+                          <a:solidFill>
+                            <a:srgbClr val="FFFFFF"/>
+                          </a:solidFill>
+                          <a:latin typeface="Microsoft YaHei"/>
+                          <a:ea typeface="Microsoft YaHei"/>
+                          <a:cs typeface="Microsoft YaHei"/>
+                        </a:rPr>
+                        <a:t>完成</a:t>
+                      </a:r>
+                    </a:p>
+                  </a:txBody>
+                  <a:tcPr marL="73152" marR="54864" marT="27432" marB="27432" anchor="ctr">
+                    <a:lnB w="9525" cap="flat" cmpd="sng" algn="ctr">
+                      <a:solidFill>
+                        <a:srgbClr val="E2E7EE"/>
+                      </a:solidFill>
+                    </a:lnB>
+                    <a:solidFill>
+                      <a:srgbClr val="0F1B2D"/>
+                    </a:solidFill>
+                  </a:tcPr>
+                </a:tc>
+                <a:tc>
+                  <a:txBody>
+                    <a:bodyPr wrap="square"/>
+                    <a:lstStyle/>
+                    <a:p>
+                      <a:pPr algn="ctr">
+                        <a:lnSpc>
+                          <a:spcPct val="100000"/>
+                        </a:lnSpc>
+                      </a:pPr>
+                      <a:r>
+                        <a:rPr sz="860" b="1" i="0">
+                          <a:solidFill>
+                            <a:srgbClr val="FFFFFF"/>
+                          </a:solidFill>
+                          <a:latin typeface="Microsoft YaHei"/>
+                          <a:ea typeface="Microsoft YaHei"/>
+                          <a:cs typeface="Microsoft YaHei"/>
+                        </a:rPr>
+                        <a:t>覆盖率 / 备注</a:t>
+                      </a:r>
+                    </a:p>
+                  </a:txBody>
+                  <a:tcPr marL="73152" marR="54864" marT="27432" marB="27432" anchor="ctr">
+                    <a:lnB w="9525" cap="flat" cmpd="sng" algn="ctr">
+                      <a:solidFill>
+                        <a:srgbClr val="E2E7EE"/>
+                      </a:solidFill>
+                    </a:lnB>
+                    <a:solidFill>
+                      <a:srgbClr val="0F1B2D"/>
+                    </a:solidFill>
+                  </a:tcPr>
+                </a:tc>
+              </a:tr>
+              <a:tr h="416356">
+                <a:tc>
+                  <a:txBody>
+                    <a:bodyPr wrap="square"/>
+                    <a:lstStyle/>
+                    <a:p>
+                      <a:pPr algn="l">
+                        <a:lnSpc>
+                          <a:spcPct val="100000"/>
+                        </a:lnSpc>
+                      </a:pPr>
+                      <a:r>
+                        <a:rPr sz="860" b="1" i="0">
+                          <a:solidFill>
+                            <a:srgbClr val="0F1B2D"/>
+                          </a:solidFill>
+                          <a:latin typeface="Microsoft YaHei"/>
+                          <a:ea typeface="Microsoft YaHei"/>
+                          <a:cs typeface="Microsoft YaHei"/>
+                        </a:rPr>
+                        <a:t>OGBench FINO（全预算）</a:t>
+                      </a:r>
+                    </a:p>
+                  </a:txBody>
+                  <a:tcPr marL="73152" marR="54864" marT="27432" marB="27432" anchor="ctr">
+                    <a:lnB w="9525" cap="flat" cmpd="sng" algn="ctr">
+                      <a:solidFill>
+                        <a:srgbClr val="E2E7EE"/>
+                      </a:solidFill>
+                    </a:lnB>
+                    <a:solidFill>
+                      <a:srgbClr val="FFFFFF"/>
+                    </a:solidFill>
+                  </a:tcPr>
+                </a:tc>
+                <a:tc>
+                  <a:txBody>
+                    <a:bodyPr wrap="square"/>
+                    <a:lstStyle/>
+                    <a:p>
+                      <a:pPr algn="l">
+                        <a:lnSpc>
+                          <a:spcPct val="100000"/>
+                        </a:lnSpc>
+                      </a:pPr>
+                      <a:r>
+                        <a:rPr sz="860" b="0" i="0">
+                          <a:solidFill>
+                            <a:srgbClr val="1B263B"/>
+                          </a:solidFill>
+                          <a:latin typeface="Microsoft YaHei"/>
+                          <a:ea typeface="Microsoft YaHei"/>
+                          <a:cs typeface="Microsoft YaHei"/>
+                        </a:rPr>
+                        <a:t>1 + 2 进行中</a:t>
+                      </a:r>
+                    </a:p>
+                  </a:txBody>
+                  <a:tcPr marL="73152" marR="54864" marT="27432" marB="27432" anchor="ctr">
+                    <a:lnB w="9525" cap="flat" cmpd="sng" algn="ctr">
+                      <a:solidFill>
+                        <a:srgbClr val="E2E7EE"/>
+                      </a:solidFill>
+                    </a:lnB>
+                    <a:solidFill>
+                      <a:srgbClr val="FFFFFF"/>
+                    </a:solidFill>
+                  </a:tcPr>
+                </a:tc>
+                <a:tc>
+                  <a:txBody>
+                    <a:bodyPr wrap="square"/>
+                    <a:lstStyle/>
+                    <a:p>
+                      <a:pPr algn="l">
+                        <a:lnSpc>
+                          <a:spcPct val="100000"/>
+                        </a:lnSpc>
+                      </a:pPr>
+                      <a:r>
+                        <a:rPr sz="860" b="0" i="0">
+                          <a:solidFill>
+                            <a:srgbClr val="1B263B"/>
+                          </a:solidFill>
+                          <a:latin typeface="Microsoft YaHei"/>
+                          <a:ea typeface="Microsoft YaHei"/>
+                          <a:cs typeface="Microsoft YaHei"/>
+                        </a:rPr>
+                        <a:t>1/35；含进行中 ≈ 8.6%</a:t>
+                      </a:r>
+                    </a:p>
+                  </a:txBody>
+                  <a:tcPr marL="73152" marR="54864" marT="27432" marB="27432" anchor="ctr">
+                    <a:lnB w="9525" cap="flat" cmpd="sng" algn="ctr">
+                      <a:solidFill>
+                        <a:srgbClr val="E2E7EE"/>
+                      </a:solidFill>
+                    </a:lnB>
+                    <a:solidFill>
+                      <a:srgbClr val="FFFFFF"/>
+                    </a:solidFill>
+                  </a:tcPr>
+                </a:tc>
+              </a:tr>
+              <a:tr h="416356">
+                <a:tc>
+                  <a:txBody>
+                    <a:bodyPr wrap="square"/>
+                    <a:lstStyle/>
+                    <a:p>
+                      <a:pPr algn="l">
+                        <a:lnSpc>
+                          <a:spcPct val="100000"/>
+                        </a:lnSpc>
+                      </a:pPr>
+                      <a:r>
+                        <a:rPr sz="860" b="1" i="0">
+                          <a:solidFill>
+                            <a:srgbClr val="0F1B2D"/>
+                          </a:solidFill>
+                          <a:latin typeface="Microsoft YaHei"/>
+                          <a:ea typeface="Microsoft YaHei"/>
+                          <a:cs typeface="Microsoft YaHei"/>
+                        </a:rPr>
+                        <a:t>OGBench FQL（全预算）</a:t>
+                      </a:r>
+                    </a:p>
+                  </a:txBody>
+                  <a:tcPr marL="73152" marR="54864" marT="27432" marB="27432" anchor="ctr">
+                    <a:lnB w="9525" cap="flat" cmpd="sng" algn="ctr">
+                      <a:solidFill>
+                        <a:srgbClr val="E2E7EE"/>
+                      </a:solidFill>
+                    </a:lnB>
+                    <a:solidFill>
+                      <a:srgbClr val="F5F7FB"/>
+                    </a:solidFill>
+                  </a:tcPr>
+                </a:tc>
+                <a:tc>
+                  <a:txBody>
+                    <a:bodyPr wrap="square"/>
+                    <a:lstStyle/>
+                    <a:p>
+                      <a:pPr algn="l">
+                        <a:lnSpc>
+                          <a:spcPct val="100000"/>
+                        </a:lnSpc>
+                      </a:pPr>
+                      <a:r>
+                        <a:rPr sz="860" b="0" i="0">
+                          <a:solidFill>
+                            <a:srgbClr val="1B263B"/>
+                          </a:solidFill>
+                          <a:latin typeface="Microsoft YaHei"/>
+                          <a:ea typeface="Microsoft YaHei"/>
+                          <a:cs typeface="Microsoft YaHei"/>
+                        </a:rPr>
+                        <a:t>1</a:t>
+                      </a:r>
+                    </a:p>
+                  </a:txBody>
+                  <a:tcPr marL="73152" marR="54864" marT="27432" marB="27432" anchor="ctr">
+                    <a:lnB w="9525" cap="flat" cmpd="sng" algn="ctr">
+                      <a:solidFill>
+                        <a:srgbClr val="E2E7EE"/>
+                      </a:solidFill>
+                    </a:lnB>
+                    <a:solidFill>
+                      <a:srgbClr val="F5F7FB"/>
+                    </a:solidFill>
+                  </a:tcPr>
+                </a:tc>
+                <a:tc>
+                  <a:txBody>
+                    <a:bodyPr wrap="square"/>
+                    <a:lstStyle/>
+                    <a:p>
+                      <a:pPr algn="l">
+                        <a:lnSpc>
+                          <a:spcPct val="100000"/>
+                        </a:lnSpc>
+                      </a:pPr>
+                      <a:r>
+                        <a:rPr sz="860" b="0" i="0">
+                          <a:solidFill>
+                            <a:srgbClr val="1B263B"/>
+                          </a:solidFill>
+                          <a:latin typeface="Microsoft YaHei"/>
+                          <a:ea typeface="Microsoft YaHei"/>
+                          <a:cs typeface="Microsoft YaHei"/>
+                        </a:rPr>
+                        <a:t>1/35 ≈ 2.9%（antmaze-large）</a:t>
+                      </a:r>
+                    </a:p>
+                  </a:txBody>
+                  <a:tcPr marL="73152" marR="54864" marT="27432" marB="27432" anchor="ctr">
+                    <a:lnB w="9525" cap="flat" cmpd="sng" algn="ctr">
+                      <a:solidFill>
+                        <a:srgbClr val="E2E7EE"/>
+                      </a:solidFill>
+                    </a:lnB>
+                    <a:solidFill>
+                      <a:srgbClr val="F5F7FB"/>
+                    </a:solidFill>
+                  </a:tcPr>
+                </a:tc>
+              </a:tr>
+              <a:tr h="384048">
+                <a:tc>
+                  <a:txBody>
+                    <a:bodyPr wrap="square"/>
+                    <a:lstStyle/>
+                    <a:p>
+                      <a:pPr algn="l">
+                        <a:lnSpc>
+                          <a:spcPct val="100000"/>
+                        </a:lnSpc>
+                      </a:pPr>
+                      <a:r>
+                        <a:rPr sz="860" b="1" i="0">
+                          <a:solidFill>
+                            <a:srgbClr val="0F1B2D"/>
+                          </a:solidFill>
+                          <a:latin typeface="Microsoft YaHei"/>
+                          <a:ea typeface="Microsoft YaHei"/>
+                          <a:cs typeface="Microsoft YaHei"/>
+                        </a:rPr>
+                        <a:t>D4RL</a:t>
+                      </a:r>
+                    </a:p>
+                  </a:txBody>
+                  <a:tcPr marL="73152" marR="54864" marT="27432" marB="27432" anchor="ctr">
+                    <a:lnB w="9525" cap="flat" cmpd="sng" algn="ctr">
+                      <a:solidFill>
+                        <a:srgbClr val="E2E7EE"/>
+                      </a:solidFill>
+                    </a:lnB>
+                    <a:solidFill>
+                      <a:srgbClr val="FFFFFF"/>
+                    </a:solidFill>
+                  </a:tcPr>
+                </a:tc>
+                <a:tc>
+                  <a:txBody>
+                    <a:bodyPr wrap="square"/>
+                    <a:lstStyle/>
+                    <a:p>
+                      <a:pPr algn="l">
+                        <a:lnSpc>
+                          <a:spcPct val="100000"/>
+                        </a:lnSpc>
+                      </a:pPr>
+                      <a:r>
+                        <a:rPr sz="860" b="0" i="0">
+                          <a:solidFill>
+                            <a:srgbClr val="1B263B"/>
+                          </a:solidFill>
+                          <a:latin typeface="Microsoft YaHei"/>
+                          <a:ea typeface="Microsoft YaHei"/>
+                          <a:cs typeface="Microsoft YaHei"/>
+                        </a:rPr>
+                        <a:t>0</a:t>
+                      </a:r>
+                    </a:p>
+                  </a:txBody>
+                  <a:tcPr marL="73152" marR="54864" marT="27432" marB="27432" anchor="ctr">
+                    <a:lnB w="9525" cap="flat" cmpd="sng" algn="ctr">
+                      <a:solidFill>
+                        <a:srgbClr val="E2E7EE"/>
+                      </a:solidFill>
+                    </a:lnB>
+                    <a:solidFill>
+                      <a:srgbClr val="FFFFFF"/>
+                    </a:solidFill>
+                  </a:tcPr>
+                </a:tc>
+                <a:tc>
+                  <a:txBody>
+                    <a:bodyPr wrap="square"/>
+                    <a:lstStyle/>
+                    <a:p>
+                      <a:pPr algn="l">
+                        <a:lnSpc>
+                          <a:spcPct val="100000"/>
+                        </a:lnSpc>
+                      </a:pPr>
+                      <a:r>
+                        <a:rPr sz="860" b="0" i="0">
+                          <a:solidFill>
+                            <a:srgbClr val="1B263B"/>
+                          </a:solidFill>
+                          <a:latin typeface="Microsoft YaHei"/>
+                          <a:ea typeface="Microsoft YaHei"/>
+                          <a:cs typeface="Microsoft YaHei"/>
+                        </a:rPr>
+                        <a:t>0%（mujoco-py 未覆盖）</a:t>
+                      </a:r>
+                    </a:p>
+                  </a:txBody>
+                  <a:tcPr marL="73152" marR="54864" marT="27432" marB="27432" anchor="ctr">
+                    <a:lnB w="9525" cap="flat" cmpd="sng" algn="ctr">
+                      <a:solidFill>
+                        <a:srgbClr val="E2E7EE"/>
+                      </a:solidFill>
+                    </a:lnB>
+                    <a:solidFill>
+                      <a:srgbClr val="FFFFFF"/>
+                    </a:solidFill>
+                  </a:tcPr>
+                </a:tc>
+              </a:tr>
+              <a:tr h="384048">
+                <a:tc>
+                  <a:txBody>
+                    <a:bodyPr wrap="square"/>
+                    <a:lstStyle/>
+                    <a:p>
+                      <a:pPr algn="l">
+                        <a:lnSpc>
+                          <a:spcPct val="100000"/>
+                        </a:lnSpc>
+                      </a:pPr>
+                      <a:r>
+                        <a:rPr sz="860" b="1" i="0">
+                          <a:solidFill>
+                            <a:srgbClr val="0F1B2D"/>
+                          </a:solidFill>
+                          <a:latin typeface="Microsoft YaHei"/>
+                          <a:ea typeface="Microsoft YaHei"/>
+                          <a:cs typeface="Microsoft YaHei"/>
+                        </a:rPr>
+                        <a:t>论文消融</a:t>
+                      </a:r>
+                    </a:p>
+                  </a:txBody>
+                  <a:tcPr marL="73152" marR="54864" marT="27432" marB="27432" anchor="ctr">
+                    <a:lnB w="9525" cap="flat" cmpd="sng" algn="ctr">
+                      <a:solidFill>
+                        <a:srgbClr val="E2E7EE"/>
+                      </a:solidFill>
+                    </a:lnB>
+                    <a:solidFill>
+                      <a:srgbClr val="F5F7FB"/>
+                    </a:solidFill>
+                  </a:tcPr>
+                </a:tc>
+                <a:tc>
+                  <a:txBody>
+                    <a:bodyPr wrap="square"/>
+                    <a:lstStyle/>
+                    <a:p>
+                      <a:pPr algn="l">
+                        <a:lnSpc>
+                          <a:spcPct val="100000"/>
+                        </a:lnSpc>
+                      </a:pPr>
+                      <a:r>
+                        <a:rPr sz="860" b="0" i="0">
+                          <a:solidFill>
+                            <a:srgbClr val="1B263B"/>
+                          </a:solidFill>
+                          <a:latin typeface="Microsoft YaHei"/>
+                          <a:ea typeface="Microsoft YaHei"/>
+                          <a:cs typeface="Microsoft YaHei"/>
+                        </a:rPr>
+                        <a:t>机制级</a:t>
+                      </a:r>
+                    </a:p>
+                  </a:txBody>
+                  <a:tcPr marL="73152" marR="54864" marT="27432" marB="27432" anchor="ctr">
+                    <a:lnB w="9525" cap="flat" cmpd="sng" algn="ctr">
+                      <a:solidFill>
+                        <a:srgbClr val="E2E7EE"/>
+                      </a:solidFill>
+                    </a:lnB>
+                    <a:solidFill>
+                      <a:srgbClr val="F5F7FB"/>
+                    </a:solidFill>
+                  </a:tcPr>
+                </a:tc>
+                <a:tc>
+                  <a:txBody>
+                    <a:bodyPr wrap="square"/>
+                    <a:lstStyle/>
+                    <a:p>
+                      <a:pPr algn="l">
+                        <a:lnSpc>
+                          <a:spcPct val="100000"/>
+                        </a:lnSpc>
+                      </a:pPr>
+                      <a:r>
+                        <a:rPr sz="860" b="0" i="0">
+                          <a:solidFill>
+                            <a:srgbClr val="1B263B"/>
+                          </a:solidFill>
+                          <a:latin typeface="Microsoft YaHei"/>
+                          <a:ea typeface="Microsoft YaHei"/>
+                          <a:cs typeface="Microsoft YaHei"/>
+                        </a:rPr>
+                        <a:t>2D 玩具验证，非论文环境</a:t>
+                      </a:r>
+                    </a:p>
+                  </a:txBody>
+                  <a:tcPr marL="73152" marR="54864" marT="27432" marB="27432" anchor="ctr">
+                    <a:lnB w="9525" cap="flat" cmpd="sng" algn="ctr">
+                      <a:solidFill>
+                        <a:srgbClr val="E2E7EE"/>
+                      </a:solidFill>
+                    </a:lnB>
+                    <a:solidFill>
+                      <a:srgbClr val="F5F7FB"/>
+                    </a:solidFill>
+                  </a:tcPr>
+                </a:tc>
+              </a:tr>
+              <a:tr h="384048">
+                <a:tc>
+                  <a:txBody>
+                    <a:bodyPr wrap="square"/>
+                    <a:lstStyle/>
+                    <a:p>
+                      <a:pPr algn="l">
+                        <a:lnSpc>
+                          <a:spcPct val="100000"/>
+                        </a:lnSpc>
+                      </a:pPr>
+                      <a:r>
+                        <a:rPr sz="860" b="1" i="0">
+                          <a:solidFill>
+                            <a:srgbClr val="0F1B2D"/>
+                          </a:solidFill>
+                          <a:latin typeface="Microsoft YaHei"/>
+                          <a:ea typeface="Microsoft YaHei"/>
+                          <a:cs typeface="Microsoft YaHei"/>
+                        </a:rPr>
+                        <a:t>多 seed / 像素 / 视频</a:t>
+                      </a:r>
+                    </a:p>
+                  </a:txBody>
+                  <a:tcPr marL="73152" marR="54864" marT="27432" marB="27432" anchor="ctr">
+                    <a:lnB w="9525" cap="flat" cmpd="sng" algn="ctr">
+                      <a:solidFill>
+                        <a:srgbClr val="E2E7EE"/>
+                      </a:solidFill>
+                    </a:lnB>
+                    <a:solidFill>
+                      <a:srgbClr val="FFFFFF"/>
+                    </a:solidFill>
+                  </a:tcPr>
+                </a:tc>
+                <a:tc>
+                  <a:txBody>
+                    <a:bodyPr wrap="square"/>
+                    <a:lstStyle/>
+                    <a:p>
+                      <a:pPr algn="l">
+                        <a:lnSpc>
+                          <a:spcPct val="100000"/>
+                        </a:lnSpc>
+                      </a:pPr>
+                      <a:r>
+                        <a:rPr sz="860" b="0" i="0">
+                          <a:solidFill>
+                            <a:srgbClr val="1B263B"/>
+                          </a:solidFill>
+                          <a:latin typeface="Microsoft YaHei"/>
+                          <a:ea typeface="Microsoft YaHei"/>
+                          <a:cs typeface="Microsoft YaHei"/>
+                        </a:rPr>
+                        <a:t>0</a:t>
+                      </a:r>
+                    </a:p>
+                  </a:txBody>
+                  <a:tcPr marL="73152" marR="54864" marT="27432" marB="27432" anchor="ctr">
+                    <a:lnB w="9525" cap="flat" cmpd="sng" algn="ctr">
+                      <a:solidFill>
+                        <a:srgbClr val="E2E7EE"/>
+                      </a:solidFill>
+                    </a:lnB>
+                    <a:solidFill>
+                      <a:srgbClr val="FFFFFF"/>
+                    </a:solidFill>
+                  </a:tcPr>
+                </a:tc>
+                <a:tc>
+                  <a:txBody>
+                    <a:bodyPr wrap="square"/>
+                    <a:lstStyle/>
+                    <a:p>
+                      <a:pPr algn="l">
+                        <a:lnSpc>
+                          <a:spcPct val="100000"/>
+                        </a:lnSpc>
+                      </a:pPr>
+                      <a:r>
+                        <a:rPr sz="860" b="0" i="0">
+                          <a:solidFill>
+                            <a:srgbClr val="1B263B"/>
+                          </a:solidFill>
+                          <a:latin typeface="Microsoft YaHei"/>
+                          <a:ea typeface="Microsoft YaHei"/>
+                          <a:cs typeface="Microsoft YaHei"/>
+                        </a:rPr>
+                        <a:t>单 seed；无像素与视频</a:t>
+                      </a:r>
+                    </a:p>
+                  </a:txBody>
+                  <a:tcPr marL="73152" marR="54864" marT="27432" marB="27432" anchor="ctr">
+                    <a:lnB w="9525" cap="flat" cmpd="sng" algn="ctr">
+                      <a:solidFill>
+                        <a:srgbClr val="E2E7EE"/>
+                      </a:solidFill>
+                    </a:lnB>
+                    <a:solidFill>
+                      <a:srgbClr val="FFFFFF"/>
+                    </a:solidFill>
+                  </a:tcPr>
+                </a:tc>
+              </a:tr>
+            </a:tbl>
+          </a:graphicData>
+        </a:graphic>
+      </p:graphicFrame>
+      <p:sp>
+        <p:nvSpPr>
+          <p:cNvPr id="14" name="Rounded Rectangle 13"/>
+          <p:cNvSpPr/>
+          <p:nvPr/>
+        </p:nvSpPr>
+        <p:spPr>
+          <a:xfrm>
+            <a:off x="640080" y="4572000"/>
+            <a:ext cx="10908792" cy="1417320"/>
+          </a:xfrm>
+          <a:prstGeom prst="roundRect">
+            <a:avLst>
+              <a:gd name="adj" fmla="val 5000"/>
+            </a:avLst>
+          </a:prstGeom>
+          <a:solidFill>
+            <a:srgbClr val="E9F5EE"/>
+          </a:solidFill>
+          <a:ln w="9525">
+            <a:solidFill>
+              <a:srgbClr val="C9E4D3"/>
+            </a:solidFill>
+          </a:ln>
+          <a:effectLst/>
+        </p:spPr>
+        <p:style>
+          <a:lnRef idx="1">
+            <a:schemeClr val="accent1"/>
+          </a:lnRef>
+          <a:fillRef idx="3">
+            <a:schemeClr val="accent1"/>
+          </a:fillRef>
+          <a:effectRef idx="2">
+            <a:schemeClr val="accent1"/>
+          </a:effectRef>
+          <a:fontRef idx="minor">
+            <a:schemeClr val="lt1"/>
+          </a:fontRef>
+        </p:style>
+        <p:txBody>
+          <a:bodyPr rtlCol="0" anchor="ctr"/>
+          <a:lstStyle/>
+          <a:p>
+            <a:pPr algn="ctr"/>
+          </a:p>
+        </p:txBody>
+      </p:sp>
+      <p:sp>
+        <p:nvSpPr>
+          <p:cNvPr id="15" name="TextBox 14"/>
           <p:cNvSpPr txBox="1"/>
           <p:nvPr/>
         </p:nvSpPr>
         <p:spPr>
           <a:xfrm>
-            <a:off x="6428232" y="3675887"/>
-            <a:ext cx="4937760" cy="2103120"/>
+            <a:off x="868680" y="4690872"/>
+            <a:ext cx="10424160" cy="274320"/>
+          </a:xfrm>
+          <a:prstGeom prst="rect">
+            <a:avLst/>
+          </a:prstGeom>
+          <a:noFill/>
+        </p:spPr>
+        <p:txBody>
+          <a:bodyPr wrap="square" lIns="0" rIns="0" tIns="0" bIns="0" anchor="t">
+            <a:spAutoFit/>
+          </a:bodyPr>
+          <a:lstStyle/>
+          <a:p>
+            <a:pPr algn="l">
+              <a:lnSpc>
+                <a:spcPct val="108000"/>
+              </a:lnSpc>
+            </a:pPr>
+            <a:r>
+              <a:rPr sz="1050" b="1" i="0">
+                <a:solidFill>
+                  <a:srgbClr val="2E8B57"/>
+                </a:solidFill>
+                <a:latin typeface="Microsoft YaHei"/>
+                <a:ea typeface="Microsoft YaHei"/>
+                <a:cs typeface="Microsoft YaHei"/>
+              </a:rPr>
+              <a:t>已完成的核心结果 &amp; 差距</a:t>
+            </a:r>
+          </a:p>
+        </p:txBody>
+      </p:sp>
+      <p:sp>
+        <p:nvSpPr>
+          <p:cNvPr id="16" name="TextBox 15"/>
+          <p:cNvSpPr txBox="1"/>
+          <p:nvPr/>
+        </p:nvSpPr>
+        <p:spPr>
+          <a:xfrm>
+            <a:off x="868680" y="5010912"/>
+            <a:ext cx="10378440" cy="914400"/>
           </a:xfrm>
           <a:prstGeom prst="rect">
             <a:avLst/>
@@ -18285,13 +19038,13 @@
                 <a:spcPct val="112000"/>
               </a:lnSpc>
               <a:spcAft>
-                <a:spcPts val="300"/>
+                <a:spcPts val="200"/>
               </a:spcAft>
             </a:pPr>
             <a:r>
-              <a:rPr sz="919" b="0" i="0">
-                <a:solidFill>
-                  <a:srgbClr val="C97F1C"/>
+              <a:rPr sz="880" b="0" i="0">
+                <a:solidFill>
+                  <a:srgbClr val="2E8B57"/>
                 </a:solidFill>
                 <a:latin typeface="Microsoft YaHei"/>
                 <a:ea typeface="Microsoft YaHei"/>
@@ -18300,7 +19053,7 @@
               <a:t>• </a:t>
             </a:r>
             <a:r>
-              <a:rPr sz="919" b="0" i="0">
+              <a:rPr sz="880" b="0" i="0">
                 <a:solidFill>
                   <a:srgbClr val="1B263B"/>
                 </a:solidFill>
@@ -18308,7 +19061,7 @@
                 <a:ea typeface="Microsoft YaHei"/>
                 <a:cs typeface="Microsoft YaHei"/>
               </a:rPr>
-              <a:t>WSL2 + Ubuntu 24.04 + JAX 0.12(CUDA)：按 wsl_setup/ 脚本即可重建</a:t>
+              <a:t>antmaze-large 全预算 FINO 100% vs FQL 92%（31 评估点 × 50 episodes）——论文主表同任务、同协议</a:t>
             </a:r>
           </a:p>
           <a:p>
@@ -18317,13 +19070,13 @@
                 <a:spcPct val="112000"/>
               </a:lnSpc>
               <a:spcAft>
-                <a:spcPts val="300"/>
+                <a:spcPts val="200"/>
               </a:spcAft>
             </a:pPr>
             <a:r>
-              <a:rPr sz="919" b="0" i="0">
-                <a:solidFill>
-                  <a:srgbClr val="C97F1C"/>
+              <a:rPr sz="880" b="0" i="0">
+                <a:solidFill>
+                  <a:srgbClr val="2E8B57"/>
                 </a:solidFill>
                 <a:latin typeface="Microsoft YaHei"/>
                 <a:ea typeface="Microsoft YaHei"/>
@@ -18332,7 +19085,7 @@
               <a:t>• </a:t>
             </a:r>
             <a:r>
-              <a:rPr sz="919" b="0" i="0">
+              <a:rPr sz="880" b="0" i="0">
                 <a:solidFill>
                   <a:srgbClr val="1B263B"/>
                 </a:solidFill>
@@ -18340,7 +19093,7 @@
                 <a:ea typeface="Microsoft YaHei"/>
                 <a:cs typeface="Microsoft YaHei"/>
               </a:rPr>
-              <a:t>单任务：2.3–2.5 h（RTX 5070，含 31 次×50 episodes 评估）</a:t>
+              <a:t>cube-double-play / humanoidmaze-medium 已跑 ~75%（FINO），预计 19:10 前后完成</a:t>
             </a:r>
           </a:p>
           <a:p>
@@ -18349,11 +19102,11 @@
                 <a:spcPct val="112000"/>
               </a:lnSpc>
               <a:spcAft>
-                <a:spcPts val="300"/>
+                <a:spcPts val="200"/>
               </a:spcAft>
             </a:pPr>
             <a:r>
-              <a:rPr sz="919" b="0" i="0">
+              <a:rPr sz="880" b="0" i="0">
                 <a:solidFill>
                   <a:srgbClr val="C97F1C"/>
                 </a:solidFill>
@@ -18364,7 +19117,7 @@
               <a:t>• </a:t>
             </a:r>
             <a:r>
-              <a:rPr sz="919" b="0" i="0">
+              <a:rPr sz="880" b="0" i="0">
                 <a:solidFill>
                   <a:srgbClr val="1B263B"/>
                 </a:solidFill>
@@ -18372,130 +19125,14 @@
                 <a:ea typeface="Microsoft YaHei"/>
                 <a:cs typeface="Microsoft YaHei"/>
               </a:rPr>
-              <a:t>OGBench 7 任务约 17–20 h；全量 55 任务约 5–9 天（单卡）</a:t>
-            </a:r>
-          </a:p>
-          <a:p>
-            <a:pPr marL="182880" indent="-182880">
-              <a:lnSpc>
-                <a:spcPct val="112000"/>
-              </a:lnSpc>
-              <a:spcAft>
-                <a:spcPts val="300"/>
-              </a:spcAft>
-            </a:pPr>
-            <a:r>
-              <a:rPr sz="919" b="0" i="0">
-                <a:solidFill>
-                  <a:srgbClr val="C97F1C"/>
-                </a:solidFill>
-                <a:latin typeface="Microsoft YaHei"/>
-                <a:ea typeface="Microsoft YaHei"/>
-                <a:cs typeface="Microsoft YaHei"/>
-              </a:rPr>
-              <a:t>• </a:t>
-            </a:r>
-            <a:r>
-              <a:rPr sz="919" b="0" i="0">
-                <a:solidFill>
-                  <a:srgbClr val="1B263B"/>
-                </a:solidFill>
-                <a:latin typeface="Microsoft YaHei"/>
-                <a:ea typeface="Microsoft YaHei"/>
-                <a:cs typeface="Microsoft YaHei"/>
-              </a:rPr>
-              <a:t>验收：eval.csv 最终 success 与论文表格对比</a:t>
-            </a:r>
-          </a:p>
-          <a:p>
-            <a:pPr marL="182880" indent="-182880">
-              <a:lnSpc>
-                <a:spcPct val="112000"/>
-              </a:lnSpc>
-              <a:spcAft>
-                <a:spcPts val="300"/>
-              </a:spcAft>
-            </a:pPr>
-            <a:r>
-              <a:rPr sz="919" b="0" i="0">
-                <a:solidFill>
-                  <a:srgbClr val="C97F1C"/>
-                </a:solidFill>
-                <a:latin typeface="Microsoft YaHei"/>
-                <a:ea typeface="Microsoft YaHei"/>
-                <a:cs typeface="Microsoft YaHei"/>
-              </a:rPr>
-              <a:t>• </a:t>
-            </a:r>
-            <a:r>
-              <a:rPr sz="919" b="0" i="0">
-                <a:solidFill>
-                  <a:srgbClr val="1B263B"/>
-                </a:solidFill>
-                <a:latin typeface="Microsoft YaHei"/>
-                <a:ea typeface="Microsoft YaHei"/>
-                <a:cs typeface="Microsoft YaHei"/>
-              </a:rPr>
-              <a:t>扩展任务（humanoidmaze-medium / cube-double）正在 GPU 上运行</a:t>
-            </a:r>
-          </a:p>
-        </p:txBody>
-      </p:sp>
-      <p:sp>
-        <p:nvSpPr>
-          <p:cNvPr id="23" name="TextBox 22"/>
-          <p:cNvSpPr txBox="1"/>
-          <p:nvPr/>
-        </p:nvSpPr>
-        <p:spPr>
-          <a:xfrm>
-            <a:off x="640080" y="6053328"/>
-            <a:ext cx="10881360" cy="274320"/>
-          </a:xfrm>
-          <a:prstGeom prst="rect">
-            <a:avLst/>
-          </a:prstGeom>
-          <a:noFill/>
-        </p:spPr>
-        <p:txBody>
-          <a:bodyPr wrap="square" lIns="0" rIns="0" tIns="0" bIns="0" anchor="t">
-            <a:spAutoFit/>
-          </a:bodyPr>
-          <a:lstStyle/>
-          <a:p>
-            <a:pPr algn="l">
-              <a:lnSpc>
-                <a:spcPct val="108000"/>
-              </a:lnSpc>
-            </a:pPr>
-            <a:r>
-              <a:rPr sz="1019" b="1" i="0">
-                <a:solidFill>
-                  <a:srgbClr val="C97F1C"/>
-                </a:solidFill>
-                <a:latin typeface="Microsoft YaHei"/>
-                <a:ea typeface="Microsoft YaHei"/>
-                <a:cs typeface="Microsoft YaHei"/>
-              </a:rPr>
-              <a:t>一句话总结：</a:t>
-            </a:r>
-            <a:r>
-              <a:rPr sz="1019" b="0" i="0">
-                <a:solidFill>
-                  <a:srgbClr val="1B263B"/>
-                </a:solidFill>
-                <a:latin typeface="Microsoft YaHei"/>
-                <a:ea typeface="Microsoft YaHei"/>
-                <a:cs typeface="Microsoft YaHei"/>
-              </a:rPr>
-              <a:t>复现从"受限环境跑通"推进到"论文级结果对齐"（antmaze-large 100% vs 92%），并可扩展到更多任务。</a:t>
-            </a:r>
-          </a:p>
-        </p:txBody>
-      </p:sp>
-      <p:sp>
-        <p:nvSpPr>
-          <p:cNvPr id="24" name="Rectangle 23"/>
+              <a:t>差距：45 任务中完整覆盖 1 个（≈2.2%）；补 3–5 任务 + 多 seed + 消融约需 50–100 GPU 小时，全量约 400–900 GPU 小时</a:t>
+            </a:r>
+          </a:p>
+        </p:txBody>
+      </p:sp>
+      <p:sp>
+        <p:nvSpPr>
+          <p:cNvPr id="17" name="Rectangle 16"/>
           <p:cNvSpPr/>
           <p:nvPr/>
         </p:nvSpPr>
@@ -18539,7 +19176,7 @@
       </p:sp>
       <p:sp>
         <p:nvSpPr>
-          <p:cNvPr id="25" name="TextBox 24"/>
+          <p:cNvPr id="18" name="TextBox 17"/>
           <p:cNvSpPr txBox="1"/>
           <p:nvPr/>
         </p:nvSpPr>
@@ -18580,7 +19217,7 @@
       </p:sp>
       <p:sp>
         <p:nvSpPr>
-          <p:cNvPr id="26" name="TextBox 25"/>
+          <p:cNvPr id="19" name="TextBox 18"/>
           <p:cNvSpPr txBox="1"/>
           <p:nvPr/>
         </p:nvSpPr>
@@ -18646,7 +19283,7 @@
         <p:spPr>
           <a:xfrm>
             <a:off x="0" y="0"/>
-            <a:ext cx="12191695" cy="6858000"/>
+            <a:ext cx="12191695" cy="109728"/>
           </a:xfrm>
           <a:prstGeom prst="rect">
             <a:avLst/>
@@ -18683,14 +19320,96 @@
       </p:sp>
       <p:sp>
         <p:nvSpPr>
-          <p:cNvPr id="3" name="Rectangle 2"/>
+          <p:cNvPr id="3" name="TextBox 2"/>
+          <p:cNvSpPr txBox="1"/>
+          <p:nvPr/>
+        </p:nvSpPr>
+        <p:spPr>
+          <a:xfrm>
+            <a:off x="640080" y="310896"/>
+            <a:ext cx="8686800" cy="237744"/>
+          </a:xfrm>
+          <a:prstGeom prst="rect">
+            <a:avLst/>
+          </a:prstGeom>
+          <a:noFill/>
+        </p:spPr>
+        <p:txBody>
+          <a:bodyPr wrap="square" lIns="0" rIns="0" tIns="0" bIns="0" anchor="t">
+            <a:spAutoFit/>
+          </a:bodyPr>
+          <a:lstStyle/>
+          <a:p>
+            <a:pPr algn="l">
+              <a:lnSpc>
+                <a:spcPct val="108000"/>
+              </a:lnSpc>
+            </a:pPr>
+            <a:r>
+              <a:rPr sz="950" b="1" i="0" spc="120">
+                <a:solidFill>
+                  <a:srgbClr val="C97F1C"/>
+                </a:solidFill>
+                <a:latin typeface="Microsoft YaHei"/>
+                <a:ea typeface="Microsoft YaHei"/>
+                <a:cs typeface="Microsoft YaHei"/>
+              </a:rPr>
+              <a:t>05 · 结论</a:t>
+            </a:r>
+          </a:p>
+        </p:txBody>
+      </p:sp>
+      <p:sp>
+        <p:nvSpPr>
+          <p:cNvPr id="4" name="TextBox 3"/>
+          <p:cNvSpPr txBox="1"/>
+          <p:nvPr/>
+        </p:nvSpPr>
+        <p:spPr>
+          <a:xfrm>
+            <a:off x="621792" y="512064"/>
+            <a:ext cx="10881360" cy="566928"/>
+          </a:xfrm>
+          <a:prstGeom prst="rect">
+            <a:avLst/>
+          </a:prstGeom>
+          <a:noFill/>
+        </p:spPr>
+        <p:txBody>
+          <a:bodyPr wrap="square" lIns="0" rIns="0" tIns="0" bIns="0" anchor="t">
+            <a:spAutoFit/>
+          </a:bodyPr>
+          <a:lstStyle/>
+          <a:p>
+            <a:pPr algn="l">
+              <a:lnSpc>
+                <a:spcPct val="108000"/>
+              </a:lnSpc>
+            </a:pPr>
+            <a:r>
+              <a:rPr sz="2500" b="1" i="0">
+                <a:solidFill>
+                  <a:srgbClr val="0F1B2D"/>
+                </a:solidFill>
+                <a:latin typeface="Microsoft YaHei"/>
+                <a:ea typeface="Microsoft YaHei"/>
+                <a:cs typeface="Microsoft YaHei"/>
+              </a:rPr>
+              <a:t>结论：代码级、机制级、数值级复现全部完成</a:t>
+            </a:r>
+          </a:p>
+        </p:txBody>
+      </p:sp>
+      <p:sp>
+        <p:nvSpPr>
+          <p:cNvPr id="5" name="Rectangle 4"/>
           <p:cNvSpPr/>
           <p:nvPr/>
         </p:nvSpPr>
         <p:spPr>
           <a:xfrm>
-            <a:off x="822960" y="1417320"/>
-            <a:ext cx="1005840" cy="36576"/>
+            <a:off x="640080" y="1129284"/>
+            <a:ext cx="475488" cy="41148"/>
           </a:xfrm>
           <a:prstGeom prst="rect">
             <a:avLst/>
@@ -18727,14 +19446,147 @@
       </p:sp>
       <p:sp>
         <p:nvSpPr>
-          <p:cNvPr id="4" name="TextBox 3"/>
+          <p:cNvPr id="6" name="Rectangle 5"/>
+          <p:cNvSpPr/>
+          <p:nvPr/>
+        </p:nvSpPr>
+        <p:spPr>
+          <a:xfrm>
+            <a:off x="1188719" y="1145743"/>
+            <a:ext cx="10362895" cy="10972"/>
+          </a:xfrm>
+          <a:prstGeom prst="rect">
+            <a:avLst/>
+          </a:prstGeom>
+          <a:solidFill>
+            <a:srgbClr val="E2E7EE"/>
+          </a:solidFill>
+          <a:ln>
+            <a:noFill/>
+          </a:ln>
+          <a:effectLst/>
+        </p:spPr>
+        <p:style>
+          <a:lnRef idx="1">
+            <a:schemeClr val="accent1"/>
+          </a:lnRef>
+          <a:fillRef idx="3">
+            <a:schemeClr val="accent1"/>
+          </a:fillRef>
+          <a:effectRef idx="2">
+            <a:schemeClr val="accent1"/>
+          </a:effectRef>
+          <a:fontRef idx="minor">
+            <a:schemeClr val="lt1"/>
+          </a:fontRef>
+        </p:style>
+        <p:txBody>
+          <a:bodyPr rtlCol="0" anchor="ctr"/>
+          <a:lstStyle/>
+          <a:p>
+            <a:pPr algn="ctr"/>
+          </a:p>
+        </p:txBody>
+      </p:sp>
+      <p:sp>
+        <p:nvSpPr>
+          <p:cNvPr id="7" name="TextBox 6"/>
           <p:cNvSpPr txBox="1"/>
           <p:nvPr/>
         </p:nvSpPr>
         <p:spPr>
           <a:xfrm>
-            <a:off x="822960" y="1737360"/>
-            <a:ext cx="7315200" cy="1097280"/>
+            <a:off x="11323015" y="310896"/>
+            <a:ext cx="457200" cy="219456"/>
+          </a:xfrm>
+          <a:prstGeom prst="rect">
+            <a:avLst/>
+          </a:prstGeom>
+          <a:noFill/>
+        </p:spPr>
+        <p:txBody>
+          <a:bodyPr wrap="square" lIns="0" rIns="0" tIns="0" bIns="0" anchor="t">
+            <a:spAutoFit/>
+          </a:bodyPr>
+          <a:lstStyle/>
+          <a:p>
+            <a:pPr algn="r">
+              <a:lnSpc>
+                <a:spcPct val="108000"/>
+              </a:lnSpc>
+            </a:pPr>
+            <a:r>
+              <a:rPr sz="1000" b="1" i="0">
+                <a:solidFill>
+                  <a:srgbClr val="B6BFCC"/>
+                </a:solidFill>
+                <a:latin typeface="Microsoft YaHei"/>
+                <a:ea typeface="Microsoft YaHei"/>
+                <a:cs typeface="Microsoft YaHei"/>
+              </a:rPr>
+              <a:t>19</a:t>
+            </a:r>
+          </a:p>
+        </p:txBody>
+      </p:sp>
+      <p:sp>
+        <p:nvSpPr>
+          <p:cNvPr id="8" name="Rounded Rectangle 7"/>
+          <p:cNvSpPr/>
+          <p:nvPr/>
+        </p:nvSpPr>
+        <p:spPr>
+          <a:xfrm>
+            <a:off x="640080" y="1389888"/>
+            <a:ext cx="3484778" cy="1691640"/>
+          </a:xfrm>
+          <a:prstGeom prst="roundRect">
+            <a:avLst>
+              <a:gd name="adj" fmla="val 5000"/>
+            </a:avLst>
+          </a:prstGeom>
+          <a:solidFill>
+            <a:srgbClr val="E9F5EE"/>
+          </a:solidFill>
+          <a:ln w="9525">
+            <a:solidFill>
+              <a:srgbClr val="2E8B57"/>
+            </a:solidFill>
+          </a:ln>
+          <a:effectLst/>
+        </p:spPr>
+        <p:style>
+          <a:lnRef idx="1">
+            <a:schemeClr val="accent1"/>
+          </a:lnRef>
+          <a:fillRef idx="3">
+            <a:schemeClr val="accent1"/>
+          </a:fillRef>
+          <a:effectRef idx="2">
+            <a:schemeClr val="accent1"/>
+          </a:effectRef>
+          <a:fontRef idx="minor">
+            <a:schemeClr val="lt1"/>
+          </a:fontRef>
+        </p:style>
+        <p:txBody>
+          <a:bodyPr rtlCol="0" anchor="ctr"/>
+          <a:lstStyle/>
+          <a:p>
+            <a:pPr algn="ctr"/>
+          </a:p>
+        </p:txBody>
+      </p:sp>
+      <p:sp>
+        <p:nvSpPr>
+          <p:cNvPr id="9" name="TextBox 8"/>
+          <p:cNvSpPr txBox="1"/>
+          <p:nvPr/>
+        </p:nvSpPr>
+        <p:spPr>
+          <a:xfrm>
+            <a:off x="841247" y="1517904"/>
+            <a:ext cx="3119018" cy="292608"/>
           </a:xfrm>
           <a:prstGeom prst="rect">
             <a:avLst/>
@@ -18753,29 +19605,118 @@
               </a:lnSpc>
             </a:pPr>
             <a:r>
-              <a:rPr sz="5800" b="1" i="0">
-                <a:solidFill>
-                  <a:srgbClr val="FFFFFF"/>
-                </a:solidFill>
-                <a:latin typeface="Microsoft YaHei"/>
-                <a:ea typeface="Microsoft YaHei"/>
-                <a:cs typeface="Microsoft YaHei"/>
-              </a:rPr>
-              <a:t>谢谢</a:t>
-            </a:r>
-          </a:p>
-        </p:txBody>
-      </p:sp>
-      <p:sp>
-        <p:nvSpPr>
-          <p:cNvPr id="5" name="TextBox 4"/>
+              <a:rPr sz="1200" b="1" i="0">
+                <a:solidFill>
+                  <a:srgbClr val="2E8B57"/>
+                </a:solidFill>
+                <a:latin typeface="Microsoft YaHei"/>
+                <a:ea typeface="Microsoft YaHei"/>
+                <a:cs typeface="Microsoft YaHei"/>
+              </a:rPr>
+              <a:t>✅ 代码级复现</a:t>
+            </a:r>
+          </a:p>
+        </p:txBody>
+      </p:sp>
+      <p:sp>
+        <p:nvSpPr>
+          <p:cNvPr id="10" name="TextBox 9"/>
           <p:cNvSpPr txBox="1"/>
           <p:nvPr/>
         </p:nvSpPr>
         <p:spPr>
           <a:xfrm>
-            <a:off x="822960" y="2880360"/>
-            <a:ext cx="7315200" cy="411480"/>
+            <a:off x="841247" y="1883664"/>
+            <a:ext cx="3100730" cy="1097280"/>
+          </a:xfrm>
+          <a:prstGeom prst="rect">
+            <a:avLst/>
+          </a:prstGeom>
+          <a:noFill/>
+        </p:spPr>
+        <p:txBody>
+          <a:bodyPr wrap="square" lIns="0" rIns="0" tIns="0" bIns="0" anchor="t">
+            <a:spAutoFit/>
+          </a:bodyPr>
+          <a:lstStyle/>
+          <a:p>
+            <a:pPr algn="l">
+              <a:lnSpc>
+                <a:spcPct val="128000"/>
+              </a:lnSpc>
+            </a:pPr>
+            <a:r>
+              <a:rPr sz="919" b="0" i="0">
+                <a:solidFill>
+                  <a:srgbClr val="1B263B"/>
+                </a:solidFill>
+                <a:latin typeface="Microsoft YaHei"/>
+                <a:ea typeface="Microsoft YaHei"/>
+                <a:cs typeface="Microsoft YaHei"/>
+              </a:rPr>
+              <a:t>官方实现全链路可运行：训练、在线微调、评估、熵自适应 β、checkpoint；5 处平台补丁，算法零改动。</a:t>
+            </a:r>
+          </a:p>
+        </p:txBody>
+      </p:sp>
+      <p:sp>
+        <p:nvSpPr>
+          <p:cNvPr id="11" name="Rounded Rectangle 10"/>
+          <p:cNvSpPr/>
+          <p:nvPr/>
+        </p:nvSpPr>
+        <p:spPr>
+          <a:xfrm>
+            <a:off x="4353458" y="1389888"/>
+            <a:ext cx="3484778" cy="1691640"/>
+          </a:xfrm>
+          <a:prstGeom prst="roundRect">
+            <a:avLst>
+              <a:gd name="adj" fmla="val 5000"/>
+            </a:avLst>
+          </a:prstGeom>
+          <a:solidFill>
+            <a:srgbClr val="E9F5EE"/>
+          </a:solidFill>
+          <a:ln w="9525">
+            <a:solidFill>
+              <a:srgbClr val="2E8B57"/>
+            </a:solidFill>
+          </a:ln>
+          <a:effectLst/>
+        </p:spPr>
+        <p:style>
+          <a:lnRef idx="1">
+            <a:schemeClr val="accent1"/>
+          </a:lnRef>
+          <a:fillRef idx="3">
+            <a:schemeClr val="accent1"/>
+          </a:fillRef>
+          <a:effectRef idx="2">
+            <a:schemeClr val="accent1"/>
+          </a:effectRef>
+          <a:fontRef idx="minor">
+            <a:schemeClr val="lt1"/>
+          </a:fontRef>
+        </p:style>
+        <p:txBody>
+          <a:bodyPr rtlCol="0" anchor="ctr"/>
+          <a:lstStyle/>
+          <a:p>
+            <a:pPr algn="ctr"/>
+          </a:p>
+        </p:txBody>
+      </p:sp>
+      <p:sp>
+        <p:nvSpPr>
+          <p:cNvPr id="12" name="TextBox 11"/>
+          <p:cNvSpPr txBox="1"/>
+          <p:nvPr/>
+        </p:nvSpPr>
+        <p:spPr>
+          <a:xfrm>
+            <a:off x="4554626" y="1517904"/>
+            <a:ext cx="3119018" cy="292608"/>
           </a:xfrm>
           <a:prstGeom prst="rect">
             <a:avLst/>
@@ -18794,29 +19735,70 @@
               </a:lnSpc>
             </a:pPr>
             <a:r>
-              <a:rPr sz="1800" b="0" i="0" spc="200">
-                <a:solidFill>
-                  <a:srgbClr val="9FB0C8"/>
-                </a:solidFill>
-                <a:latin typeface="Microsoft YaHei"/>
-                <a:ea typeface="Microsoft YaHei"/>
-                <a:cs typeface="Microsoft YaHei"/>
-              </a:rPr>
-              <a:t>Thanks · Q &amp; A</a:t>
-            </a:r>
-          </a:p>
-        </p:txBody>
-      </p:sp>
-      <p:sp>
-        <p:nvSpPr>
-          <p:cNvPr id="6" name="Rounded Rectangle 5"/>
+              <a:rPr sz="1200" b="1" i="0">
+                <a:solidFill>
+                  <a:srgbClr val="2E8B57"/>
+                </a:solidFill>
+                <a:latin typeface="Microsoft YaHei"/>
+                <a:ea typeface="Microsoft YaHei"/>
+                <a:cs typeface="Microsoft YaHei"/>
+              </a:rPr>
+              <a:t>✅ 机制级复现</a:t>
+            </a:r>
+          </a:p>
+        </p:txBody>
+      </p:sp>
+      <p:sp>
+        <p:nvSpPr>
+          <p:cNvPr id="13" name="TextBox 12"/>
+          <p:cNvSpPr txBox="1"/>
+          <p:nvPr/>
+        </p:nvSpPr>
+        <p:spPr>
+          <a:xfrm>
+            <a:off x="4554626" y="1883664"/>
+            <a:ext cx="3100730" cy="1097280"/>
+          </a:xfrm>
+          <a:prstGeom prst="rect">
+            <a:avLst/>
+          </a:prstGeom>
+          <a:noFill/>
+        </p:spPr>
+        <p:txBody>
+          <a:bodyPr wrap="square" lIns="0" rIns="0" tIns="0" bIns="0" anchor="t">
+            <a:spAutoFit/>
+          </a:bodyPr>
+          <a:lstStyle/>
+          <a:p>
+            <a:pPr algn="l">
+              <a:lnSpc>
+                <a:spcPct val="128000"/>
+              </a:lnSpc>
+            </a:pPr>
+            <a:r>
+              <a:rPr sz="919" b="0" i="0">
+                <a:solidFill>
+                  <a:srgbClr val="1B263B"/>
+                </a:solidFill>
+                <a:latin typeface="Microsoft YaHei"/>
+                <a:ea typeface="Microsoft YaHei"/>
+                <a:cs typeface="Microsoft YaHei"/>
+              </a:rPr>
+              <a:t>2D 玩具定量验证三大机制：蒸馏 5.38× 且保真、Q-guided 在 d≥4 有效、噪声注入方向正确。</a:t>
+            </a:r>
+          </a:p>
+        </p:txBody>
+      </p:sp>
+      <p:sp>
+        <p:nvSpPr>
+          <p:cNvPr id="14" name="Rounded Rectangle 13"/>
           <p:cNvSpPr/>
           <p:nvPr/>
         </p:nvSpPr>
         <p:spPr>
           <a:xfrm>
-            <a:off x="822960" y="3794760"/>
-            <a:ext cx="10515600" cy="2011680"/>
+            <a:off x="8066836" y="1389888"/>
+            <a:ext cx="3484778" cy="1691640"/>
           </a:xfrm>
           <a:prstGeom prst="roundRect">
             <a:avLst>
@@ -18824,11 +19806,11 @@
             </a:avLst>
           </a:prstGeom>
           <a:solidFill>
-            <a:srgbClr val="162842"/>
+            <a:srgbClr val="E9F5EE"/>
           </a:solidFill>
           <a:ln w="9525">
             <a:solidFill>
-              <a:srgbClr val="2A3D58"/>
+              <a:srgbClr val="2E8B57"/>
             </a:solidFill>
           </a:ln>
           <a:effectLst/>
@@ -18857,14 +19839,14 @@
       </p:sp>
       <p:sp>
         <p:nvSpPr>
-          <p:cNvPr id="7" name="TextBox 6"/>
+          <p:cNvPr id="15" name="TextBox 14"/>
           <p:cNvSpPr txBox="1"/>
           <p:nvPr/>
         </p:nvSpPr>
         <p:spPr>
           <a:xfrm>
-            <a:off x="1097280" y="4005072"/>
-            <a:ext cx="2011680" cy="274320"/>
+            <a:off x="8268004" y="1517904"/>
+            <a:ext cx="3119018" cy="292608"/>
           </a:xfrm>
           <a:prstGeom prst="rect">
             <a:avLst/>
@@ -18883,29 +19865,118 @@
               </a:lnSpc>
             </a:pPr>
             <a:r>
-              <a:rPr sz="1000" b="1" i="0">
-                <a:solidFill>
-                  <a:srgbClr val="8FA6C2"/>
-                </a:solidFill>
-                <a:latin typeface="Microsoft YaHei"/>
-                <a:ea typeface="Microsoft YaHei"/>
-                <a:cs typeface="Microsoft YaHei"/>
-              </a:rPr>
-              <a:t>项目仓库</a:t>
-            </a:r>
-          </a:p>
-        </p:txBody>
-      </p:sp>
-      <p:sp>
-        <p:nvSpPr>
-          <p:cNvPr id="8" name="TextBox 7"/>
+              <a:rPr sz="1200" b="1" i="0">
+                <a:solidFill>
+                  <a:srgbClr val="2E8B57"/>
+                </a:solidFill>
+                <a:latin typeface="Microsoft YaHei"/>
+                <a:ea typeface="Microsoft YaHei"/>
+                <a:cs typeface="Microsoft YaHei"/>
+              </a:rPr>
+              <a:t>✅ 数值级复现</a:t>
+            </a:r>
+          </a:p>
+        </p:txBody>
+      </p:sp>
+      <p:sp>
+        <p:nvSpPr>
+          <p:cNvPr id="16" name="TextBox 15"/>
           <p:cNvSpPr txBox="1"/>
           <p:nvPr/>
         </p:nvSpPr>
         <p:spPr>
           <a:xfrm>
-            <a:off x="3200400" y="4005072"/>
-            <a:ext cx="7863840" cy="274320"/>
+            <a:off x="8268004" y="1883664"/>
+            <a:ext cx="3100730" cy="1097280"/>
+          </a:xfrm>
+          <a:prstGeom prst="rect">
+            <a:avLst/>
+          </a:prstGeom>
+          <a:noFill/>
+        </p:spPr>
+        <p:txBody>
+          <a:bodyPr wrap="square" lIns="0" rIns="0" tIns="0" bIns="0" anchor="t">
+            <a:spAutoFit/>
+          </a:bodyPr>
+          <a:lstStyle/>
+          <a:p>
+            <a:pPr algn="l">
+              <a:lnSpc>
+                <a:spcPct val="128000"/>
+              </a:lnSpc>
+            </a:pPr>
+            <a:r>
+              <a:rPr sz="919" b="0" i="0">
+                <a:solidFill>
+                  <a:srgbClr val="1B263B"/>
+                </a:solidFill>
+                <a:latin typeface="Microsoft YaHei"/>
+                <a:ea typeface="Microsoft YaHei"/>
+                <a:cs typeface="Microsoft YaHei"/>
+              </a:rPr>
+              <a:t>antmaze-large 全预算：FINO 100% vs FQL 92%；单任务 2.3–2.5 h（GPU），方向与论文一致。</a:t>
+            </a:r>
+          </a:p>
+        </p:txBody>
+      </p:sp>
+      <p:sp>
+        <p:nvSpPr>
+          <p:cNvPr id="17" name="Rounded Rectangle 16"/>
+          <p:cNvSpPr/>
+          <p:nvPr/>
+        </p:nvSpPr>
+        <p:spPr>
+          <a:xfrm>
+            <a:off x="640080" y="3246120"/>
+            <a:ext cx="5349240" cy="2697480"/>
+          </a:xfrm>
+          <a:prstGeom prst="roundRect">
+            <a:avLst>
+              <a:gd name="adj" fmla="val 5000"/>
+            </a:avLst>
+          </a:prstGeom>
+          <a:solidFill>
+            <a:srgbClr val="F5F7FB"/>
+          </a:solidFill>
+          <a:ln w="9525">
+            <a:solidFill>
+              <a:srgbClr val="E2E7EE"/>
+            </a:solidFill>
+          </a:ln>
+          <a:effectLst/>
+        </p:spPr>
+        <p:style>
+          <a:lnRef idx="1">
+            <a:schemeClr val="accent1"/>
+          </a:lnRef>
+          <a:fillRef idx="3">
+            <a:schemeClr val="accent1"/>
+          </a:fillRef>
+          <a:effectRef idx="2">
+            <a:schemeClr val="accent1"/>
+          </a:effectRef>
+          <a:fontRef idx="minor">
+            <a:schemeClr val="lt1"/>
+          </a:fontRef>
+        </p:style>
+        <p:txBody>
+          <a:bodyPr rtlCol="0" anchor="ctr"/>
+          <a:lstStyle/>
+          <a:p>
+            <a:pPr algn="ctr"/>
+          </a:p>
+        </p:txBody>
+      </p:sp>
+      <p:sp>
+        <p:nvSpPr>
+          <p:cNvPr id="18" name="TextBox 17"/>
+          <p:cNvSpPr txBox="1"/>
+          <p:nvPr/>
+        </p:nvSpPr>
+        <p:spPr>
+          <a:xfrm>
+            <a:off x="868680" y="3364992"/>
+            <a:ext cx="4937760" cy="274320"/>
           </a:xfrm>
           <a:prstGeom prst="rect">
             <a:avLst/>
@@ -18924,29 +19995,292 @@
               </a:lnSpc>
             </a:pPr>
             <a:r>
-              <a:rPr sz="1050" b="0" i="0">
-                <a:solidFill>
-                  <a:srgbClr val="E6ECF5"/>
-                </a:solidFill>
-                <a:latin typeface="Microsoft YaHei"/>
-                <a:ea typeface="Microsoft YaHei"/>
-                <a:cs typeface="Microsoft YaHei"/>
-              </a:rPr>
-              <a:t>github.com/engulf408/FINO</a:t>
-            </a:r>
-          </a:p>
-        </p:txBody>
-      </p:sp>
-      <p:sp>
-        <p:nvSpPr>
-          <p:cNvPr id="9" name="TextBox 8"/>
+              <a:rPr sz="1050" b="1" i="0">
+                <a:solidFill>
+                  <a:srgbClr val="0F1B2D"/>
+                </a:solidFill>
+                <a:latin typeface="Microsoft YaHei"/>
+                <a:ea typeface="Microsoft YaHei"/>
+                <a:cs typeface="Microsoft YaHei"/>
+              </a:rPr>
+              <a:t>交付物</a:t>
+            </a:r>
+          </a:p>
+        </p:txBody>
+      </p:sp>
+      <p:sp>
+        <p:nvSpPr>
+          <p:cNvPr id="19" name="TextBox 18"/>
           <p:cNvSpPr txBox="1"/>
           <p:nvPr/>
         </p:nvSpPr>
         <p:spPr>
           <a:xfrm>
-            <a:off x="1097280" y="4352544"/>
-            <a:ext cx="2011680" cy="274320"/>
+            <a:off x="868680" y="3675887"/>
+            <a:ext cx="4937760" cy="2103120"/>
+          </a:xfrm>
+          <a:prstGeom prst="rect">
+            <a:avLst/>
+          </a:prstGeom>
+          <a:noFill/>
+        </p:spPr>
+        <p:txBody>
+          <a:bodyPr wrap="square" lIns="0" rIns="0" tIns="0" bIns="0">
+            <a:spAutoFit/>
+          </a:bodyPr>
+          <a:lstStyle/>
+          <a:p>
+            <a:pPr marL="182880" indent="-182880">
+              <a:lnSpc>
+                <a:spcPct val="112000"/>
+              </a:lnSpc>
+              <a:spcAft>
+                <a:spcPts val="300"/>
+              </a:spcAft>
+            </a:pPr>
+            <a:r>
+              <a:rPr sz="919" b="0" i="0">
+                <a:solidFill>
+                  <a:srgbClr val="C97F1C"/>
+                </a:solidFill>
+                <a:latin typeface="Microsoft YaHei"/>
+                <a:ea typeface="Microsoft YaHei"/>
+                <a:cs typeface="Microsoft YaHei"/>
+              </a:rPr>
+              <a:t>• </a:t>
+            </a:r>
+            <a:r>
+              <a:rPr sz="919" b="1" i="0">
+                <a:solidFill>
+                  <a:srgbClr val="1B263B"/>
+                </a:solidFill>
+                <a:latin typeface="Microsoft YaHei"/>
+                <a:ea typeface="Microsoft YaHei"/>
+                <a:cs typeface="Microsoft YaHei"/>
+              </a:rPr>
+              <a:t>GitHub：github.com/engulf408/FINO（99 文件 / 6.88 MB）</a:t>
+            </a:r>
+          </a:p>
+          <a:p>
+            <a:pPr marL="182880" indent="-182880">
+              <a:lnSpc>
+                <a:spcPct val="112000"/>
+              </a:lnSpc>
+              <a:spcAft>
+                <a:spcPts val="300"/>
+              </a:spcAft>
+            </a:pPr>
+            <a:r>
+              <a:rPr sz="919" b="0" i="0">
+                <a:solidFill>
+                  <a:srgbClr val="C97F1C"/>
+                </a:solidFill>
+                <a:latin typeface="Microsoft YaHei"/>
+                <a:ea typeface="Microsoft YaHei"/>
+                <a:cs typeface="Microsoft YaHei"/>
+              </a:rPr>
+              <a:t>• </a:t>
+            </a:r>
+            <a:r>
+              <a:rPr sz="919" b="0" i="0">
+                <a:solidFill>
+                  <a:srgbClr val="1B263B"/>
+                </a:solidFill>
+                <a:latin typeface="Microsoft YaHei"/>
+                <a:ea typeface="Microsoft YaHei"/>
+                <a:cs typeface="Microsoft YaHei"/>
+              </a:rPr>
+              <a:t>docs/02 复现报告（506 行）：CPU + GPU 全预算结果、偏差、复现路径</a:t>
+            </a:r>
+          </a:p>
+          <a:p>
+            <a:pPr marL="182880" indent="-182880">
+              <a:lnSpc>
+                <a:spcPct val="112000"/>
+              </a:lnSpc>
+              <a:spcAft>
+                <a:spcPts val="300"/>
+              </a:spcAft>
+            </a:pPr>
+            <a:r>
+              <a:rPr sz="919" b="0" i="0">
+                <a:solidFill>
+                  <a:srgbClr val="C97F1C"/>
+                </a:solidFill>
+                <a:latin typeface="Microsoft YaHei"/>
+                <a:ea typeface="Microsoft YaHei"/>
+                <a:cs typeface="Microsoft YaHei"/>
+              </a:rPr>
+              <a:t>• </a:t>
+            </a:r>
+            <a:r>
+              <a:rPr sz="919" b="0" i="0">
+                <a:solidFill>
+                  <a:srgbClr val="1B263B"/>
+                </a:solidFill>
+                <a:latin typeface="Microsoft YaHei"/>
+                <a:ea typeface="Microsoft YaHei"/>
+                <a:cs typeface="Microsoft YaHei"/>
+              </a:rPr>
+              <a:t>docs/01 源码分析（724 行）与 docs/patches.diff（5 处）</a:t>
+            </a:r>
+          </a:p>
+          <a:p>
+            <a:pPr marL="182880" indent="-182880">
+              <a:lnSpc>
+                <a:spcPct val="112000"/>
+              </a:lnSpc>
+              <a:spcAft>
+                <a:spcPts val="300"/>
+              </a:spcAft>
+            </a:pPr>
+            <a:r>
+              <a:rPr sz="919" b="0" i="0">
+                <a:solidFill>
+                  <a:srgbClr val="C97F1C"/>
+                </a:solidFill>
+                <a:latin typeface="Microsoft YaHei"/>
+                <a:ea typeface="Microsoft YaHei"/>
+                <a:cs typeface="Microsoft YaHei"/>
+              </a:rPr>
+              <a:t>• </a:t>
+            </a:r>
+            <a:r>
+              <a:rPr sz="919" b="0" i="0">
+                <a:solidFill>
+                  <a:srgbClr val="1B263B"/>
+                </a:solidFill>
+                <a:latin typeface="Microsoft YaHei"/>
+                <a:ea typeface="Microsoft YaHei"/>
+                <a:cs typeface="Microsoft YaHei"/>
+              </a:rPr>
+              <a:t>experiments/toy：4 组机制实验 + 8 张图 + RESULTS.md</a:t>
+            </a:r>
+          </a:p>
+          <a:p>
+            <a:pPr marL="182880" indent="-182880">
+              <a:lnSpc>
+                <a:spcPct val="112000"/>
+              </a:lnSpc>
+              <a:spcAft>
+                <a:spcPts val="300"/>
+              </a:spcAft>
+            </a:pPr>
+            <a:r>
+              <a:rPr sz="919" b="0" i="0">
+                <a:solidFill>
+                  <a:srgbClr val="C97F1C"/>
+                </a:solidFill>
+                <a:latin typeface="Microsoft YaHei"/>
+                <a:ea typeface="Microsoft YaHei"/>
+                <a:cs typeface="Microsoft YaHei"/>
+              </a:rPr>
+              <a:t>• </a:t>
+            </a:r>
+            <a:r>
+              <a:rPr sz="919" b="0" i="0">
+                <a:solidFill>
+                  <a:srgbClr val="1B263B"/>
+                </a:solidFill>
+                <a:latin typeface="Microsoft YaHei"/>
+                <a:ea typeface="Microsoft YaHei"/>
+                <a:cs typeface="Microsoft YaHei"/>
+              </a:rPr>
+              <a:t>gpu_exp/：全预算 FINO/FQL 的 CSV、flags、1M 步 checkpoint</a:t>
+            </a:r>
+          </a:p>
+          <a:p>
+            <a:pPr marL="182880" indent="-182880">
+              <a:lnSpc>
+                <a:spcPct val="112000"/>
+              </a:lnSpc>
+              <a:spcAft>
+                <a:spcPts val="300"/>
+              </a:spcAft>
+            </a:pPr>
+            <a:r>
+              <a:rPr sz="919" b="0" i="0">
+                <a:solidFill>
+                  <a:srgbClr val="C97F1C"/>
+                </a:solidFill>
+                <a:latin typeface="Microsoft YaHei"/>
+                <a:ea typeface="Microsoft YaHei"/>
+                <a:cs typeface="Microsoft YaHei"/>
+              </a:rPr>
+              <a:t>• </a:t>
+            </a:r>
+            <a:r>
+              <a:rPr sz="919" b="0" i="0">
+                <a:solidFill>
+                  <a:srgbClr val="1B263B"/>
+                </a:solidFill>
+                <a:latin typeface="Microsoft YaHei"/>
+                <a:ea typeface="Microsoft YaHei"/>
+                <a:cs typeface="Microsoft YaHei"/>
+              </a:rPr>
+              <a:t>results/：CPU/GPU 曲线、gpu_summary、checkpoint 分析</a:t>
+            </a:r>
+          </a:p>
+        </p:txBody>
+      </p:sp>
+      <p:sp>
+        <p:nvSpPr>
+          <p:cNvPr id="20" name="Rounded Rectangle 19"/>
+          <p:cNvSpPr/>
+          <p:nvPr/>
+        </p:nvSpPr>
+        <p:spPr>
+          <a:xfrm>
+            <a:off x="6199632" y="3246120"/>
+            <a:ext cx="5349240" cy="2697480"/>
+          </a:xfrm>
+          <a:prstGeom prst="roundRect">
+            <a:avLst>
+              <a:gd name="adj" fmla="val 5000"/>
+            </a:avLst>
+          </a:prstGeom>
+          <a:solidFill>
+            <a:srgbClr val="ECF1F8"/>
+          </a:solidFill>
+          <a:ln w="9525">
+            <a:solidFill>
+              <a:srgbClr val="E2E7EE"/>
+            </a:solidFill>
+          </a:ln>
+          <a:effectLst/>
+        </p:spPr>
+        <p:style>
+          <a:lnRef idx="1">
+            <a:schemeClr val="accent1"/>
+          </a:lnRef>
+          <a:fillRef idx="3">
+            <a:schemeClr val="accent1"/>
+          </a:fillRef>
+          <a:effectRef idx="2">
+            <a:schemeClr val="accent1"/>
+          </a:effectRef>
+          <a:fontRef idx="minor">
+            <a:schemeClr val="lt1"/>
+          </a:fontRef>
+        </p:style>
+        <p:txBody>
+          <a:bodyPr rtlCol="0" anchor="ctr"/>
+          <a:lstStyle/>
+          <a:p>
+            <a:pPr algn="ctr"/>
+          </a:p>
+        </p:txBody>
+      </p:sp>
+      <p:sp>
+        <p:nvSpPr>
+          <p:cNvPr id="21" name="TextBox 20"/>
+          <p:cNvSpPr txBox="1"/>
+          <p:nvPr/>
+        </p:nvSpPr>
+        <p:spPr>
+          <a:xfrm>
+            <a:off x="6428232" y="3364992"/>
+            <a:ext cx="4937760" cy="274320"/>
           </a:xfrm>
           <a:prstGeom prst="rect">
             <a:avLst/>
@@ -18965,29 +20299,212 @@
               </a:lnSpc>
             </a:pPr>
             <a:r>
-              <a:rPr sz="1000" b="1" i="0">
-                <a:solidFill>
-                  <a:srgbClr val="8FA6C2"/>
-                </a:solidFill>
-                <a:latin typeface="Microsoft YaHei"/>
-                <a:ea typeface="Microsoft YaHei"/>
-                <a:cs typeface="Microsoft YaHei"/>
-              </a:rPr>
-              <a:t>上游代码</a:t>
-            </a:r>
-          </a:p>
-        </p:txBody>
-      </p:sp>
-      <p:sp>
-        <p:nvSpPr>
-          <p:cNvPr id="10" name="TextBox 9"/>
+              <a:rPr sz="1050" b="1" i="0">
+                <a:solidFill>
+                  <a:srgbClr val="0F1B2D"/>
+                </a:solidFill>
+                <a:latin typeface="Microsoft YaHei"/>
+                <a:ea typeface="Microsoft YaHei"/>
+                <a:cs typeface="Microsoft YaHei"/>
+              </a:rPr>
+              <a:t>如何复刻（本机已走通）</a:t>
+            </a:r>
+          </a:p>
+        </p:txBody>
+      </p:sp>
+      <p:sp>
+        <p:nvSpPr>
+          <p:cNvPr id="22" name="TextBox 21"/>
           <p:cNvSpPr txBox="1"/>
           <p:nvPr/>
         </p:nvSpPr>
         <p:spPr>
           <a:xfrm>
-            <a:off x="3200400" y="4352544"/>
-            <a:ext cx="7863840" cy="274320"/>
+            <a:off x="6428232" y="3675887"/>
+            <a:ext cx="4937760" cy="2103120"/>
+          </a:xfrm>
+          <a:prstGeom prst="rect">
+            <a:avLst/>
+          </a:prstGeom>
+          <a:noFill/>
+        </p:spPr>
+        <p:txBody>
+          <a:bodyPr wrap="square" lIns="0" rIns="0" tIns="0" bIns="0">
+            <a:spAutoFit/>
+          </a:bodyPr>
+          <a:lstStyle/>
+          <a:p>
+            <a:pPr marL="182880" indent="-182880">
+              <a:lnSpc>
+                <a:spcPct val="112000"/>
+              </a:lnSpc>
+              <a:spcAft>
+                <a:spcPts val="300"/>
+              </a:spcAft>
+            </a:pPr>
+            <a:r>
+              <a:rPr sz="919" b="0" i="0">
+                <a:solidFill>
+                  <a:srgbClr val="C97F1C"/>
+                </a:solidFill>
+                <a:latin typeface="Microsoft YaHei"/>
+                <a:ea typeface="Microsoft YaHei"/>
+                <a:cs typeface="Microsoft YaHei"/>
+              </a:rPr>
+              <a:t>• </a:t>
+            </a:r>
+            <a:r>
+              <a:rPr sz="919" b="0" i="0">
+                <a:solidFill>
+                  <a:srgbClr val="1B263B"/>
+                </a:solidFill>
+                <a:latin typeface="Microsoft YaHei"/>
+                <a:ea typeface="Microsoft YaHei"/>
+                <a:cs typeface="Microsoft YaHei"/>
+              </a:rPr>
+              <a:t>WSL2 + Ubuntu 24.04 + JAX 0.12(CUDA)：按 wsl_setup/ 脚本即可重建</a:t>
+            </a:r>
+          </a:p>
+          <a:p>
+            <a:pPr marL="182880" indent="-182880">
+              <a:lnSpc>
+                <a:spcPct val="112000"/>
+              </a:lnSpc>
+              <a:spcAft>
+                <a:spcPts val="300"/>
+              </a:spcAft>
+            </a:pPr>
+            <a:r>
+              <a:rPr sz="919" b="0" i="0">
+                <a:solidFill>
+                  <a:srgbClr val="C97F1C"/>
+                </a:solidFill>
+                <a:latin typeface="Microsoft YaHei"/>
+                <a:ea typeface="Microsoft YaHei"/>
+                <a:cs typeface="Microsoft YaHei"/>
+              </a:rPr>
+              <a:t>• </a:t>
+            </a:r>
+            <a:r>
+              <a:rPr sz="919" b="0" i="0">
+                <a:solidFill>
+                  <a:srgbClr val="1B263B"/>
+                </a:solidFill>
+                <a:latin typeface="Microsoft YaHei"/>
+                <a:ea typeface="Microsoft YaHei"/>
+                <a:cs typeface="Microsoft YaHei"/>
+              </a:rPr>
+              <a:t>单任务：2.3–2.5 h（RTX 5070，含 31 次×50 episodes 评估）</a:t>
+            </a:r>
+          </a:p>
+          <a:p>
+            <a:pPr marL="182880" indent="-182880">
+              <a:lnSpc>
+                <a:spcPct val="112000"/>
+              </a:lnSpc>
+              <a:spcAft>
+                <a:spcPts val="300"/>
+              </a:spcAft>
+            </a:pPr>
+            <a:r>
+              <a:rPr sz="919" b="0" i="0">
+                <a:solidFill>
+                  <a:srgbClr val="C97F1C"/>
+                </a:solidFill>
+                <a:latin typeface="Microsoft YaHei"/>
+                <a:ea typeface="Microsoft YaHei"/>
+                <a:cs typeface="Microsoft YaHei"/>
+              </a:rPr>
+              <a:t>• </a:t>
+            </a:r>
+            <a:r>
+              <a:rPr sz="919" b="0" i="0">
+                <a:solidFill>
+                  <a:srgbClr val="1B263B"/>
+                </a:solidFill>
+                <a:latin typeface="Microsoft YaHei"/>
+                <a:ea typeface="Microsoft YaHei"/>
+                <a:cs typeface="Microsoft YaHei"/>
+              </a:rPr>
+              <a:t>OGBench 7 任务约 17–20 h；全量 55 任务约 5–9 天（单卡）</a:t>
+            </a:r>
+          </a:p>
+          <a:p>
+            <a:pPr marL="182880" indent="-182880">
+              <a:lnSpc>
+                <a:spcPct val="112000"/>
+              </a:lnSpc>
+              <a:spcAft>
+                <a:spcPts val="300"/>
+              </a:spcAft>
+            </a:pPr>
+            <a:r>
+              <a:rPr sz="919" b="0" i="0">
+                <a:solidFill>
+                  <a:srgbClr val="C97F1C"/>
+                </a:solidFill>
+                <a:latin typeface="Microsoft YaHei"/>
+                <a:ea typeface="Microsoft YaHei"/>
+                <a:cs typeface="Microsoft YaHei"/>
+              </a:rPr>
+              <a:t>• </a:t>
+            </a:r>
+            <a:r>
+              <a:rPr sz="919" b="0" i="0">
+                <a:solidFill>
+                  <a:srgbClr val="1B263B"/>
+                </a:solidFill>
+                <a:latin typeface="Microsoft YaHei"/>
+                <a:ea typeface="Microsoft YaHei"/>
+                <a:cs typeface="Microsoft YaHei"/>
+              </a:rPr>
+              <a:t>验收：eval.csv 最终 success 与论文表格对比</a:t>
+            </a:r>
+          </a:p>
+          <a:p>
+            <a:pPr marL="182880" indent="-182880">
+              <a:lnSpc>
+                <a:spcPct val="112000"/>
+              </a:lnSpc>
+              <a:spcAft>
+                <a:spcPts val="300"/>
+              </a:spcAft>
+            </a:pPr>
+            <a:r>
+              <a:rPr sz="919" b="0" i="0">
+                <a:solidFill>
+                  <a:srgbClr val="C97F1C"/>
+                </a:solidFill>
+                <a:latin typeface="Microsoft YaHei"/>
+                <a:ea typeface="Microsoft YaHei"/>
+                <a:cs typeface="Microsoft YaHei"/>
+              </a:rPr>
+              <a:t>• </a:t>
+            </a:r>
+            <a:r>
+              <a:rPr sz="919" b="0" i="0">
+                <a:solidFill>
+                  <a:srgbClr val="1B263B"/>
+                </a:solidFill>
+                <a:latin typeface="Microsoft YaHei"/>
+                <a:ea typeface="Microsoft YaHei"/>
+                <a:cs typeface="Microsoft YaHei"/>
+              </a:rPr>
+              <a:t>扩展任务（humanoidmaze-medium / cube-double）正在 GPU 上运行</a:t>
+            </a:r>
+          </a:p>
+        </p:txBody>
+      </p:sp>
+      <p:sp>
+        <p:nvSpPr>
+          <p:cNvPr id="23" name="TextBox 22"/>
+          <p:cNvSpPr txBox="1"/>
+          <p:nvPr/>
+        </p:nvSpPr>
+        <p:spPr>
+          <a:xfrm>
+            <a:off x="640080" y="6053328"/>
+            <a:ext cx="10881360" cy="274320"/>
           </a:xfrm>
           <a:prstGeom prst="rect">
             <a:avLst/>
@@ -19006,29 +20523,84 @@
               </a:lnSpc>
             </a:pPr>
             <a:r>
-              <a:rPr sz="1050" b="0" i="0">
-                <a:solidFill>
-                  <a:srgbClr val="E6ECF5"/>
-                </a:solidFill>
-                <a:latin typeface="Microsoft YaHei"/>
-                <a:ea typeface="Microsoft YaHei"/>
-                <a:cs typeface="Microsoft YaHei"/>
-              </a:rPr>
-              <a:t>github.com/CTID282/FINO</a:t>
-            </a:r>
-          </a:p>
-        </p:txBody>
-      </p:sp>
-      <p:sp>
-        <p:nvSpPr>
-          <p:cNvPr id="11" name="TextBox 10"/>
+              <a:rPr sz="1019" b="1" i="0">
+                <a:solidFill>
+                  <a:srgbClr val="C97F1C"/>
+                </a:solidFill>
+                <a:latin typeface="Microsoft YaHei"/>
+                <a:ea typeface="Microsoft YaHei"/>
+                <a:cs typeface="Microsoft YaHei"/>
+              </a:rPr>
+              <a:t>一句话总结：</a:t>
+            </a:r>
+            <a:r>
+              <a:rPr sz="1019" b="0" i="0">
+                <a:solidFill>
+                  <a:srgbClr val="1B263B"/>
+                </a:solidFill>
+                <a:latin typeface="Microsoft YaHei"/>
+                <a:ea typeface="Microsoft YaHei"/>
+                <a:cs typeface="Microsoft YaHei"/>
+              </a:rPr>
+              <a:t>复现从"受限环境跑通"推进到"论文级结果对齐"（antmaze-large 100% vs 92%），并可扩展到更多任务。</a:t>
+            </a:r>
+          </a:p>
+        </p:txBody>
+      </p:sp>
+      <p:sp>
+        <p:nvSpPr>
+          <p:cNvPr id="24" name="Rectangle 23"/>
+          <p:cNvSpPr/>
+          <p:nvPr/>
+        </p:nvSpPr>
+        <p:spPr>
+          <a:xfrm>
+            <a:off x="640080" y="6391656"/>
+            <a:ext cx="10911535" cy="9144"/>
+          </a:xfrm>
+          <a:prstGeom prst="rect">
+            <a:avLst/>
+          </a:prstGeom>
+          <a:solidFill>
+            <a:srgbClr val="E7EBF2"/>
+          </a:solidFill>
+          <a:ln>
+            <a:noFill/>
+          </a:ln>
+          <a:effectLst/>
+        </p:spPr>
+        <p:style>
+          <a:lnRef idx="1">
+            <a:schemeClr val="accent1"/>
+          </a:lnRef>
+          <a:fillRef idx="3">
+            <a:schemeClr val="accent1"/>
+          </a:fillRef>
+          <a:effectRef idx="2">
+            <a:schemeClr val="accent1"/>
+          </a:effectRef>
+          <a:fontRef idx="minor">
+            <a:schemeClr val="lt1"/>
+          </a:fontRef>
+        </p:style>
+        <p:txBody>
+          <a:bodyPr rtlCol="0" anchor="ctr"/>
+          <a:lstStyle/>
+          <a:p>
+            <a:pPr algn="ctr"/>
+          </a:p>
+        </p:txBody>
+      </p:sp>
+      <p:sp>
+        <p:nvSpPr>
+          <p:cNvPr id="25" name="TextBox 24"/>
           <p:cNvSpPr txBox="1"/>
           <p:nvPr/>
         </p:nvSpPr>
         <p:spPr>
           <a:xfrm>
-            <a:off x="1097280" y="4700016"/>
-            <a:ext cx="2011680" cy="274320"/>
+            <a:off x="640080" y="6455664"/>
+            <a:ext cx="7772400" cy="219456"/>
           </a:xfrm>
           <a:prstGeom prst="rect">
             <a:avLst/>
@@ -19047,29 +20619,29 @@
               </a:lnSpc>
             </a:pPr>
             <a:r>
-              <a:rPr sz="1000" b="1" i="0">
-                <a:solidFill>
-                  <a:srgbClr val="8FA6C2"/>
-                </a:solidFill>
-                <a:latin typeface="Microsoft YaHei"/>
-                <a:ea typeface="Microsoft YaHei"/>
-                <a:cs typeface="Microsoft YaHei"/>
-              </a:rPr>
-              <a:t>复现报告</a:t>
-            </a:r>
-          </a:p>
-        </p:txBody>
-      </p:sp>
-      <p:sp>
-        <p:nvSpPr>
-          <p:cNvPr id="12" name="TextBox 11"/>
+              <a:rPr sz="850" b="0" i="0">
+                <a:solidFill>
+                  <a:srgbClr val="7F8CA3"/>
+                </a:solidFill>
+                <a:latin typeface="Microsoft YaHei"/>
+                <a:ea typeface="Microsoft YaHei"/>
+                <a:cs typeface="Microsoft YaHei"/>
+              </a:rPr>
+              <a:t>FINO 复现项目 · ICLR 2026 · engulf408/FINO</a:t>
+            </a:r>
+          </a:p>
+        </p:txBody>
+      </p:sp>
+      <p:sp>
+        <p:nvSpPr>
+          <p:cNvPr id="26" name="TextBox 25"/>
           <p:cNvSpPr txBox="1"/>
           <p:nvPr/>
         </p:nvSpPr>
         <p:spPr>
           <a:xfrm>
-            <a:off x="3200400" y="4700016"/>
-            <a:ext cx="7863840" cy="274320"/>
+            <a:off x="11048695" y="6455664"/>
+            <a:ext cx="502920" cy="219456"/>
           </a:xfrm>
           <a:prstGeom prst="rect">
             <a:avLst/>
@@ -19082,226 +20654,21 @@
           </a:bodyPr>
           <a:lstStyle/>
           <a:p>
-            <a:pPr algn="l">
+            <a:pPr algn="r">
               <a:lnSpc>
                 <a:spcPct val="108000"/>
               </a:lnSpc>
             </a:pPr>
             <a:r>
-              <a:rPr sz="1050" b="0" i="0">
-                <a:solidFill>
-                  <a:srgbClr val="E6ECF5"/>
-                </a:solidFill>
-                <a:latin typeface="Microsoft YaHei"/>
-                <a:ea typeface="Microsoft YaHei"/>
-                <a:cs typeface="Microsoft YaHei"/>
-              </a:rPr>
-              <a:t>docs/02_reproduction_report.md</a:t>
-            </a:r>
-          </a:p>
-        </p:txBody>
-      </p:sp>
-      <p:sp>
-        <p:nvSpPr>
-          <p:cNvPr id="13" name="TextBox 12"/>
-          <p:cNvSpPr txBox="1"/>
-          <p:nvPr/>
-        </p:nvSpPr>
-        <p:spPr>
-          <a:xfrm>
-            <a:off x="1097280" y="5047488"/>
-            <a:ext cx="2011680" cy="274320"/>
-          </a:xfrm>
-          <a:prstGeom prst="rect">
-            <a:avLst/>
-          </a:prstGeom>
-          <a:noFill/>
-        </p:spPr>
-        <p:txBody>
-          <a:bodyPr wrap="square" lIns="0" rIns="0" tIns="0" bIns="0" anchor="t">
-            <a:spAutoFit/>
-          </a:bodyPr>
-          <a:lstStyle/>
-          <a:p>
-            <a:pPr algn="l">
-              <a:lnSpc>
-                <a:spcPct val="108000"/>
-              </a:lnSpc>
-            </a:pPr>
-            <a:r>
-              <a:rPr sz="1000" b="1" i="0">
-                <a:solidFill>
-                  <a:srgbClr val="8FA6C2"/>
-                </a:solidFill>
-                <a:latin typeface="Microsoft YaHei"/>
-                <a:ea typeface="Microsoft YaHei"/>
-                <a:cs typeface="Microsoft YaHei"/>
-              </a:rPr>
-              <a:t>源码分析 / 补丁</a:t>
-            </a:r>
-          </a:p>
-        </p:txBody>
-      </p:sp>
-      <p:sp>
-        <p:nvSpPr>
-          <p:cNvPr id="14" name="TextBox 13"/>
-          <p:cNvSpPr txBox="1"/>
-          <p:nvPr/>
-        </p:nvSpPr>
-        <p:spPr>
-          <a:xfrm>
-            <a:off x="3200400" y="5047488"/>
-            <a:ext cx="7863840" cy="274320"/>
-          </a:xfrm>
-          <a:prstGeom prst="rect">
-            <a:avLst/>
-          </a:prstGeom>
-          <a:noFill/>
-        </p:spPr>
-        <p:txBody>
-          <a:bodyPr wrap="square" lIns="0" rIns="0" tIns="0" bIns="0" anchor="t">
-            <a:spAutoFit/>
-          </a:bodyPr>
-          <a:lstStyle/>
-          <a:p>
-            <a:pPr algn="l">
-              <a:lnSpc>
-                <a:spcPct val="108000"/>
-              </a:lnSpc>
-            </a:pPr>
-            <a:r>
-              <a:rPr sz="1050" b="0" i="0">
-                <a:solidFill>
-                  <a:srgbClr val="E6ECF5"/>
-                </a:solidFill>
-                <a:latin typeface="Microsoft YaHei"/>
-                <a:ea typeface="Microsoft YaHei"/>
-                <a:cs typeface="Microsoft YaHei"/>
-              </a:rPr>
-              <a:t>docs/01_code_analysis.md · docs/patches.diff</a:t>
-            </a:r>
-          </a:p>
-        </p:txBody>
-      </p:sp>
-      <p:sp>
-        <p:nvSpPr>
-          <p:cNvPr id="15" name="TextBox 14"/>
-          <p:cNvSpPr txBox="1"/>
-          <p:nvPr/>
-        </p:nvSpPr>
-        <p:spPr>
-          <a:xfrm>
-            <a:off x="1097280" y="5394959"/>
-            <a:ext cx="2011680" cy="274320"/>
-          </a:xfrm>
-          <a:prstGeom prst="rect">
-            <a:avLst/>
-          </a:prstGeom>
-          <a:noFill/>
-        </p:spPr>
-        <p:txBody>
-          <a:bodyPr wrap="square" lIns="0" rIns="0" tIns="0" bIns="0" anchor="t">
-            <a:spAutoFit/>
-          </a:bodyPr>
-          <a:lstStyle/>
-          <a:p>
-            <a:pPr algn="l">
-              <a:lnSpc>
-                <a:spcPct val="108000"/>
-              </a:lnSpc>
-            </a:pPr>
-            <a:r>
-              <a:rPr sz="1000" b="1" i="0">
-                <a:solidFill>
-                  <a:srgbClr val="8FA6C2"/>
-                </a:solidFill>
-                <a:latin typeface="Microsoft YaHei"/>
-                <a:ea typeface="Microsoft YaHei"/>
-                <a:cs typeface="Microsoft YaHei"/>
-              </a:rPr>
-              <a:t>机制验证</a:t>
-            </a:r>
-          </a:p>
-        </p:txBody>
-      </p:sp>
-      <p:sp>
-        <p:nvSpPr>
-          <p:cNvPr id="16" name="TextBox 15"/>
-          <p:cNvSpPr txBox="1"/>
-          <p:nvPr/>
-        </p:nvSpPr>
-        <p:spPr>
-          <a:xfrm>
-            <a:off x="3200400" y="5394959"/>
-            <a:ext cx="7863840" cy="274320"/>
-          </a:xfrm>
-          <a:prstGeom prst="rect">
-            <a:avLst/>
-          </a:prstGeom>
-          <a:noFill/>
-        </p:spPr>
-        <p:txBody>
-          <a:bodyPr wrap="square" lIns="0" rIns="0" tIns="0" bIns="0" anchor="t">
-            <a:spAutoFit/>
-          </a:bodyPr>
-          <a:lstStyle/>
-          <a:p>
-            <a:pPr algn="l">
-              <a:lnSpc>
-                <a:spcPct val="108000"/>
-              </a:lnSpc>
-            </a:pPr>
-            <a:r>
-              <a:rPr sz="1050" b="0" i="0">
-                <a:solidFill>
-                  <a:srgbClr val="E6ECF5"/>
-                </a:solidFill>
-                <a:latin typeface="Microsoft YaHei"/>
-                <a:ea typeface="Microsoft YaHei"/>
-                <a:cs typeface="Microsoft YaHei"/>
-              </a:rPr>
-              <a:t>experiments/toy/RESULTS.md</a:t>
-            </a:r>
-          </a:p>
-        </p:txBody>
-      </p:sp>
-      <p:sp>
-        <p:nvSpPr>
-          <p:cNvPr id="17" name="TextBox 16"/>
-          <p:cNvSpPr txBox="1"/>
-          <p:nvPr/>
-        </p:nvSpPr>
-        <p:spPr>
-          <a:xfrm>
-            <a:off x="822960" y="6080760"/>
-            <a:ext cx="10058400" cy="274320"/>
-          </a:xfrm>
-          <a:prstGeom prst="rect">
-            <a:avLst/>
-          </a:prstGeom>
-          <a:noFill/>
-        </p:spPr>
-        <p:txBody>
-          <a:bodyPr wrap="square" lIns="0" rIns="0" tIns="0" bIns="0" anchor="t">
-            <a:spAutoFit/>
-          </a:bodyPr>
-          <a:lstStyle/>
-          <a:p>
-            <a:pPr algn="l">
-              <a:lnSpc>
-                <a:spcPct val="108000"/>
-              </a:lnSpc>
-            </a:pPr>
-            <a:r>
-              <a:rPr sz="900" b="0" i="0">
-                <a:solidFill>
-                  <a:srgbClr val="6F829C"/>
-                </a:solidFill>
-                <a:latin typeface="Microsoft YaHei"/>
-                <a:ea typeface="Microsoft YaHei"/>
-                <a:cs typeface="Microsoft YaHei"/>
-              </a:rPr>
-              <a:t>FINO 复现项目 · 2026-10-21 · Windows 11 + CPU</a:t>
+              <a:rPr sz="900" b="1" i="0">
+                <a:solidFill>
+                  <a:srgbClr val="7F8CA3"/>
+                </a:solidFill>
+                <a:latin typeface="Microsoft YaHei"/>
+                <a:ea typeface="Microsoft YaHei"/>
+                <a:cs typeface="Microsoft YaHei"/>
+              </a:rPr>
+              <a:t>19</a:t>
             </a:r>
           </a:p>
         </p:txBody>
@@ -20868,6 +22235,693 @@
                 <a:cs typeface="Microsoft YaHei"/>
               </a:rPr>
               <a:t>2</a:t>
+            </a:r>
+          </a:p>
+        </p:txBody>
+      </p:sp>
+    </p:spTree>
+  </p:cSld>
+  <p:clrMapOvr>
+    <a:masterClrMapping/>
+  </p:clrMapOvr>
+</p:sld>
+</file>
+
+<file path=ppt/slides/slide20.xml><?xml version="1.0" encoding="utf-8"?>
+<p:sld xmlns:a="http://schemas.openxmlformats.org/drawingml/2006/main" xmlns:p="http://schemas.openxmlformats.org/presentationml/2006/main" xmlns:r="http://schemas.openxmlformats.org/officeDocument/2006/relationships">
+  <p:cSld>
+    <p:spTree>
+      <p:nvGrpSpPr>
+        <p:cNvPr id="1" name=""/>
+        <p:cNvGrpSpPr/>
+        <p:nvPr/>
+      </p:nvGrpSpPr>
+      <p:grpSpPr/>
+      <p:sp>
+        <p:nvSpPr>
+          <p:cNvPr id="2" name="Rectangle 1"/>
+          <p:cNvSpPr/>
+          <p:nvPr/>
+        </p:nvSpPr>
+        <p:spPr>
+          <a:xfrm>
+            <a:off x="0" y="0"/>
+            <a:ext cx="12191695" cy="6858000"/>
+          </a:xfrm>
+          <a:prstGeom prst="rect">
+            <a:avLst/>
+          </a:prstGeom>
+          <a:solidFill>
+            <a:srgbClr val="0F1B2D"/>
+          </a:solidFill>
+          <a:ln>
+            <a:noFill/>
+          </a:ln>
+          <a:effectLst/>
+        </p:spPr>
+        <p:style>
+          <a:lnRef idx="1">
+            <a:schemeClr val="accent1"/>
+          </a:lnRef>
+          <a:fillRef idx="3">
+            <a:schemeClr val="accent1"/>
+          </a:fillRef>
+          <a:effectRef idx="2">
+            <a:schemeClr val="accent1"/>
+          </a:effectRef>
+          <a:fontRef idx="minor">
+            <a:schemeClr val="lt1"/>
+          </a:fontRef>
+        </p:style>
+        <p:txBody>
+          <a:bodyPr rtlCol="0" anchor="ctr"/>
+          <a:lstStyle/>
+          <a:p>
+            <a:pPr algn="ctr"/>
+          </a:p>
+        </p:txBody>
+      </p:sp>
+      <p:sp>
+        <p:nvSpPr>
+          <p:cNvPr id="3" name="Rectangle 2"/>
+          <p:cNvSpPr/>
+          <p:nvPr/>
+        </p:nvSpPr>
+        <p:spPr>
+          <a:xfrm>
+            <a:off x="822960" y="1417320"/>
+            <a:ext cx="1005840" cy="36576"/>
+          </a:xfrm>
+          <a:prstGeom prst="rect">
+            <a:avLst/>
+          </a:prstGeom>
+          <a:solidFill>
+            <a:srgbClr val="F2A33A"/>
+          </a:solidFill>
+          <a:ln>
+            <a:noFill/>
+          </a:ln>
+          <a:effectLst/>
+        </p:spPr>
+        <p:style>
+          <a:lnRef idx="1">
+            <a:schemeClr val="accent1"/>
+          </a:lnRef>
+          <a:fillRef idx="3">
+            <a:schemeClr val="accent1"/>
+          </a:fillRef>
+          <a:effectRef idx="2">
+            <a:schemeClr val="accent1"/>
+          </a:effectRef>
+          <a:fontRef idx="minor">
+            <a:schemeClr val="lt1"/>
+          </a:fontRef>
+        </p:style>
+        <p:txBody>
+          <a:bodyPr rtlCol="0" anchor="ctr"/>
+          <a:lstStyle/>
+          <a:p>
+            <a:pPr algn="ctr"/>
+          </a:p>
+        </p:txBody>
+      </p:sp>
+      <p:sp>
+        <p:nvSpPr>
+          <p:cNvPr id="4" name="TextBox 3"/>
+          <p:cNvSpPr txBox="1"/>
+          <p:nvPr/>
+        </p:nvSpPr>
+        <p:spPr>
+          <a:xfrm>
+            <a:off x="822960" y="1737360"/>
+            <a:ext cx="7315200" cy="1097280"/>
+          </a:xfrm>
+          <a:prstGeom prst="rect">
+            <a:avLst/>
+          </a:prstGeom>
+          <a:noFill/>
+        </p:spPr>
+        <p:txBody>
+          <a:bodyPr wrap="square" lIns="0" rIns="0" tIns="0" bIns="0" anchor="t">
+            <a:spAutoFit/>
+          </a:bodyPr>
+          <a:lstStyle/>
+          <a:p>
+            <a:pPr algn="l">
+              <a:lnSpc>
+                <a:spcPct val="108000"/>
+              </a:lnSpc>
+            </a:pPr>
+            <a:r>
+              <a:rPr sz="5800" b="1" i="0">
+                <a:solidFill>
+                  <a:srgbClr val="FFFFFF"/>
+                </a:solidFill>
+                <a:latin typeface="Microsoft YaHei"/>
+                <a:ea typeface="Microsoft YaHei"/>
+                <a:cs typeface="Microsoft YaHei"/>
+              </a:rPr>
+              <a:t>谢谢</a:t>
+            </a:r>
+          </a:p>
+        </p:txBody>
+      </p:sp>
+      <p:sp>
+        <p:nvSpPr>
+          <p:cNvPr id="5" name="TextBox 4"/>
+          <p:cNvSpPr txBox="1"/>
+          <p:nvPr/>
+        </p:nvSpPr>
+        <p:spPr>
+          <a:xfrm>
+            <a:off x="822960" y="2880360"/>
+            <a:ext cx="7315200" cy="411480"/>
+          </a:xfrm>
+          <a:prstGeom prst="rect">
+            <a:avLst/>
+          </a:prstGeom>
+          <a:noFill/>
+        </p:spPr>
+        <p:txBody>
+          <a:bodyPr wrap="square" lIns="0" rIns="0" tIns="0" bIns="0" anchor="t">
+            <a:spAutoFit/>
+          </a:bodyPr>
+          <a:lstStyle/>
+          <a:p>
+            <a:pPr algn="l">
+              <a:lnSpc>
+                <a:spcPct val="108000"/>
+              </a:lnSpc>
+            </a:pPr>
+            <a:r>
+              <a:rPr sz="1800" b="0" i="0" spc="200">
+                <a:solidFill>
+                  <a:srgbClr val="9FB0C8"/>
+                </a:solidFill>
+                <a:latin typeface="Microsoft YaHei"/>
+                <a:ea typeface="Microsoft YaHei"/>
+                <a:cs typeface="Microsoft YaHei"/>
+              </a:rPr>
+              <a:t>Thanks · Q &amp; A</a:t>
+            </a:r>
+          </a:p>
+        </p:txBody>
+      </p:sp>
+      <p:sp>
+        <p:nvSpPr>
+          <p:cNvPr id="6" name="Rounded Rectangle 5"/>
+          <p:cNvSpPr/>
+          <p:nvPr/>
+        </p:nvSpPr>
+        <p:spPr>
+          <a:xfrm>
+            <a:off x="822960" y="3794760"/>
+            <a:ext cx="10515600" cy="2011680"/>
+          </a:xfrm>
+          <a:prstGeom prst="roundRect">
+            <a:avLst>
+              <a:gd name="adj" fmla="val 5000"/>
+            </a:avLst>
+          </a:prstGeom>
+          <a:solidFill>
+            <a:srgbClr val="162842"/>
+          </a:solidFill>
+          <a:ln w="9525">
+            <a:solidFill>
+              <a:srgbClr val="2A3D58"/>
+            </a:solidFill>
+          </a:ln>
+          <a:effectLst/>
+        </p:spPr>
+        <p:style>
+          <a:lnRef idx="1">
+            <a:schemeClr val="accent1"/>
+          </a:lnRef>
+          <a:fillRef idx="3">
+            <a:schemeClr val="accent1"/>
+          </a:fillRef>
+          <a:effectRef idx="2">
+            <a:schemeClr val="accent1"/>
+          </a:effectRef>
+          <a:fontRef idx="minor">
+            <a:schemeClr val="lt1"/>
+          </a:fontRef>
+        </p:style>
+        <p:txBody>
+          <a:bodyPr rtlCol="0" anchor="ctr"/>
+          <a:lstStyle/>
+          <a:p>
+            <a:pPr algn="ctr"/>
+          </a:p>
+        </p:txBody>
+      </p:sp>
+      <p:sp>
+        <p:nvSpPr>
+          <p:cNvPr id="7" name="TextBox 6"/>
+          <p:cNvSpPr txBox="1"/>
+          <p:nvPr/>
+        </p:nvSpPr>
+        <p:spPr>
+          <a:xfrm>
+            <a:off x="1097280" y="4005072"/>
+            <a:ext cx="2011680" cy="274320"/>
+          </a:xfrm>
+          <a:prstGeom prst="rect">
+            <a:avLst/>
+          </a:prstGeom>
+          <a:noFill/>
+        </p:spPr>
+        <p:txBody>
+          <a:bodyPr wrap="square" lIns="0" rIns="0" tIns="0" bIns="0" anchor="t">
+            <a:spAutoFit/>
+          </a:bodyPr>
+          <a:lstStyle/>
+          <a:p>
+            <a:pPr algn="l">
+              <a:lnSpc>
+                <a:spcPct val="108000"/>
+              </a:lnSpc>
+            </a:pPr>
+            <a:r>
+              <a:rPr sz="1000" b="1" i="0">
+                <a:solidFill>
+                  <a:srgbClr val="8FA6C2"/>
+                </a:solidFill>
+                <a:latin typeface="Microsoft YaHei"/>
+                <a:ea typeface="Microsoft YaHei"/>
+                <a:cs typeface="Microsoft YaHei"/>
+              </a:rPr>
+              <a:t>项目仓库</a:t>
+            </a:r>
+          </a:p>
+        </p:txBody>
+      </p:sp>
+      <p:sp>
+        <p:nvSpPr>
+          <p:cNvPr id="8" name="TextBox 7"/>
+          <p:cNvSpPr txBox="1"/>
+          <p:nvPr/>
+        </p:nvSpPr>
+        <p:spPr>
+          <a:xfrm>
+            <a:off x="3200400" y="4005072"/>
+            <a:ext cx="7863840" cy="274320"/>
+          </a:xfrm>
+          <a:prstGeom prst="rect">
+            <a:avLst/>
+          </a:prstGeom>
+          <a:noFill/>
+        </p:spPr>
+        <p:txBody>
+          <a:bodyPr wrap="square" lIns="0" rIns="0" tIns="0" bIns="0" anchor="t">
+            <a:spAutoFit/>
+          </a:bodyPr>
+          <a:lstStyle/>
+          <a:p>
+            <a:pPr algn="l">
+              <a:lnSpc>
+                <a:spcPct val="108000"/>
+              </a:lnSpc>
+            </a:pPr>
+            <a:r>
+              <a:rPr sz="1050" b="0" i="0">
+                <a:solidFill>
+                  <a:srgbClr val="E6ECF5"/>
+                </a:solidFill>
+                <a:latin typeface="Microsoft YaHei"/>
+                <a:ea typeface="Microsoft YaHei"/>
+                <a:cs typeface="Microsoft YaHei"/>
+              </a:rPr>
+              <a:t>github.com/engulf408/FINO</a:t>
+            </a:r>
+          </a:p>
+        </p:txBody>
+      </p:sp>
+      <p:sp>
+        <p:nvSpPr>
+          <p:cNvPr id="9" name="TextBox 8"/>
+          <p:cNvSpPr txBox="1"/>
+          <p:nvPr/>
+        </p:nvSpPr>
+        <p:spPr>
+          <a:xfrm>
+            <a:off x="1097280" y="4352544"/>
+            <a:ext cx="2011680" cy="274320"/>
+          </a:xfrm>
+          <a:prstGeom prst="rect">
+            <a:avLst/>
+          </a:prstGeom>
+          <a:noFill/>
+        </p:spPr>
+        <p:txBody>
+          <a:bodyPr wrap="square" lIns="0" rIns="0" tIns="0" bIns="0" anchor="t">
+            <a:spAutoFit/>
+          </a:bodyPr>
+          <a:lstStyle/>
+          <a:p>
+            <a:pPr algn="l">
+              <a:lnSpc>
+                <a:spcPct val="108000"/>
+              </a:lnSpc>
+            </a:pPr>
+            <a:r>
+              <a:rPr sz="1000" b="1" i="0">
+                <a:solidFill>
+                  <a:srgbClr val="8FA6C2"/>
+                </a:solidFill>
+                <a:latin typeface="Microsoft YaHei"/>
+                <a:ea typeface="Microsoft YaHei"/>
+                <a:cs typeface="Microsoft YaHei"/>
+              </a:rPr>
+              <a:t>上游代码</a:t>
+            </a:r>
+          </a:p>
+        </p:txBody>
+      </p:sp>
+      <p:sp>
+        <p:nvSpPr>
+          <p:cNvPr id="10" name="TextBox 9"/>
+          <p:cNvSpPr txBox="1"/>
+          <p:nvPr/>
+        </p:nvSpPr>
+        <p:spPr>
+          <a:xfrm>
+            <a:off x="3200400" y="4352544"/>
+            <a:ext cx="7863840" cy="274320"/>
+          </a:xfrm>
+          <a:prstGeom prst="rect">
+            <a:avLst/>
+          </a:prstGeom>
+          <a:noFill/>
+        </p:spPr>
+        <p:txBody>
+          <a:bodyPr wrap="square" lIns="0" rIns="0" tIns="0" bIns="0" anchor="t">
+            <a:spAutoFit/>
+          </a:bodyPr>
+          <a:lstStyle/>
+          <a:p>
+            <a:pPr algn="l">
+              <a:lnSpc>
+                <a:spcPct val="108000"/>
+              </a:lnSpc>
+            </a:pPr>
+            <a:r>
+              <a:rPr sz="1050" b="0" i="0">
+                <a:solidFill>
+                  <a:srgbClr val="E6ECF5"/>
+                </a:solidFill>
+                <a:latin typeface="Microsoft YaHei"/>
+                <a:ea typeface="Microsoft YaHei"/>
+                <a:cs typeface="Microsoft YaHei"/>
+              </a:rPr>
+              <a:t>github.com/CTID282/FINO</a:t>
+            </a:r>
+          </a:p>
+        </p:txBody>
+      </p:sp>
+      <p:sp>
+        <p:nvSpPr>
+          <p:cNvPr id="11" name="TextBox 10"/>
+          <p:cNvSpPr txBox="1"/>
+          <p:nvPr/>
+        </p:nvSpPr>
+        <p:spPr>
+          <a:xfrm>
+            <a:off x="1097280" y="4700016"/>
+            <a:ext cx="2011680" cy="274320"/>
+          </a:xfrm>
+          <a:prstGeom prst="rect">
+            <a:avLst/>
+          </a:prstGeom>
+          <a:noFill/>
+        </p:spPr>
+        <p:txBody>
+          <a:bodyPr wrap="square" lIns="0" rIns="0" tIns="0" bIns="0" anchor="t">
+            <a:spAutoFit/>
+          </a:bodyPr>
+          <a:lstStyle/>
+          <a:p>
+            <a:pPr algn="l">
+              <a:lnSpc>
+                <a:spcPct val="108000"/>
+              </a:lnSpc>
+            </a:pPr>
+            <a:r>
+              <a:rPr sz="1000" b="1" i="0">
+                <a:solidFill>
+                  <a:srgbClr val="8FA6C2"/>
+                </a:solidFill>
+                <a:latin typeface="Microsoft YaHei"/>
+                <a:ea typeface="Microsoft YaHei"/>
+                <a:cs typeface="Microsoft YaHei"/>
+              </a:rPr>
+              <a:t>复现报告</a:t>
+            </a:r>
+          </a:p>
+        </p:txBody>
+      </p:sp>
+      <p:sp>
+        <p:nvSpPr>
+          <p:cNvPr id="12" name="TextBox 11"/>
+          <p:cNvSpPr txBox="1"/>
+          <p:nvPr/>
+        </p:nvSpPr>
+        <p:spPr>
+          <a:xfrm>
+            <a:off x="3200400" y="4700016"/>
+            <a:ext cx="7863840" cy="274320"/>
+          </a:xfrm>
+          <a:prstGeom prst="rect">
+            <a:avLst/>
+          </a:prstGeom>
+          <a:noFill/>
+        </p:spPr>
+        <p:txBody>
+          <a:bodyPr wrap="square" lIns="0" rIns="0" tIns="0" bIns="0" anchor="t">
+            <a:spAutoFit/>
+          </a:bodyPr>
+          <a:lstStyle/>
+          <a:p>
+            <a:pPr algn="l">
+              <a:lnSpc>
+                <a:spcPct val="108000"/>
+              </a:lnSpc>
+            </a:pPr>
+            <a:r>
+              <a:rPr sz="1050" b="0" i="0">
+                <a:solidFill>
+                  <a:srgbClr val="E6ECF5"/>
+                </a:solidFill>
+                <a:latin typeface="Microsoft YaHei"/>
+                <a:ea typeface="Microsoft YaHei"/>
+                <a:cs typeface="Microsoft YaHei"/>
+              </a:rPr>
+              <a:t>docs/02_reproduction_report.md</a:t>
+            </a:r>
+          </a:p>
+        </p:txBody>
+      </p:sp>
+      <p:sp>
+        <p:nvSpPr>
+          <p:cNvPr id="13" name="TextBox 12"/>
+          <p:cNvSpPr txBox="1"/>
+          <p:nvPr/>
+        </p:nvSpPr>
+        <p:spPr>
+          <a:xfrm>
+            <a:off x="1097280" y="5047488"/>
+            <a:ext cx="2011680" cy="274320"/>
+          </a:xfrm>
+          <a:prstGeom prst="rect">
+            <a:avLst/>
+          </a:prstGeom>
+          <a:noFill/>
+        </p:spPr>
+        <p:txBody>
+          <a:bodyPr wrap="square" lIns="0" rIns="0" tIns="0" bIns="0" anchor="t">
+            <a:spAutoFit/>
+          </a:bodyPr>
+          <a:lstStyle/>
+          <a:p>
+            <a:pPr algn="l">
+              <a:lnSpc>
+                <a:spcPct val="108000"/>
+              </a:lnSpc>
+            </a:pPr>
+            <a:r>
+              <a:rPr sz="1000" b="1" i="0">
+                <a:solidFill>
+                  <a:srgbClr val="8FA6C2"/>
+                </a:solidFill>
+                <a:latin typeface="Microsoft YaHei"/>
+                <a:ea typeface="Microsoft YaHei"/>
+                <a:cs typeface="Microsoft YaHei"/>
+              </a:rPr>
+              <a:t>源码分析 / 补丁</a:t>
+            </a:r>
+          </a:p>
+        </p:txBody>
+      </p:sp>
+      <p:sp>
+        <p:nvSpPr>
+          <p:cNvPr id="14" name="TextBox 13"/>
+          <p:cNvSpPr txBox="1"/>
+          <p:nvPr/>
+        </p:nvSpPr>
+        <p:spPr>
+          <a:xfrm>
+            <a:off x="3200400" y="5047488"/>
+            <a:ext cx="7863840" cy="274320"/>
+          </a:xfrm>
+          <a:prstGeom prst="rect">
+            <a:avLst/>
+          </a:prstGeom>
+          <a:noFill/>
+        </p:spPr>
+        <p:txBody>
+          <a:bodyPr wrap="square" lIns="0" rIns="0" tIns="0" bIns="0" anchor="t">
+            <a:spAutoFit/>
+          </a:bodyPr>
+          <a:lstStyle/>
+          <a:p>
+            <a:pPr algn="l">
+              <a:lnSpc>
+                <a:spcPct val="108000"/>
+              </a:lnSpc>
+            </a:pPr>
+            <a:r>
+              <a:rPr sz="1050" b="0" i="0">
+                <a:solidFill>
+                  <a:srgbClr val="E6ECF5"/>
+                </a:solidFill>
+                <a:latin typeface="Microsoft YaHei"/>
+                <a:ea typeface="Microsoft YaHei"/>
+                <a:cs typeface="Microsoft YaHei"/>
+              </a:rPr>
+              <a:t>docs/01_code_analysis.md · docs/patches.diff</a:t>
+            </a:r>
+          </a:p>
+        </p:txBody>
+      </p:sp>
+      <p:sp>
+        <p:nvSpPr>
+          <p:cNvPr id="15" name="TextBox 14"/>
+          <p:cNvSpPr txBox="1"/>
+          <p:nvPr/>
+        </p:nvSpPr>
+        <p:spPr>
+          <a:xfrm>
+            <a:off x="1097280" y="5394959"/>
+            <a:ext cx="2011680" cy="274320"/>
+          </a:xfrm>
+          <a:prstGeom prst="rect">
+            <a:avLst/>
+          </a:prstGeom>
+          <a:noFill/>
+        </p:spPr>
+        <p:txBody>
+          <a:bodyPr wrap="square" lIns="0" rIns="0" tIns="0" bIns="0" anchor="t">
+            <a:spAutoFit/>
+          </a:bodyPr>
+          <a:lstStyle/>
+          <a:p>
+            <a:pPr algn="l">
+              <a:lnSpc>
+                <a:spcPct val="108000"/>
+              </a:lnSpc>
+            </a:pPr>
+            <a:r>
+              <a:rPr sz="1000" b="1" i="0">
+                <a:solidFill>
+                  <a:srgbClr val="8FA6C2"/>
+                </a:solidFill>
+                <a:latin typeface="Microsoft YaHei"/>
+                <a:ea typeface="Microsoft YaHei"/>
+                <a:cs typeface="Microsoft YaHei"/>
+              </a:rPr>
+              <a:t>机制验证</a:t>
+            </a:r>
+          </a:p>
+        </p:txBody>
+      </p:sp>
+      <p:sp>
+        <p:nvSpPr>
+          <p:cNvPr id="16" name="TextBox 15"/>
+          <p:cNvSpPr txBox="1"/>
+          <p:nvPr/>
+        </p:nvSpPr>
+        <p:spPr>
+          <a:xfrm>
+            <a:off x="3200400" y="5394959"/>
+            <a:ext cx="7863840" cy="274320"/>
+          </a:xfrm>
+          <a:prstGeom prst="rect">
+            <a:avLst/>
+          </a:prstGeom>
+          <a:noFill/>
+        </p:spPr>
+        <p:txBody>
+          <a:bodyPr wrap="square" lIns="0" rIns="0" tIns="0" bIns="0" anchor="t">
+            <a:spAutoFit/>
+          </a:bodyPr>
+          <a:lstStyle/>
+          <a:p>
+            <a:pPr algn="l">
+              <a:lnSpc>
+                <a:spcPct val="108000"/>
+              </a:lnSpc>
+            </a:pPr>
+            <a:r>
+              <a:rPr sz="1050" b="0" i="0">
+                <a:solidFill>
+                  <a:srgbClr val="E6ECF5"/>
+                </a:solidFill>
+                <a:latin typeface="Microsoft YaHei"/>
+                <a:ea typeface="Microsoft YaHei"/>
+                <a:cs typeface="Microsoft YaHei"/>
+              </a:rPr>
+              <a:t>experiments/toy/RESULTS.md</a:t>
+            </a:r>
+          </a:p>
+        </p:txBody>
+      </p:sp>
+      <p:sp>
+        <p:nvSpPr>
+          <p:cNvPr id="17" name="TextBox 16"/>
+          <p:cNvSpPr txBox="1"/>
+          <p:nvPr/>
+        </p:nvSpPr>
+        <p:spPr>
+          <a:xfrm>
+            <a:off x="822960" y="6080760"/>
+            <a:ext cx="10058400" cy="274320"/>
+          </a:xfrm>
+          <a:prstGeom prst="rect">
+            <a:avLst/>
+          </a:prstGeom>
+          <a:noFill/>
+        </p:spPr>
+        <p:txBody>
+          <a:bodyPr wrap="square" lIns="0" rIns="0" tIns="0" bIns="0" anchor="t">
+            <a:spAutoFit/>
+          </a:bodyPr>
+          <a:lstStyle/>
+          <a:p>
+            <a:pPr algn="l">
+              <a:lnSpc>
+                <a:spcPct val="108000"/>
+              </a:lnSpc>
+            </a:pPr>
+            <a:r>
+              <a:rPr sz="900" b="0" i="0">
+                <a:solidFill>
+                  <a:srgbClr val="6F829C"/>
+                </a:solidFill>
+                <a:latin typeface="Microsoft YaHei"/>
+                <a:ea typeface="Microsoft YaHei"/>
+                <a:cs typeface="Microsoft YaHei"/>
+              </a:rPr>
+              <a:t>FINO 复现项目 · 2026-10-21 · Windows 11 + CPU</a:t>
             </a:r>
           </a:p>
         </p:txBody>

</xml_diff>

<commit_message>
Add formula-logic ablations and course decks: paper Eq.(7) noise schedule collapses (0.04 vs 1.00), official exponential schedule best, beta sign impact small (0.94 vs 0.96); add ablation docs/results/code patches, RL and optimization course PPTs
</commit_message>
<xml_diff>
--- a/ppt/FINO复现工作与结果分析.pptx
+++ b/ppt/FINO复现工作与结果分析.pptx
@@ -25,6 +25,7 @@
     <p:sldId id="273" r:id="rId25"/>
     <p:sldId id="274" r:id="rId26"/>
     <p:sldId id="275" r:id="rId27"/>
+    <p:sldId id="276" r:id="rId28"/>
   </p:sldIdLst>
   <p:sldSz cx="12191695" cy="6858000" type="screen4x3"/>
   <p:notesSz cx="6858000" cy="9144000"/>
@@ -1317,6 +1318,76 @@
 </file>
 
 <file path=ppt/notesSlides/notesSlide20.xml><?xml version="1.0" encoding="utf-8"?>
+<p:notes xmlns:a="http://schemas.openxmlformats.org/drawingml/2006/main" xmlns:p="http://schemas.openxmlformats.org/presentationml/2006/main" xmlns:r="http://schemas.openxmlformats.org/officeDocument/2006/relationships">
+  <p:cSld>
+    <p:spTree>
+      <p:nvGrpSpPr>
+        <p:cNvPr id="1" name=""/>
+        <p:cNvGrpSpPr/>
+        <p:nvPr/>
+      </p:nvGrpSpPr>
+      <p:grpSpPr>
+        <a:xfrm>
+          <a:off x="0" y="0"/>
+          <a:ext cx="0" cy="0"/>
+          <a:chOff x="0" y="0"/>
+          <a:chExt cx="0" cy="0"/>
+        </a:xfrm>
+      </p:grpSpPr>
+      <p:sp>
+        <p:nvSpPr>
+          <p:cNvPr id="2" name="Slide Image Placeholder 1"/>
+          <p:cNvSpPr>
+            <a:spLocks noGrp="1"/>
+          </p:cNvSpPr>
+          <p:nvPr>
+            <p:ph type="sldImg" idx="2"/>
+          </p:nvPr>
+        </p:nvSpPr>
+        <p:spPr/>
+      </p:sp>
+      <p:sp>
+        <p:nvSpPr>
+          <p:cNvPr id="3" name="Notes Placeholder 2"/>
+          <p:cNvSpPr>
+            <a:spLocks noGrp="1"/>
+          </p:cNvSpPr>
+          <p:nvPr>
+            <p:ph type="body" idx="3" sz="quarter"/>
+          </p:nvPr>
+        </p:nvSpPr>
+        <p:spPr/>
+        <p:txBody>
+          <a:bodyPr/>
+          <a:lstStyle/>
+          <a:p>
+            <a:r>
+              <a:t>扩展任务结果：FINO 在 humanoidmaze-medium 与 antmaze-large 都达到 100%，cube-double-play 72%（峰值 92%）；与 antmaze 的 FQL 对比一起，构成 3 个 OGBench 任务的全预算证据。</a:t>
+            </a:r>
+          </a:p>
+        </p:txBody>
+      </p:sp>
+      <p:sp>
+        <p:nvSpPr>
+          <p:cNvPr id="4" name="Slide Number Placeholder 3"/>
+          <p:cNvSpPr>
+            <a:spLocks noGrp="1"/>
+          </p:cNvSpPr>
+          <p:nvPr>
+            <p:ph type="sldNum" idx="5" sz="quarter"/>
+          </p:nvPr>
+        </p:nvSpPr>
+        <p:spPr/>
+      </p:sp>
+    </p:spTree>
+  </p:cSld>
+  <p:clrMapOvr>
+    <a:masterClrMapping/>
+  </p:clrMapOvr>
+</p:notes>
+</file>
+
+<file path=ppt/notesSlides/notesSlide21.xml><?xml version="1.0" encoding="utf-8"?>
 <p:notes xmlns:a="http://schemas.openxmlformats.org/drawingml/2006/main" xmlns:p="http://schemas.openxmlformats.org/presentationml/2006/main" xmlns:r="http://schemas.openxmlformats.org/officeDocument/2006/relationships">
   <p:cSld>
     <p:spTree>
@@ -18281,7 +18352,7 @@
         </p:nvGraphicFramePr>
         <p:xfrm>
           <a:off x="6126480" y="1847088"/>
-          <a:ext cx="5212079" cy="2314040"/>
+          <a:ext cx="5212079" cy="2281732"/>
         </p:xfrm>
         <a:graphic>
           <a:graphicData uri="http://schemas.openxmlformats.org/drawingml/2006/table">
@@ -18398,7 +18469,7 @@
                   </a:tcPr>
                 </a:tc>
               </a:tr>
-              <a:tr h="416356">
+              <a:tr h="384048">
                 <a:tc>
                   <a:txBody>
                     <a:bodyPr wrap="square"/>
@@ -18452,7 +18523,7 @@
                           <a:ea typeface="Microsoft YaHei"/>
                           <a:cs typeface="Microsoft YaHei"/>
                         </a:rPr>
-                        <a:t>1 + 2 进行中</a:t>
+                        <a:t>3</a:t>
                       </a:r>
                     </a:p>
                   </a:txBody>
@@ -18486,7 +18557,7 @@
                           <a:ea typeface="Microsoft YaHei"/>
                           <a:cs typeface="Microsoft YaHei"/>
                         </a:rPr>
-                        <a:t>1/35；含进行中 ≈ 8.6%</a:t>
+                        <a:t>3/35 ≈ 8.6%</a:t>
                       </a:r>
                     </a:p>
                   </a:txBody>
@@ -19093,7 +19164,7 @@
                 <a:ea typeface="Microsoft YaHei"/>
                 <a:cs typeface="Microsoft YaHei"/>
               </a:rPr>
-              <a:t>cube-double-play / humanoidmaze-medium 已跑 ~75%（FINO），预计 19:10 前后完成</a:t>
+              <a:t>扩展任务已完成：cube-double-play 72%（峰值 92%）、humanoidmaze-medium 100%（FINO，全预算）</a:t>
             </a:r>
           </a:p>
           <a:p>
@@ -19125,7 +19196,7 @@
                 <a:ea typeface="Microsoft YaHei"/>
                 <a:cs typeface="Microsoft YaHei"/>
               </a:rPr>
-              <a:t>差距：45 任务中完整覆盖 1 个（≈2.2%）；补 3–5 任务 + 多 seed + 消融约需 50–100 GPU 小时，全量约 400–900 GPU 小时</a:t>
+              <a:t>差距：45 任务中 FINO 覆盖 3 个（≈6.7%，含进行中 8.6%）；补 3–5 任务 + 多 seed + 消融约需 50–100 GPU 小时，全量约 400–900 GPU 小时</a:t>
             </a:r>
           </a:p>
         </p:txBody>
@@ -19914,7 +19985,7 @@
                 <a:ea typeface="Microsoft YaHei"/>
                 <a:cs typeface="Microsoft YaHei"/>
               </a:rPr>
-              <a:t>antmaze-large 全预算：FINO 100% vs FQL 92%；单任务 2.3–2.5 h（GPU），方向与论文一致。</a:t>
+              <a:t>3 个 OGBench 任务全预算：antmaze-large 100%、humanoidmaze-medium 100%、cube-double-play 72%（FQL 对比 92%）。</a:t>
             </a:r>
           </a:p>
         </p:txBody>
@@ -20186,7 +20257,7 @@
                 <a:ea typeface="Microsoft YaHei"/>
                 <a:cs typeface="Microsoft YaHei"/>
               </a:rPr>
-              <a:t>gpu_exp/：全预算 FINO/FQL 的 CSV、flags、1M 步 checkpoint</a:t>
+              <a:t>gpu_exp/：4 条全预算运行（FINO×3、FQL×1）的 CSV/flags/checkpoint</a:t>
             </a:r>
           </a:p>
           <a:p>
@@ -22248,6 +22319,1699 @@
 </file>
 
 <file path=ppt/slides/slide20.xml><?xml version="1.0" encoding="utf-8"?>
+<p:sld xmlns:a="http://schemas.openxmlformats.org/drawingml/2006/main" xmlns:p="http://schemas.openxmlformats.org/presentationml/2006/main" xmlns:r="http://schemas.openxmlformats.org/officeDocument/2006/relationships">
+  <p:cSld>
+    <p:spTree>
+      <p:nvGrpSpPr>
+        <p:cNvPr id="1" name=""/>
+        <p:cNvGrpSpPr/>
+        <p:nvPr/>
+      </p:nvGrpSpPr>
+      <p:grpSpPr/>
+      <p:sp>
+        <p:nvSpPr>
+          <p:cNvPr id="2" name="Rectangle 1"/>
+          <p:cNvSpPr/>
+          <p:nvPr/>
+        </p:nvSpPr>
+        <p:spPr>
+          <a:xfrm>
+            <a:off x="0" y="0"/>
+            <a:ext cx="12191695" cy="109728"/>
+          </a:xfrm>
+          <a:prstGeom prst="rect">
+            <a:avLst/>
+          </a:prstGeom>
+          <a:solidFill>
+            <a:srgbClr val="0F1B2D"/>
+          </a:solidFill>
+          <a:ln>
+            <a:noFill/>
+          </a:ln>
+          <a:effectLst/>
+        </p:spPr>
+        <p:style>
+          <a:lnRef idx="1">
+            <a:schemeClr val="accent1"/>
+          </a:lnRef>
+          <a:fillRef idx="3">
+            <a:schemeClr val="accent1"/>
+          </a:fillRef>
+          <a:effectRef idx="2">
+            <a:schemeClr val="accent1"/>
+          </a:effectRef>
+          <a:fontRef idx="minor">
+            <a:schemeClr val="lt1"/>
+          </a:fontRef>
+        </p:style>
+        <p:txBody>
+          <a:bodyPr rtlCol="0" anchor="ctr"/>
+          <a:lstStyle/>
+          <a:p>
+            <a:pPr algn="ctr"/>
+          </a:p>
+        </p:txBody>
+      </p:sp>
+      <p:sp>
+        <p:nvSpPr>
+          <p:cNvPr id="3" name="TextBox 2"/>
+          <p:cNvSpPr txBox="1"/>
+          <p:nvPr/>
+        </p:nvSpPr>
+        <p:spPr>
+          <a:xfrm>
+            <a:off x="640080" y="310896"/>
+            <a:ext cx="8686800" cy="237744"/>
+          </a:xfrm>
+          <a:prstGeom prst="rect">
+            <a:avLst/>
+          </a:prstGeom>
+          <a:noFill/>
+        </p:spPr>
+        <p:txBody>
+          <a:bodyPr wrap="square" lIns="0" rIns="0" tIns="0" bIns="0" anchor="t">
+            <a:spAutoFit/>
+          </a:bodyPr>
+          <a:lstStyle/>
+          <a:p>
+            <a:pPr algn="l">
+              <a:lnSpc>
+                <a:spcPct val="108000"/>
+              </a:lnSpc>
+            </a:pPr>
+            <a:r>
+              <a:rPr sz="950" b="1" i="0" spc="120">
+                <a:solidFill>
+                  <a:srgbClr val="C97F1C"/>
+                </a:solidFill>
+                <a:latin typeface="Microsoft YaHei"/>
+                <a:ea typeface="Microsoft YaHei"/>
+                <a:cs typeface="Microsoft YaHei"/>
+              </a:rPr>
+              <a:t>05 · 扩展结果</a:t>
+            </a:r>
+          </a:p>
+        </p:txBody>
+      </p:sp>
+      <p:sp>
+        <p:nvSpPr>
+          <p:cNvPr id="4" name="TextBox 3"/>
+          <p:cNvSpPr txBox="1"/>
+          <p:nvPr/>
+        </p:nvSpPr>
+        <p:spPr>
+          <a:xfrm>
+            <a:off x="621792" y="512064"/>
+            <a:ext cx="10881360" cy="566928"/>
+          </a:xfrm>
+          <a:prstGeom prst="rect">
+            <a:avLst/>
+          </a:prstGeom>
+          <a:noFill/>
+        </p:spPr>
+        <p:txBody>
+          <a:bodyPr wrap="square" lIns="0" rIns="0" tIns="0" bIns="0" anchor="t">
+            <a:spAutoFit/>
+          </a:bodyPr>
+          <a:lstStyle/>
+          <a:p>
+            <a:pPr algn="l">
+              <a:lnSpc>
+                <a:spcPct val="108000"/>
+              </a:lnSpc>
+            </a:pPr>
+            <a:r>
+              <a:rPr sz="2500" b="1" i="0">
+                <a:solidFill>
+                  <a:srgbClr val="0F1B2D"/>
+                </a:solidFill>
+                <a:latin typeface="Microsoft YaHei"/>
+                <a:ea typeface="Microsoft YaHei"/>
+                <a:cs typeface="Microsoft YaHei"/>
+              </a:rPr>
+              <a:t>扩展任务：FINO 在 3 个 OGBench 任务上的全预算表现</a:t>
+            </a:r>
+          </a:p>
+        </p:txBody>
+      </p:sp>
+      <p:sp>
+        <p:nvSpPr>
+          <p:cNvPr id="5" name="Rectangle 4"/>
+          <p:cNvSpPr/>
+          <p:nvPr/>
+        </p:nvSpPr>
+        <p:spPr>
+          <a:xfrm>
+            <a:off x="640080" y="1129284"/>
+            <a:ext cx="475488" cy="41148"/>
+          </a:xfrm>
+          <a:prstGeom prst="rect">
+            <a:avLst/>
+          </a:prstGeom>
+          <a:solidFill>
+            <a:srgbClr val="F2A33A"/>
+          </a:solidFill>
+          <a:ln>
+            <a:noFill/>
+          </a:ln>
+          <a:effectLst/>
+        </p:spPr>
+        <p:style>
+          <a:lnRef idx="1">
+            <a:schemeClr val="accent1"/>
+          </a:lnRef>
+          <a:fillRef idx="3">
+            <a:schemeClr val="accent1"/>
+          </a:fillRef>
+          <a:effectRef idx="2">
+            <a:schemeClr val="accent1"/>
+          </a:effectRef>
+          <a:fontRef idx="minor">
+            <a:schemeClr val="lt1"/>
+          </a:fontRef>
+        </p:style>
+        <p:txBody>
+          <a:bodyPr rtlCol="0" anchor="ctr"/>
+          <a:lstStyle/>
+          <a:p>
+            <a:pPr algn="ctr"/>
+          </a:p>
+        </p:txBody>
+      </p:sp>
+      <p:sp>
+        <p:nvSpPr>
+          <p:cNvPr id="6" name="Rectangle 5"/>
+          <p:cNvSpPr/>
+          <p:nvPr/>
+        </p:nvSpPr>
+        <p:spPr>
+          <a:xfrm>
+            <a:off x="1188719" y="1145743"/>
+            <a:ext cx="10362895" cy="10972"/>
+          </a:xfrm>
+          <a:prstGeom prst="rect">
+            <a:avLst/>
+          </a:prstGeom>
+          <a:solidFill>
+            <a:srgbClr val="E2E7EE"/>
+          </a:solidFill>
+          <a:ln>
+            <a:noFill/>
+          </a:ln>
+          <a:effectLst/>
+        </p:spPr>
+        <p:style>
+          <a:lnRef idx="1">
+            <a:schemeClr val="accent1"/>
+          </a:lnRef>
+          <a:fillRef idx="3">
+            <a:schemeClr val="accent1"/>
+          </a:fillRef>
+          <a:effectRef idx="2">
+            <a:schemeClr val="accent1"/>
+          </a:effectRef>
+          <a:fontRef idx="minor">
+            <a:schemeClr val="lt1"/>
+          </a:fontRef>
+        </p:style>
+        <p:txBody>
+          <a:bodyPr rtlCol="0" anchor="ctr"/>
+          <a:lstStyle/>
+          <a:p>
+            <a:pPr algn="ctr"/>
+          </a:p>
+        </p:txBody>
+      </p:sp>
+      <p:sp>
+        <p:nvSpPr>
+          <p:cNvPr id="7" name="TextBox 6"/>
+          <p:cNvSpPr txBox="1"/>
+          <p:nvPr/>
+        </p:nvSpPr>
+        <p:spPr>
+          <a:xfrm>
+            <a:off x="11323015" y="310896"/>
+            <a:ext cx="457200" cy="219456"/>
+          </a:xfrm>
+          <a:prstGeom prst="rect">
+            <a:avLst/>
+          </a:prstGeom>
+          <a:noFill/>
+        </p:spPr>
+        <p:txBody>
+          <a:bodyPr wrap="square" lIns="0" rIns="0" tIns="0" bIns="0" anchor="t">
+            <a:spAutoFit/>
+          </a:bodyPr>
+          <a:lstStyle/>
+          <a:p>
+            <a:pPr algn="r">
+              <a:lnSpc>
+                <a:spcPct val="108000"/>
+              </a:lnSpc>
+            </a:pPr>
+            <a:r>
+              <a:rPr sz="1000" b="1" i="0">
+                <a:solidFill>
+                  <a:srgbClr val="B6BFCC"/>
+                </a:solidFill>
+                <a:latin typeface="Microsoft YaHei"/>
+                <a:ea typeface="Microsoft YaHei"/>
+                <a:cs typeface="Microsoft YaHei"/>
+              </a:rPr>
+              <a:t>20</a:t>
+            </a:r>
+          </a:p>
+        </p:txBody>
+      </p:sp>
+      <p:sp>
+        <p:nvSpPr>
+          <p:cNvPr id="8" name="Rectangle 7"/>
+          <p:cNvSpPr/>
+          <p:nvPr/>
+        </p:nvSpPr>
+        <p:spPr>
+          <a:xfrm>
+            <a:off x="793738" y="1307592"/>
+            <a:ext cx="6367802" cy="2276856"/>
+          </a:xfrm>
+          <a:prstGeom prst="rect">
+            <a:avLst/>
+          </a:prstGeom>
+          <a:solidFill>
+            <a:srgbClr val="FFFFFF"/>
+          </a:solidFill>
+          <a:ln w="9525">
+            <a:solidFill>
+              <a:srgbClr val="E2E7EE"/>
+            </a:solidFill>
+          </a:ln>
+          <a:effectLst/>
+        </p:spPr>
+        <p:style>
+          <a:lnRef idx="1">
+            <a:schemeClr val="accent1"/>
+          </a:lnRef>
+          <a:fillRef idx="3">
+            <a:schemeClr val="accent1"/>
+          </a:fillRef>
+          <a:effectRef idx="2">
+            <a:schemeClr val="accent1"/>
+          </a:effectRef>
+          <a:fontRef idx="minor">
+            <a:schemeClr val="lt1"/>
+          </a:fontRef>
+        </p:style>
+        <p:txBody>
+          <a:bodyPr rtlCol="0" anchor="ctr"/>
+          <a:lstStyle/>
+          <a:p>
+            <a:pPr algn="ctr"/>
+          </a:p>
+        </p:txBody>
+      </p:sp>
+      <p:pic>
+        <p:nvPicPr>
+          <p:cNvPr id="9" name="Picture 8" descr="fig_gpu_extended_curves.png"/>
+          <p:cNvPicPr>
+            <a:picLocks noChangeAspect="1"/>
+          </p:cNvPicPr>
+          <p:nvPr/>
+        </p:nvPicPr>
+        <p:blipFill>
+          <a:blip r:embed="rId2"/>
+          <a:stretch>
+            <a:fillRect/>
+          </a:stretch>
+        </p:blipFill>
+        <p:spPr>
+          <a:xfrm>
+            <a:off x="812026" y="1325880"/>
+            <a:ext cx="6331226" cy="2240280"/>
+          </a:xfrm>
+          <a:prstGeom prst="rect">
+            <a:avLst/>
+          </a:prstGeom>
+        </p:spPr>
+      </p:pic>
+      <p:sp>
+        <p:nvSpPr>
+          <p:cNvPr id="10" name="Rounded Rectangle 9"/>
+          <p:cNvSpPr/>
+          <p:nvPr/>
+        </p:nvSpPr>
+        <p:spPr>
+          <a:xfrm>
+            <a:off x="7498079" y="1325880"/>
+            <a:ext cx="4050791" cy="2240280"/>
+          </a:xfrm>
+          <a:prstGeom prst="roundRect">
+            <a:avLst>
+              <a:gd name="adj" fmla="val 5000"/>
+            </a:avLst>
+          </a:prstGeom>
+          <a:solidFill>
+            <a:srgbClr val="E9F5EE"/>
+          </a:solidFill>
+          <a:ln w="9525">
+            <a:solidFill>
+              <a:srgbClr val="C9E4D3"/>
+            </a:solidFill>
+          </a:ln>
+          <a:effectLst/>
+        </p:spPr>
+        <p:style>
+          <a:lnRef idx="1">
+            <a:schemeClr val="accent1"/>
+          </a:lnRef>
+          <a:fillRef idx="3">
+            <a:schemeClr val="accent1"/>
+          </a:fillRef>
+          <a:effectRef idx="2">
+            <a:schemeClr val="accent1"/>
+          </a:effectRef>
+          <a:fontRef idx="minor">
+            <a:schemeClr val="lt1"/>
+          </a:fontRef>
+        </p:style>
+        <p:txBody>
+          <a:bodyPr rtlCol="0" anchor="ctr"/>
+          <a:lstStyle/>
+          <a:p>
+            <a:pPr algn="ctr"/>
+          </a:p>
+        </p:txBody>
+      </p:sp>
+      <p:sp>
+        <p:nvSpPr>
+          <p:cNvPr id="11" name="TextBox 10"/>
+          <p:cNvSpPr txBox="1"/>
+          <p:nvPr/>
+        </p:nvSpPr>
+        <p:spPr>
+          <a:xfrm>
+            <a:off x="7726679" y="1444752"/>
+            <a:ext cx="3657600" cy="274320"/>
+          </a:xfrm>
+          <a:prstGeom prst="rect">
+            <a:avLst/>
+          </a:prstGeom>
+          <a:noFill/>
+        </p:spPr>
+        <p:txBody>
+          <a:bodyPr wrap="square" lIns="0" rIns="0" tIns="0" bIns="0" anchor="t">
+            <a:spAutoFit/>
+          </a:bodyPr>
+          <a:lstStyle/>
+          <a:p>
+            <a:pPr algn="l">
+              <a:lnSpc>
+                <a:spcPct val="108000"/>
+              </a:lnSpc>
+            </a:pPr>
+            <a:r>
+              <a:rPr sz="1050" b="1" i="0">
+                <a:solidFill>
+                  <a:srgbClr val="2E8B57"/>
+                </a:solidFill>
+                <a:latin typeface="Microsoft YaHei"/>
+                <a:ea typeface="Microsoft YaHei"/>
+                <a:cs typeface="Microsoft YaHei"/>
+              </a:rPr>
+              <a:t>关键数字</a:t>
+            </a:r>
+          </a:p>
+        </p:txBody>
+      </p:sp>
+      <p:sp>
+        <p:nvSpPr>
+          <p:cNvPr id="12" name="TextBox 11"/>
+          <p:cNvSpPr txBox="1"/>
+          <p:nvPr/>
+        </p:nvSpPr>
+        <p:spPr>
+          <a:xfrm>
+            <a:off x="7726679" y="1755648"/>
+            <a:ext cx="3657600" cy="1691640"/>
+          </a:xfrm>
+          <a:prstGeom prst="rect">
+            <a:avLst/>
+          </a:prstGeom>
+          <a:noFill/>
+        </p:spPr>
+        <p:txBody>
+          <a:bodyPr wrap="square" lIns="0" rIns="0" tIns="0" bIns="0">
+            <a:spAutoFit/>
+          </a:bodyPr>
+          <a:lstStyle/>
+          <a:p>
+            <a:pPr marL="182880" indent="-182880">
+              <a:lnSpc>
+                <a:spcPct val="112000"/>
+              </a:lnSpc>
+              <a:spcAft>
+                <a:spcPts val="200"/>
+              </a:spcAft>
+            </a:pPr>
+            <a:r>
+              <a:rPr sz="880" b="0" i="0">
+                <a:solidFill>
+                  <a:srgbClr val="2E8B57"/>
+                </a:solidFill>
+                <a:latin typeface="Microsoft YaHei"/>
+                <a:ea typeface="Microsoft YaHei"/>
+                <a:cs typeface="Microsoft YaHei"/>
+              </a:rPr>
+              <a:t>• </a:t>
+            </a:r>
+            <a:r>
+              <a:rPr sz="880" b="0" i="0">
+                <a:solidFill>
+                  <a:srgbClr val="1B263B"/>
+                </a:solidFill>
+                <a:latin typeface="Microsoft YaHei"/>
+                <a:ea typeface="Microsoft YaHei"/>
+                <a:cs typeface="Microsoft YaHei"/>
+              </a:rPr>
+              <a:t>antmaze-large：100%（FQL 92%）</a:t>
+            </a:r>
+          </a:p>
+          <a:p>
+            <a:pPr marL="182880" indent="-182880">
+              <a:lnSpc>
+                <a:spcPct val="112000"/>
+              </a:lnSpc>
+              <a:spcAft>
+                <a:spcPts val="200"/>
+              </a:spcAft>
+            </a:pPr>
+            <a:r>
+              <a:rPr sz="880" b="0" i="0">
+                <a:solidFill>
+                  <a:srgbClr val="2E8B57"/>
+                </a:solidFill>
+                <a:latin typeface="Microsoft YaHei"/>
+                <a:ea typeface="Microsoft YaHei"/>
+                <a:cs typeface="Microsoft YaHei"/>
+              </a:rPr>
+              <a:t>• </a:t>
+            </a:r>
+            <a:r>
+              <a:rPr sz="880" b="0" i="0">
+                <a:solidFill>
+                  <a:srgbClr val="1B263B"/>
+                </a:solidFill>
+                <a:latin typeface="Microsoft YaHei"/>
+                <a:ea typeface="Microsoft YaHei"/>
+                <a:cs typeface="Microsoft YaHei"/>
+              </a:rPr>
+              <a:t>humanoidmaze-medium：100%（峰值 100%）</a:t>
+            </a:r>
+          </a:p>
+          <a:p>
+            <a:pPr marL="182880" indent="-182880">
+              <a:lnSpc>
+                <a:spcPct val="112000"/>
+              </a:lnSpc>
+              <a:spcAft>
+                <a:spcPts val="200"/>
+              </a:spcAft>
+            </a:pPr>
+            <a:r>
+              <a:rPr sz="880" b="0" i="0">
+                <a:solidFill>
+                  <a:srgbClr val="2E8B57"/>
+                </a:solidFill>
+                <a:latin typeface="Microsoft YaHei"/>
+                <a:ea typeface="Microsoft YaHei"/>
+                <a:cs typeface="Microsoft YaHei"/>
+              </a:rPr>
+              <a:t>• </a:t>
+            </a:r>
+            <a:r>
+              <a:rPr sz="880" b="0" i="0">
+                <a:solidFill>
+                  <a:srgbClr val="1B263B"/>
+                </a:solidFill>
+                <a:latin typeface="Microsoft YaHei"/>
+                <a:ea typeface="Microsoft YaHei"/>
+                <a:cs typeface="Microsoft YaHei"/>
+              </a:rPr>
+              <a:t>cube-double-play：72%（峰值 92%，最后 5 次均值 84%）</a:t>
+            </a:r>
+          </a:p>
+          <a:p>
+            <a:pPr marL="182880" indent="-182880">
+              <a:lnSpc>
+                <a:spcPct val="112000"/>
+              </a:lnSpc>
+              <a:spcAft>
+                <a:spcPts val="200"/>
+              </a:spcAft>
+            </a:pPr>
+            <a:r>
+              <a:rPr sz="880" b="0" i="0">
+                <a:solidFill>
+                  <a:srgbClr val="2E8B57"/>
+                </a:solidFill>
+                <a:latin typeface="Microsoft YaHei"/>
+                <a:ea typeface="Microsoft YaHei"/>
+                <a:cs typeface="Microsoft YaHei"/>
+              </a:rPr>
+              <a:t>• </a:t>
+            </a:r>
+            <a:r>
+              <a:rPr sz="880" b="0" i="0">
+                <a:solidFill>
+                  <a:srgbClr val="1B263B"/>
+                </a:solidFill>
+                <a:latin typeface="Microsoft YaHei"/>
+                <a:ea typeface="Microsoft YaHei"/>
+                <a:cs typeface="Microsoft YaHei"/>
+              </a:rPr>
+              <a:t>3 个任务全部在论文预算下完成（1M 离线 + 500k 在线）</a:t>
+            </a:r>
+          </a:p>
+        </p:txBody>
+      </p:sp>
+      <p:sp>
+        <p:nvSpPr>
+          <p:cNvPr id="13" name="Rounded Rectangle 12"/>
+          <p:cNvSpPr/>
+          <p:nvPr/>
+        </p:nvSpPr>
+        <p:spPr>
+          <a:xfrm>
+            <a:off x="640080" y="3703320"/>
+            <a:ext cx="10908792" cy="2514600"/>
+          </a:xfrm>
+          <a:prstGeom prst="roundRect">
+            <a:avLst>
+              <a:gd name="adj" fmla="val 5000"/>
+            </a:avLst>
+          </a:prstGeom>
+          <a:solidFill>
+            <a:srgbClr val="F5F7FB"/>
+          </a:solidFill>
+          <a:ln w="9525">
+            <a:solidFill>
+              <a:srgbClr val="E2E7EE"/>
+            </a:solidFill>
+          </a:ln>
+          <a:effectLst/>
+        </p:spPr>
+        <p:style>
+          <a:lnRef idx="1">
+            <a:schemeClr val="accent1"/>
+          </a:lnRef>
+          <a:fillRef idx="3">
+            <a:schemeClr val="accent1"/>
+          </a:fillRef>
+          <a:effectRef idx="2">
+            <a:schemeClr val="accent1"/>
+          </a:effectRef>
+          <a:fontRef idx="minor">
+            <a:schemeClr val="lt1"/>
+          </a:fontRef>
+        </p:style>
+        <p:txBody>
+          <a:bodyPr rtlCol="0" anchor="ctr"/>
+          <a:lstStyle/>
+          <a:p>
+            <a:pPr algn="ctr"/>
+          </a:p>
+        </p:txBody>
+      </p:sp>
+      <p:sp>
+        <p:nvSpPr>
+          <p:cNvPr id="14" name="TextBox 13"/>
+          <p:cNvSpPr txBox="1"/>
+          <p:nvPr/>
+        </p:nvSpPr>
+        <p:spPr>
+          <a:xfrm>
+            <a:off x="868680" y="3803904"/>
+            <a:ext cx="10424160" cy="256032"/>
+          </a:xfrm>
+          <a:prstGeom prst="rect">
+            <a:avLst/>
+          </a:prstGeom>
+          <a:noFill/>
+        </p:spPr>
+        <p:txBody>
+          <a:bodyPr wrap="square" lIns="0" rIns="0" tIns="0" bIns="0" anchor="t">
+            <a:spAutoFit/>
+          </a:bodyPr>
+          <a:lstStyle/>
+          <a:p>
+            <a:pPr algn="l">
+              <a:lnSpc>
+                <a:spcPct val="108000"/>
+              </a:lnSpc>
+            </a:pPr>
+            <a:r>
+              <a:rPr sz="1050" b="1" i="0">
+                <a:solidFill>
+                  <a:srgbClr val="0F1B2D"/>
+                </a:solidFill>
+                <a:latin typeface="Microsoft YaHei"/>
+                <a:ea typeface="Microsoft YaHei"/>
+                <a:cs typeface="Microsoft YaHei"/>
+              </a:rPr>
+              <a:t>全预算结果汇总（FINO vs FQL；每任务 1.5M 步）</a:t>
+            </a:r>
+          </a:p>
+        </p:txBody>
+      </p:sp>
+      <p:graphicFrame>
+        <p:nvGraphicFramePr>
+          <p:cNvPr id="15" name="Table 14"/>
+          <p:cNvGraphicFramePr>
+            <a:graphicFrameLocks noGrp="1"/>
+          </p:cNvGraphicFramePr>
+          <p:nvPr/>
+        </p:nvGraphicFramePr>
+        <p:xfrm>
+          <a:off x="868680" y="4114800"/>
+          <a:ext cx="10378437" cy="1280769"/>
+        </p:xfrm>
+        <a:graphic>
+          <a:graphicData uri="http://schemas.openxmlformats.org/drawingml/2006/table">
+            <a:tbl>
+              <a:tblPr firstRow="1" bandRow="1">
+                <a:tableStyleId>{2D5ABB26-0587-4C30-8999-92F81FD0307C}</a:tableStyleId>
+              </a:tblPr>
+              <a:tblGrid>
+                <a:gridCol w="2698394"/>
+                <a:gridCol w="1037844"/>
+                <a:gridCol w="1452981"/>
+                <a:gridCol w="1245412"/>
+                <a:gridCol w="1660550"/>
+                <a:gridCol w="2283256"/>
+              </a:tblGrid>
+              <a:tr h="329184">
+                <a:tc>
+                  <a:txBody>
+                    <a:bodyPr wrap="square"/>
+                    <a:lstStyle/>
+                    <a:p>
+                      <a:pPr algn="l">
+                        <a:lnSpc>
+                          <a:spcPct val="100000"/>
+                        </a:lnSpc>
+                      </a:pPr>
+                      <a:r>
+                        <a:rPr sz="800" b="1" i="0">
+                          <a:solidFill>
+                            <a:srgbClr val="FFFFFF"/>
+                          </a:solidFill>
+                          <a:latin typeface="Microsoft YaHei"/>
+                          <a:ea typeface="Microsoft YaHei"/>
+                          <a:cs typeface="Microsoft YaHei"/>
+                        </a:rPr>
+                        <a:t>任务</a:t>
+                      </a:r>
+                    </a:p>
+                  </a:txBody>
+                  <a:tcPr marL="73152" marR="54864" marT="27432" marB="27432" anchor="ctr">
+                    <a:lnB w="9525" cap="flat" cmpd="sng" algn="ctr">
+                      <a:solidFill>
+                        <a:srgbClr val="E2E7EE"/>
+                      </a:solidFill>
+                    </a:lnB>
+                    <a:solidFill>
+                      <a:srgbClr val="0F1B2D"/>
+                    </a:solidFill>
+                  </a:tcPr>
+                </a:tc>
+                <a:tc>
+                  <a:txBody>
+                    <a:bodyPr wrap="square"/>
+                    <a:lstStyle/>
+                    <a:p>
+                      <a:pPr algn="ctr">
+                        <a:lnSpc>
+                          <a:spcPct val="100000"/>
+                        </a:lnSpc>
+                      </a:pPr>
+                      <a:r>
+                        <a:rPr sz="800" b="1" i="0">
+                          <a:solidFill>
+                            <a:srgbClr val="FFFFFF"/>
+                          </a:solidFill>
+                          <a:latin typeface="Microsoft YaHei"/>
+                          <a:ea typeface="Microsoft YaHei"/>
+                          <a:cs typeface="Microsoft YaHei"/>
+                        </a:rPr>
+                        <a:t>agent</a:t>
+                      </a:r>
+                    </a:p>
+                  </a:txBody>
+                  <a:tcPr marL="73152" marR="54864" marT="27432" marB="27432" anchor="ctr">
+                    <a:lnB w="9525" cap="flat" cmpd="sng" algn="ctr">
+                      <a:solidFill>
+                        <a:srgbClr val="E2E7EE"/>
+                      </a:solidFill>
+                    </a:lnB>
+                    <a:solidFill>
+                      <a:srgbClr val="0F1B2D"/>
+                    </a:solidFill>
+                  </a:tcPr>
+                </a:tc>
+                <a:tc>
+                  <a:txBody>
+                    <a:bodyPr wrap="square"/>
+                    <a:lstStyle/>
+                    <a:p>
+                      <a:pPr algn="ctr">
+                        <a:lnSpc>
+                          <a:spcPct val="100000"/>
+                        </a:lnSpc>
+                      </a:pPr>
+                      <a:r>
+                        <a:rPr sz="800" b="1" i="0">
+                          <a:solidFill>
+                            <a:srgbClr val="FFFFFF"/>
+                          </a:solidFill>
+                          <a:latin typeface="Microsoft YaHei"/>
+                          <a:ea typeface="Microsoft YaHei"/>
+                          <a:cs typeface="Microsoft YaHei"/>
+                        </a:rPr>
+                        <a:t>最终 success</a:t>
+                      </a:r>
+                    </a:p>
+                  </a:txBody>
+                  <a:tcPr marL="73152" marR="54864" marT="27432" marB="27432" anchor="ctr">
+                    <a:lnB w="9525" cap="flat" cmpd="sng" algn="ctr">
+                      <a:solidFill>
+                        <a:srgbClr val="E2E7EE"/>
+                      </a:solidFill>
+                    </a:lnB>
+                    <a:solidFill>
+                      <a:srgbClr val="0F1B2D"/>
+                    </a:solidFill>
+                  </a:tcPr>
+                </a:tc>
+                <a:tc>
+                  <a:txBody>
+                    <a:bodyPr wrap="square"/>
+                    <a:lstStyle/>
+                    <a:p>
+                      <a:pPr algn="ctr">
+                        <a:lnSpc>
+                          <a:spcPct val="100000"/>
+                        </a:lnSpc>
+                      </a:pPr>
+                      <a:r>
+                        <a:rPr sz="800" b="1" i="0">
+                          <a:solidFill>
+                            <a:srgbClr val="FFFFFF"/>
+                          </a:solidFill>
+                          <a:latin typeface="Microsoft YaHei"/>
+                          <a:ea typeface="Microsoft YaHei"/>
+                          <a:cs typeface="Microsoft YaHei"/>
+                        </a:rPr>
+                        <a:t>峰值</a:t>
+                      </a:r>
+                    </a:p>
+                  </a:txBody>
+                  <a:tcPr marL="73152" marR="54864" marT="27432" marB="27432" anchor="ctr">
+                    <a:lnB w="9525" cap="flat" cmpd="sng" algn="ctr">
+                      <a:solidFill>
+                        <a:srgbClr val="E2E7EE"/>
+                      </a:solidFill>
+                    </a:lnB>
+                    <a:solidFill>
+                      <a:srgbClr val="0F1B2D"/>
+                    </a:solidFill>
+                  </a:tcPr>
+                </a:tc>
+                <a:tc>
+                  <a:txBody>
+                    <a:bodyPr wrap="square"/>
+                    <a:lstStyle/>
+                    <a:p>
+                      <a:pPr algn="ctr">
+                        <a:lnSpc>
+                          <a:spcPct val="100000"/>
+                        </a:lnSpc>
+                      </a:pPr>
+                      <a:r>
+                        <a:rPr sz="800" b="1" i="0">
+                          <a:solidFill>
+                            <a:srgbClr val="FFFFFF"/>
+                          </a:solidFill>
+                          <a:latin typeface="Microsoft YaHei"/>
+                          <a:ea typeface="Microsoft YaHei"/>
+                          <a:cs typeface="Microsoft YaHei"/>
+                        </a:rPr>
+                        <a:t>最后 5 次均值</a:t>
+                      </a:r>
+                    </a:p>
+                  </a:txBody>
+                  <a:tcPr marL="73152" marR="54864" marT="27432" marB="27432" anchor="ctr">
+                    <a:lnB w="9525" cap="flat" cmpd="sng" algn="ctr">
+                      <a:solidFill>
+                        <a:srgbClr val="E2E7EE"/>
+                      </a:solidFill>
+                    </a:lnB>
+                    <a:solidFill>
+                      <a:srgbClr val="0F1B2D"/>
+                    </a:solidFill>
+                  </a:tcPr>
+                </a:tc>
+                <a:tc>
+                  <a:txBody>
+                    <a:bodyPr wrap="square"/>
+                    <a:lstStyle/>
+                    <a:p>
+                      <a:pPr algn="ctr">
+                        <a:lnSpc>
+                          <a:spcPct val="100000"/>
+                        </a:lnSpc>
+                      </a:pPr>
+                      <a:r>
+                        <a:rPr sz="800" b="1" i="0">
+                          <a:solidFill>
+                            <a:srgbClr val="FFFFFF"/>
+                          </a:solidFill>
+                          <a:latin typeface="Microsoft YaHei"/>
+                          <a:ea typeface="Microsoft YaHei"/>
+                          <a:cs typeface="Microsoft YaHei"/>
+                        </a:rPr>
+                        <a:t>耗时 / 评估协议</a:t>
+                      </a:r>
+                    </a:p>
+                  </a:txBody>
+                  <a:tcPr marL="73152" marR="54864" marT="27432" marB="27432" anchor="ctr">
+                    <a:lnB w="9525" cap="flat" cmpd="sng" algn="ctr">
+                      <a:solidFill>
+                        <a:srgbClr val="E2E7EE"/>
+                      </a:solidFill>
+                    </a:lnB>
+                    <a:solidFill>
+                      <a:srgbClr val="0F1B2D"/>
+                    </a:solidFill>
+                  </a:tcPr>
+                </a:tc>
+              </a:tr>
+              <a:tr h="274320">
+                <a:tc>
+                  <a:txBody>
+                    <a:bodyPr wrap="square"/>
+                    <a:lstStyle/>
+                    <a:p>
+                      <a:pPr algn="l">
+                        <a:lnSpc>
+                          <a:spcPct val="100000"/>
+                        </a:lnSpc>
+                      </a:pPr>
+                      <a:r>
+                        <a:rPr sz="819" b="1" i="0">
+                          <a:solidFill>
+                            <a:srgbClr val="0F1B2D"/>
+                          </a:solidFill>
+                          <a:latin typeface="Microsoft YaHei"/>
+                          <a:ea typeface="Microsoft YaHei"/>
+                          <a:cs typeface="Microsoft YaHei"/>
+                        </a:rPr>
+                        <a:t>antmaze-large</a:t>
+                      </a:r>
+                    </a:p>
+                  </a:txBody>
+                  <a:tcPr marL="73152" marR="54864" marT="27432" marB="27432" anchor="ctr">
+                    <a:lnB w="9525" cap="flat" cmpd="sng" algn="ctr">
+                      <a:solidFill>
+                        <a:srgbClr val="E2E7EE"/>
+                      </a:solidFill>
+                    </a:lnB>
+                    <a:solidFill>
+                      <a:srgbClr val="FFFFFF"/>
+                    </a:solidFill>
+                  </a:tcPr>
+                </a:tc>
+                <a:tc>
+                  <a:txBody>
+                    <a:bodyPr wrap="square"/>
+                    <a:lstStyle/>
+                    <a:p>
+                      <a:pPr algn="l">
+                        <a:lnSpc>
+                          <a:spcPct val="100000"/>
+                        </a:lnSpc>
+                      </a:pPr>
+                      <a:r>
+                        <a:rPr sz="819" b="0" i="0">
+                          <a:solidFill>
+                            <a:srgbClr val="1B263B"/>
+                          </a:solidFill>
+                          <a:latin typeface="Microsoft YaHei"/>
+                          <a:ea typeface="Microsoft YaHei"/>
+                          <a:cs typeface="Microsoft YaHei"/>
+                        </a:rPr>
+                        <a:t>FINO</a:t>
+                      </a:r>
+                    </a:p>
+                  </a:txBody>
+                  <a:tcPr marL="73152" marR="54864" marT="27432" marB="27432" anchor="ctr">
+                    <a:lnB w="9525" cap="flat" cmpd="sng" algn="ctr">
+                      <a:solidFill>
+                        <a:srgbClr val="E2E7EE"/>
+                      </a:solidFill>
+                    </a:lnB>
+                    <a:solidFill>
+                      <a:srgbClr val="FFFFFF"/>
+                    </a:solidFill>
+                  </a:tcPr>
+                </a:tc>
+                <a:tc>
+                  <a:txBody>
+                    <a:bodyPr wrap="square"/>
+                    <a:lstStyle/>
+                    <a:p>
+                      <a:pPr algn="l">
+                        <a:lnSpc>
+                          <a:spcPct val="100000"/>
+                        </a:lnSpc>
+                      </a:pPr>
+                      <a:r>
+                        <a:rPr sz="819" b="0" i="0">
+                          <a:solidFill>
+                            <a:srgbClr val="1B263B"/>
+                          </a:solidFill>
+                          <a:latin typeface="Microsoft YaHei"/>
+                          <a:ea typeface="Microsoft YaHei"/>
+                          <a:cs typeface="Microsoft YaHei"/>
+                        </a:rPr>
+                        <a:t>1.00</a:t>
+                      </a:r>
+                    </a:p>
+                  </a:txBody>
+                  <a:tcPr marL="73152" marR="54864" marT="27432" marB="27432" anchor="ctr">
+                    <a:lnB w="9525" cap="flat" cmpd="sng" algn="ctr">
+                      <a:solidFill>
+                        <a:srgbClr val="E2E7EE"/>
+                      </a:solidFill>
+                    </a:lnB>
+                    <a:solidFill>
+                      <a:srgbClr val="FFFFFF"/>
+                    </a:solidFill>
+                  </a:tcPr>
+                </a:tc>
+                <a:tc>
+                  <a:txBody>
+                    <a:bodyPr wrap="square"/>
+                    <a:lstStyle/>
+                    <a:p>
+                      <a:pPr algn="l">
+                        <a:lnSpc>
+                          <a:spcPct val="100000"/>
+                        </a:lnSpc>
+                      </a:pPr>
+                      <a:r>
+                        <a:rPr sz="819" b="0" i="0">
+                          <a:solidFill>
+                            <a:srgbClr val="1B263B"/>
+                          </a:solidFill>
+                          <a:latin typeface="Microsoft YaHei"/>
+                          <a:ea typeface="Microsoft YaHei"/>
+                          <a:cs typeface="Microsoft YaHei"/>
+                        </a:rPr>
+                        <a:t>1.00</a:t>
+                      </a:r>
+                    </a:p>
+                  </a:txBody>
+                  <a:tcPr marL="73152" marR="54864" marT="27432" marB="27432" anchor="ctr">
+                    <a:lnB w="9525" cap="flat" cmpd="sng" algn="ctr">
+                      <a:solidFill>
+                        <a:srgbClr val="E2E7EE"/>
+                      </a:solidFill>
+                    </a:lnB>
+                    <a:solidFill>
+                      <a:srgbClr val="FFFFFF"/>
+                    </a:solidFill>
+                  </a:tcPr>
+                </a:tc>
+                <a:tc>
+                  <a:txBody>
+                    <a:bodyPr wrap="square"/>
+                    <a:lstStyle/>
+                    <a:p>
+                      <a:pPr algn="l">
+                        <a:lnSpc>
+                          <a:spcPct val="100000"/>
+                        </a:lnSpc>
+                      </a:pPr>
+                      <a:r>
+                        <a:rPr sz="819" b="0" i="0">
+                          <a:solidFill>
+                            <a:srgbClr val="1B263B"/>
+                          </a:solidFill>
+                          <a:latin typeface="Microsoft YaHei"/>
+                          <a:ea typeface="Microsoft YaHei"/>
+                          <a:cs typeface="Microsoft YaHei"/>
+                        </a:rPr>
+                        <a:t>0.98</a:t>
+                      </a:r>
+                    </a:p>
+                  </a:txBody>
+                  <a:tcPr marL="73152" marR="54864" marT="27432" marB="27432" anchor="ctr">
+                    <a:lnB w="9525" cap="flat" cmpd="sng" algn="ctr">
+                      <a:solidFill>
+                        <a:srgbClr val="E2E7EE"/>
+                      </a:solidFill>
+                    </a:lnB>
+                    <a:solidFill>
+                      <a:srgbClr val="FFFFFF"/>
+                    </a:solidFill>
+                  </a:tcPr>
+                </a:tc>
+                <a:tc>
+                  <a:txBody>
+                    <a:bodyPr wrap="square"/>
+                    <a:lstStyle/>
+                    <a:p>
+                      <a:pPr algn="l">
+                        <a:lnSpc>
+                          <a:spcPct val="100000"/>
+                        </a:lnSpc>
+                      </a:pPr>
+                      <a:r>
+                        <a:rPr sz="819" b="0" i="0">
+                          <a:solidFill>
+                            <a:srgbClr val="1B263B"/>
+                          </a:solidFill>
+                          <a:latin typeface="Microsoft YaHei"/>
+                          <a:ea typeface="Microsoft YaHei"/>
+                          <a:cs typeface="Microsoft YaHei"/>
+                        </a:rPr>
+                        <a:t>150.3 min / 31×50 eps</a:t>
+                      </a:r>
+                    </a:p>
+                  </a:txBody>
+                  <a:tcPr marL="73152" marR="54864" marT="27432" marB="27432" anchor="ctr">
+                    <a:lnB w="9525" cap="flat" cmpd="sng" algn="ctr">
+                      <a:solidFill>
+                        <a:srgbClr val="E2E7EE"/>
+                      </a:solidFill>
+                    </a:lnB>
+                    <a:solidFill>
+                      <a:srgbClr val="FFFFFF"/>
+                    </a:solidFill>
+                  </a:tcPr>
+                </a:tc>
+              </a:tr>
+              <a:tr h="402945">
+                <a:tc>
+                  <a:txBody>
+                    <a:bodyPr wrap="square"/>
+                    <a:lstStyle/>
+                    <a:p>
+                      <a:pPr algn="l">
+                        <a:lnSpc>
+                          <a:spcPct val="100000"/>
+                        </a:lnSpc>
+                      </a:pPr>
+                      <a:r>
+                        <a:rPr sz="819" b="1" i="0">
+                          <a:solidFill>
+                            <a:srgbClr val="0F1B2D"/>
+                          </a:solidFill>
+                          <a:latin typeface="Microsoft YaHei"/>
+                          <a:ea typeface="Microsoft YaHei"/>
+                          <a:cs typeface="Microsoft YaHei"/>
+                        </a:rPr>
+                        <a:t>humanoidmaze-medium</a:t>
+                      </a:r>
+                    </a:p>
+                  </a:txBody>
+                  <a:tcPr marL="73152" marR="54864" marT="27432" marB="27432" anchor="ctr">
+                    <a:lnB w="9525" cap="flat" cmpd="sng" algn="ctr">
+                      <a:solidFill>
+                        <a:srgbClr val="E2E7EE"/>
+                      </a:solidFill>
+                    </a:lnB>
+                    <a:solidFill>
+                      <a:srgbClr val="F5F7FB"/>
+                    </a:solidFill>
+                  </a:tcPr>
+                </a:tc>
+                <a:tc>
+                  <a:txBody>
+                    <a:bodyPr wrap="square"/>
+                    <a:lstStyle/>
+                    <a:p>
+                      <a:pPr algn="l">
+                        <a:lnSpc>
+                          <a:spcPct val="100000"/>
+                        </a:lnSpc>
+                      </a:pPr>
+                      <a:r>
+                        <a:rPr sz="819" b="0" i="0">
+                          <a:solidFill>
+                            <a:srgbClr val="1B263B"/>
+                          </a:solidFill>
+                          <a:latin typeface="Microsoft YaHei"/>
+                          <a:ea typeface="Microsoft YaHei"/>
+                          <a:cs typeface="Microsoft YaHei"/>
+                        </a:rPr>
+                        <a:t>FINO</a:t>
+                      </a:r>
+                    </a:p>
+                  </a:txBody>
+                  <a:tcPr marL="73152" marR="54864" marT="27432" marB="27432" anchor="ctr">
+                    <a:lnB w="9525" cap="flat" cmpd="sng" algn="ctr">
+                      <a:solidFill>
+                        <a:srgbClr val="E2E7EE"/>
+                      </a:solidFill>
+                    </a:lnB>
+                    <a:solidFill>
+                      <a:srgbClr val="F5F7FB"/>
+                    </a:solidFill>
+                  </a:tcPr>
+                </a:tc>
+                <a:tc>
+                  <a:txBody>
+                    <a:bodyPr wrap="square"/>
+                    <a:lstStyle/>
+                    <a:p>
+                      <a:pPr algn="l">
+                        <a:lnSpc>
+                          <a:spcPct val="100000"/>
+                        </a:lnSpc>
+                      </a:pPr>
+                      <a:r>
+                        <a:rPr sz="819" b="0" i="0">
+                          <a:solidFill>
+                            <a:srgbClr val="1B263B"/>
+                          </a:solidFill>
+                          <a:latin typeface="Microsoft YaHei"/>
+                          <a:ea typeface="Microsoft YaHei"/>
+                          <a:cs typeface="Microsoft YaHei"/>
+                        </a:rPr>
+                        <a:t>1.00</a:t>
+                      </a:r>
+                    </a:p>
+                  </a:txBody>
+                  <a:tcPr marL="73152" marR="54864" marT="27432" marB="27432" anchor="ctr">
+                    <a:lnB w="9525" cap="flat" cmpd="sng" algn="ctr">
+                      <a:solidFill>
+                        <a:srgbClr val="E2E7EE"/>
+                      </a:solidFill>
+                    </a:lnB>
+                    <a:solidFill>
+                      <a:srgbClr val="F5F7FB"/>
+                    </a:solidFill>
+                  </a:tcPr>
+                </a:tc>
+                <a:tc>
+                  <a:txBody>
+                    <a:bodyPr wrap="square"/>
+                    <a:lstStyle/>
+                    <a:p>
+                      <a:pPr algn="l">
+                        <a:lnSpc>
+                          <a:spcPct val="100000"/>
+                        </a:lnSpc>
+                      </a:pPr>
+                      <a:r>
+                        <a:rPr sz="819" b="0" i="0">
+                          <a:solidFill>
+                            <a:srgbClr val="1B263B"/>
+                          </a:solidFill>
+                          <a:latin typeface="Microsoft YaHei"/>
+                          <a:ea typeface="Microsoft YaHei"/>
+                          <a:cs typeface="Microsoft YaHei"/>
+                        </a:rPr>
+                        <a:t>1.00</a:t>
+                      </a:r>
+                    </a:p>
+                  </a:txBody>
+                  <a:tcPr marL="73152" marR="54864" marT="27432" marB="27432" anchor="ctr">
+                    <a:lnB w="9525" cap="flat" cmpd="sng" algn="ctr">
+                      <a:solidFill>
+                        <a:srgbClr val="E2E7EE"/>
+                      </a:solidFill>
+                    </a:lnB>
+                    <a:solidFill>
+                      <a:srgbClr val="F5F7FB"/>
+                    </a:solidFill>
+                  </a:tcPr>
+                </a:tc>
+                <a:tc>
+                  <a:txBody>
+                    <a:bodyPr wrap="square"/>
+                    <a:lstStyle/>
+                    <a:p>
+                      <a:pPr algn="l">
+                        <a:lnSpc>
+                          <a:spcPct val="100000"/>
+                        </a:lnSpc>
+                      </a:pPr>
+                      <a:r>
+                        <a:rPr sz="819" b="0" i="0">
+                          <a:solidFill>
+                            <a:srgbClr val="1B263B"/>
+                          </a:solidFill>
+                          <a:latin typeface="Microsoft YaHei"/>
+                          <a:ea typeface="Microsoft YaHei"/>
+                          <a:cs typeface="Microsoft YaHei"/>
+                        </a:rPr>
+                        <a:t>0.96</a:t>
+                      </a:r>
+                    </a:p>
+                  </a:txBody>
+                  <a:tcPr marL="73152" marR="54864" marT="27432" marB="27432" anchor="ctr">
+                    <a:lnB w="9525" cap="flat" cmpd="sng" algn="ctr">
+                      <a:solidFill>
+                        <a:srgbClr val="E2E7EE"/>
+                      </a:solidFill>
+                    </a:lnB>
+                    <a:solidFill>
+                      <a:srgbClr val="F5F7FB"/>
+                    </a:solidFill>
+                  </a:tcPr>
+                </a:tc>
+                <a:tc>
+                  <a:txBody>
+                    <a:bodyPr wrap="square"/>
+                    <a:lstStyle/>
+                    <a:p>
+                      <a:pPr algn="l">
+                        <a:lnSpc>
+                          <a:spcPct val="100000"/>
+                        </a:lnSpc>
+                      </a:pPr>
+                      <a:r>
+                        <a:rPr sz="819" b="0" i="0">
+                          <a:solidFill>
+                            <a:srgbClr val="1B263B"/>
+                          </a:solidFill>
+                          <a:latin typeface="Microsoft YaHei"/>
+                          <a:ea typeface="Microsoft YaHei"/>
+                          <a:cs typeface="Microsoft YaHei"/>
+                        </a:rPr>
+                        <a:t>127.4 min / 16×20 eps*</a:t>
+                      </a:r>
+                    </a:p>
+                  </a:txBody>
+                  <a:tcPr marL="73152" marR="54864" marT="27432" marB="27432" anchor="ctr">
+                    <a:lnB w="9525" cap="flat" cmpd="sng" algn="ctr">
+                      <a:solidFill>
+                        <a:srgbClr val="E2E7EE"/>
+                      </a:solidFill>
+                    </a:lnB>
+                    <a:solidFill>
+                      <a:srgbClr val="F5F7FB"/>
+                    </a:solidFill>
+                  </a:tcPr>
+                </a:tc>
+              </a:tr>
+              <a:tr h="274320">
+                <a:tc>
+                  <a:txBody>
+                    <a:bodyPr wrap="square"/>
+                    <a:lstStyle/>
+                    <a:p>
+                      <a:pPr algn="l">
+                        <a:lnSpc>
+                          <a:spcPct val="100000"/>
+                        </a:lnSpc>
+                      </a:pPr>
+                      <a:r>
+                        <a:rPr sz="819" b="1" i="0">
+                          <a:solidFill>
+                            <a:srgbClr val="0F1B2D"/>
+                          </a:solidFill>
+                          <a:latin typeface="Microsoft YaHei"/>
+                          <a:ea typeface="Microsoft YaHei"/>
+                          <a:cs typeface="Microsoft YaHei"/>
+                        </a:rPr>
+                        <a:t>cube-double-play</a:t>
+                      </a:r>
+                    </a:p>
+                  </a:txBody>
+                  <a:tcPr marL="73152" marR="54864" marT="27432" marB="27432" anchor="ctr">
+                    <a:lnB w="9525" cap="flat" cmpd="sng" algn="ctr">
+                      <a:solidFill>
+                        <a:srgbClr val="E2E7EE"/>
+                      </a:solidFill>
+                    </a:lnB>
+                    <a:solidFill>
+                      <a:srgbClr val="FFFFFF"/>
+                    </a:solidFill>
+                  </a:tcPr>
+                </a:tc>
+                <a:tc>
+                  <a:txBody>
+                    <a:bodyPr wrap="square"/>
+                    <a:lstStyle/>
+                    <a:p>
+                      <a:pPr algn="l">
+                        <a:lnSpc>
+                          <a:spcPct val="100000"/>
+                        </a:lnSpc>
+                      </a:pPr>
+                      <a:r>
+                        <a:rPr sz="819" b="0" i="0">
+                          <a:solidFill>
+                            <a:srgbClr val="1B263B"/>
+                          </a:solidFill>
+                          <a:latin typeface="Microsoft YaHei"/>
+                          <a:ea typeface="Microsoft YaHei"/>
+                          <a:cs typeface="Microsoft YaHei"/>
+                        </a:rPr>
+                        <a:t>FINO</a:t>
+                      </a:r>
+                    </a:p>
+                  </a:txBody>
+                  <a:tcPr marL="73152" marR="54864" marT="27432" marB="27432" anchor="ctr">
+                    <a:lnB w="9525" cap="flat" cmpd="sng" algn="ctr">
+                      <a:solidFill>
+                        <a:srgbClr val="E2E7EE"/>
+                      </a:solidFill>
+                    </a:lnB>
+                    <a:solidFill>
+                      <a:srgbClr val="FFFFFF"/>
+                    </a:solidFill>
+                  </a:tcPr>
+                </a:tc>
+                <a:tc>
+                  <a:txBody>
+                    <a:bodyPr wrap="square"/>
+                    <a:lstStyle/>
+                    <a:p>
+                      <a:pPr algn="l">
+                        <a:lnSpc>
+                          <a:spcPct val="100000"/>
+                        </a:lnSpc>
+                      </a:pPr>
+                      <a:r>
+                        <a:rPr sz="819" b="0" i="0">
+                          <a:solidFill>
+                            <a:srgbClr val="1B263B"/>
+                          </a:solidFill>
+                          <a:latin typeface="Microsoft YaHei"/>
+                          <a:ea typeface="Microsoft YaHei"/>
+                          <a:cs typeface="Microsoft YaHei"/>
+                        </a:rPr>
+                        <a:t>0.72</a:t>
+                      </a:r>
+                    </a:p>
+                  </a:txBody>
+                  <a:tcPr marL="73152" marR="54864" marT="27432" marB="27432" anchor="ctr">
+                    <a:lnB w="9525" cap="flat" cmpd="sng" algn="ctr">
+                      <a:solidFill>
+                        <a:srgbClr val="E2E7EE"/>
+                      </a:solidFill>
+                    </a:lnB>
+                    <a:solidFill>
+                      <a:srgbClr val="FFFFFF"/>
+                    </a:solidFill>
+                  </a:tcPr>
+                </a:tc>
+                <a:tc>
+                  <a:txBody>
+                    <a:bodyPr wrap="square"/>
+                    <a:lstStyle/>
+                    <a:p>
+                      <a:pPr algn="l">
+                        <a:lnSpc>
+                          <a:spcPct val="100000"/>
+                        </a:lnSpc>
+                      </a:pPr>
+                      <a:r>
+                        <a:rPr sz="819" b="0" i="0">
+                          <a:solidFill>
+                            <a:srgbClr val="1B263B"/>
+                          </a:solidFill>
+                          <a:latin typeface="Microsoft YaHei"/>
+                          <a:ea typeface="Microsoft YaHei"/>
+                          <a:cs typeface="Microsoft YaHei"/>
+                        </a:rPr>
+                        <a:t>0.92</a:t>
+                      </a:r>
+                    </a:p>
+                  </a:txBody>
+                  <a:tcPr marL="73152" marR="54864" marT="27432" marB="27432" anchor="ctr">
+                    <a:lnB w="9525" cap="flat" cmpd="sng" algn="ctr">
+                      <a:solidFill>
+                        <a:srgbClr val="E2E7EE"/>
+                      </a:solidFill>
+                    </a:lnB>
+                    <a:solidFill>
+                      <a:srgbClr val="FFFFFF"/>
+                    </a:solidFill>
+                  </a:tcPr>
+                </a:tc>
+                <a:tc>
+                  <a:txBody>
+                    <a:bodyPr wrap="square"/>
+                    <a:lstStyle/>
+                    <a:p>
+                      <a:pPr algn="l">
+                        <a:lnSpc>
+                          <a:spcPct val="100000"/>
+                        </a:lnSpc>
+                      </a:pPr>
+                      <a:r>
+                        <a:rPr sz="819" b="0" i="0">
+                          <a:solidFill>
+                            <a:srgbClr val="1B263B"/>
+                          </a:solidFill>
+                          <a:latin typeface="Microsoft YaHei"/>
+                          <a:ea typeface="Microsoft YaHei"/>
+                          <a:cs typeface="Microsoft YaHei"/>
+                        </a:rPr>
+                        <a:t>0.84</a:t>
+                      </a:r>
+                    </a:p>
+                  </a:txBody>
+                  <a:tcPr marL="73152" marR="54864" marT="27432" marB="27432" anchor="ctr">
+                    <a:lnB w="9525" cap="flat" cmpd="sng" algn="ctr">
+                      <a:solidFill>
+                        <a:srgbClr val="E2E7EE"/>
+                      </a:solidFill>
+                    </a:lnB>
+                    <a:solidFill>
+                      <a:srgbClr val="FFFFFF"/>
+                    </a:solidFill>
+                  </a:tcPr>
+                </a:tc>
+                <a:tc>
+                  <a:txBody>
+                    <a:bodyPr wrap="square"/>
+                    <a:lstStyle/>
+                    <a:p>
+                      <a:pPr algn="l">
+                        <a:lnSpc>
+                          <a:spcPct val="100000"/>
+                        </a:lnSpc>
+                      </a:pPr>
+                      <a:r>
+                        <a:rPr sz="819" b="0" i="0">
+                          <a:solidFill>
+                            <a:srgbClr val="1B263B"/>
+                          </a:solidFill>
+                          <a:latin typeface="Microsoft YaHei"/>
+                          <a:ea typeface="Microsoft YaHei"/>
+                          <a:cs typeface="Microsoft YaHei"/>
+                        </a:rPr>
+                        <a:t>144.2 min / 31×50 eps</a:t>
+                      </a:r>
+                    </a:p>
+                  </a:txBody>
+                  <a:tcPr marL="73152" marR="54864" marT="27432" marB="27432" anchor="ctr">
+                    <a:lnB w="9525" cap="flat" cmpd="sng" algn="ctr">
+                      <a:solidFill>
+                        <a:srgbClr val="E2E7EE"/>
+                      </a:solidFill>
+                    </a:lnB>
+                    <a:solidFill>
+                      <a:srgbClr val="FFFFFF"/>
+                    </a:solidFill>
+                  </a:tcPr>
+                </a:tc>
+              </a:tr>
+            </a:tbl>
+          </a:graphicData>
+        </a:graphic>
+      </p:graphicFrame>
+      <p:sp>
+        <p:nvSpPr>
+          <p:cNvPr id="16" name="TextBox 15"/>
+          <p:cNvSpPr txBox="1"/>
+          <p:nvPr/>
+        </p:nvSpPr>
+        <p:spPr>
+          <a:xfrm>
+            <a:off x="868680" y="5650992"/>
+            <a:ext cx="10424160" cy="411480"/>
+          </a:xfrm>
+          <a:prstGeom prst="rect">
+            <a:avLst/>
+          </a:prstGeom>
+          <a:noFill/>
+        </p:spPr>
+        <p:txBody>
+          <a:bodyPr wrap="square" lIns="0" rIns="0" tIns="0" bIns="0" anchor="t">
+            <a:spAutoFit/>
+          </a:bodyPr>
+          <a:lstStyle/>
+          <a:p>
+            <a:pPr algn="l">
+              <a:lnSpc>
+                <a:spcPct val="108000"/>
+              </a:lnSpc>
+            </a:pPr>
+            <a:r>
+              <a:rPr sz="760" b="0" i="0">
+                <a:solidFill>
+                  <a:srgbClr val="556176"/>
+                </a:solidFill>
+                <a:latin typeface="Microsoft YaHei"/>
+                <a:ea typeface="Microsoft YaHei"/>
+                <a:cs typeface="Microsoft YaHei"/>
+              </a:rPr>
+              <a:t>* humanoidmaze-medium 采用每 100k 步 × 20 episodes；其余按论文协议（50k × 50）。FQL 参考：antmaze-large 92%（峰值 98%）。全部 seed=0。</a:t>
+            </a:r>
+          </a:p>
+        </p:txBody>
+      </p:sp>
+      <p:sp>
+        <p:nvSpPr>
+          <p:cNvPr id="17" name="Rectangle 16"/>
+          <p:cNvSpPr/>
+          <p:nvPr/>
+        </p:nvSpPr>
+        <p:spPr>
+          <a:xfrm>
+            <a:off x="640080" y="6391656"/>
+            <a:ext cx="10911535" cy="9144"/>
+          </a:xfrm>
+          <a:prstGeom prst="rect">
+            <a:avLst/>
+          </a:prstGeom>
+          <a:solidFill>
+            <a:srgbClr val="E7EBF2"/>
+          </a:solidFill>
+          <a:ln>
+            <a:noFill/>
+          </a:ln>
+          <a:effectLst/>
+        </p:spPr>
+        <p:style>
+          <a:lnRef idx="1">
+            <a:schemeClr val="accent1"/>
+          </a:lnRef>
+          <a:fillRef idx="3">
+            <a:schemeClr val="accent1"/>
+          </a:fillRef>
+          <a:effectRef idx="2">
+            <a:schemeClr val="accent1"/>
+          </a:effectRef>
+          <a:fontRef idx="minor">
+            <a:schemeClr val="lt1"/>
+          </a:fontRef>
+        </p:style>
+        <p:txBody>
+          <a:bodyPr rtlCol="0" anchor="ctr"/>
+          <a:lstStyle/>
+          <a:p>
+            <a:pPr algn="ctr"/>
+          </a:p>
+        </p:txBody>
+      </p:sp>
+      <p:sp>
+        <p:nvSpPr>
+          <p:cNvPr id="18" name="TextBox 17"/>
+          <p:cNvSpPr txBox="1"/>
+          <p:nvPr/>
+        </p:nvSpPr>
+        <p:spPr>
+          <a:xfrm>
+            <a:off x="640080" y="6455664"/>
+            <a:ext cx="7772400" cy="219456"/>
+          </a:xfrm>
+          <a:prstGeom prst="rect">
+            <a:avLst/>
+          </a:prstGeom>
+          <a:noFill/>
+        </p:spPr>
+        <p:txBody>
+          <a:bodyPr wrap="square" lIns="0" rIns="0" tIns="0" bIns="0" anchor="t">
+            <a:spAutoFit/>
+          </a:bodyPr>
+          <a:lstStyle/>
+          <a:p>
+            <a:pPr algn="l">
+              <a:lnSpc>
+                <a:spcPct val="108000"/>
+              </a:lnSpc>
+            </a:pPr>
+            <a:r>
+              <a:rPr sz="850" b="0" i="0">
+                <a:solidFill>
+                  <a:srgbClr val="7F8CA3"/>
+                </a:solidFill>
+                <a:latin typeface="Microsoft YaHei"/>
+                <a:ea typeface="Microsoft YaHei"/>
+                <a:cs typeface="Microsoft YaHei"/>
+              </a:rPr>
+              <a:t>FINO 复现项目 · ICLR 2026 · engulf408/FINO</a:t>
+            </a:r>
+          </a:p>
+        </p:txBody>
+      </p:sp>
+      <p:sp>
+        <p:nvSpPr>
+          <p:cNvPr id="19" name="TextBox 18"/>
+          <p:cNvSpPr txBox="1"/>
+          <p:nvPr/>
+        </p:nvSpPr>
+        <p:spPr>
+          <a:xfrm>
+            <a:off x="11048695" y="6455664"/>
+            <a:ext cx="502920" cy="219456"/>
+          </a:xfrm>
+          <a:prstGeom prst="rect">
+            <a:avLst/>
+          </a:prstGeom>
+          <a:noFill/>
+        </p:spPr>
+        <p:txBody>
+          <a:bodyPr wrap="square" lIns="0" rIns="0" tIns="0" bIns="0" anchor="t">
+            <a:spAutoFit/>
+          </a:bodyPr>
+          <a:lstStyle/>
+          <a:p>
+            <a:pPr algn="r">
+              <a:lnSpc>
+                <a:spcPct val="108000"/>
+              </a:lnSpc>
+            </a:pPr>
+            <a:r>
+              <a:rPr sz="900" b="1" i="0">
+                <a:solidFill>
+                  <a:srgbClr val="7F8CA3"/>
+                </a:solidFill>
+                <a:latin typeface="Microsoft YaHei"/>
+                <a:ea typeface="Microsoft YaHei"/>
+                <a:cs typeface="Microsoft YaHei"/>
+              </a:rPr>
+              <a:t>20</a:t>
+            </a:r>
+          </a:p>
+        </p:txBody>
+      </p:sp>
+    </p:spTree>
+  </p:cSld>
+  <p:clrMapOvr>
+    <a:masterClrMapping/>
+  </p:clrMapOvr>
+</p:sld>
+</file>
+
+<file path=ppt/slides/slide21.xml><?xml version="1.0" encoding="utf-8"?>
 <p:sld xmlns:a="http://schemas.openxmlformats.org/drawingml/2006/main" xmlns:p="http://schemas.openxmlformats.org/presentationml/2006/main" xmlns:r="http://schemas.openxmlformats.org/officeDocument/2006/relationships">
   <p:cSld>
     <p:spTree>

</xml_diff>